<commit_message>
slides: 本人の編集版を更新 (10-02 04:08)
</commit_message>
<xml_diff>
--- a/slides/2026-10-02_研究進捗報告.pptx
+++ b/slides/2026-10-02_研究進捗報告.pptx
@@ -4,42 +4,45 @@
   <p:sldMasterIdLst>
     <p:sldMasterId id="2147483648" r:id="rId1"/>
   </p:sldMasterIdLst>
+  <p:notesMasterIdLst>
+    <p:notesMasterId r:id="rId37"/>
+  </p:notesMasterIdLst>
   <p:sldIdLst>
     <p:sldId id="256" r:id="rId2"/>
-    <p:sldId id="257" r:id="rId5"/>
-    <p:sldId id="258" r:id="rId3"/>
-    <p:sldId id="259" r:id="rId10"/>
-    <p:sldId id="260" r:id="rId11"/>
-    <p:sldId id="261" r:id="rId12"/>
-    <p:sldId id="262" r:id="rId13"/>
-    <p:sldId id="263" r:id="rId14"/>
-    <p:sldId id="264" r:id="rId15"/>
-    <p:sldId id="265" r:id="rId16"/>
-    <p:sldId id="266" r:id="rId17"/>
-    <p:sldId id="267" r:id="rId18"/>
-    <p:sldId id="268" r:id="rId19"/>
-    <p:sldId id="269" r:id="rId20"/>
-    <p:sldId id="270" r:id="rId21"/>
-    <p:sldId id="271" r:id="rId22"/>
-    <p:sldId id="272" r:id="rId23"/>
-    <p:sldId id="273" r:id="rId24"/>
-    <p:sldId id="274" r:id="rId25"/>
-    <p:sldId id="275" r:id="rId26"/>
-    <p:sldId id="276" r:id="rId27"/>
-    <p:sldId id="277" r:id="rId28"/>
-    <p:sldId id="278" r:id="rId29"/>
-    <p:sldId id="279" r:id="rId30"/>
-    <p:sldId id="280" r:id="rId31"/>
-    <p:sldId id="281" r:id="rId32"/>
-    <p:sldId id="282" r:id="rId33"/>
-    <p:sldId id="283" r:id="rId34"/>
-    <p:sldId id="284" r:id="rId35"/>
-    <p:sldId id="285" r:id="rId36"/>
-    <p:sldId id="286" r:id="rId37"/>
-    <p:sldId id="287" r:id="rId38"/>
-    <p:sldId id="288" r:id="rId39"/>
-    <p:sldId id="289" r:id="rId40"/>
-    <p:sldId id="290" r:id="rId41"/>
+    <p:sldId id="257" r:id="rId3"/>
+    <p:sldId id="258" r:id="rId4"/>
+    <p:sldId id="259" r:id="rId5"/>
+    <p:sldId id="260" r:id="rId6"/>
+    <p:sldId id="261" r:id="rId7"/>
+    <p:sldId id="262" r:id="rId8"/>
+    <p:sldId id="263" r:id="rId9"/>
+    <p:sldId id="264" r:id="rId10"/>
+    <p:sldId id="265" r:id="rId11"/>
+    <p:sldId id="266" r:id="rId12"/>
+    <p:sldId id="267" r:id="rId13"/>
+    <p:sldId id="268" r:id="rId14"/>
+    <p:sldId id="269" r:id="rId15"/>
+    <p:sldId id="270" r:id="rId16"/>
+    <p:sldId id="271" r:id="rId17"/>
+    <p:sldId id="272" r:id="rId18"/>
+    <p:sldId id="273" r:id="rId19"/>
+    <p:sldId id="274" r:id="rId20"/>
+    <p:sldId id="275" r:id="rId21"/>
+    <p:sldId id="276" r:id="rId22"/>
+    <p:sldId id="277" r:id="rId23"/>
+    <p:sldId id="278" r:id="rId24"/>
+    <p:sldId id="279" r:id="rId25"/>
+    <p:sldId id="280" r:id="rId26"/>
+    <p:sldId id="281" r:id="rId27"/>
+    <p:sldId id="282" r:id="rId28"/>
+    <p:sldId id="283" r:id="rId29"/>
+    <p:sldId id="284" r:id="rId30"/>
+    <p:sldId id="285" r:id="rId31"/>
+    <p:sldId id="286" r:id="rId32"/>
+    <p:sldId id="287" r:id="rId33"/>
+    <p:sldId id="288" r:id="rId34"/>
+    <p:sldId id="289" r:id="rId35"/>
+    <p:sldId id="290" r:id="rId36"/>
   </p:sldIdLst>
   <p:sldSz cx="12192000" cy="6858000"/>
   <p:notesSz cx="6858000" cy="9144000"/>
@@ -158,7 +161,7 @@
 </file>
 
 <file path=ppt/notesMasters/notesMaster1.xml><?xml version="1.0" encoding="utf-8"?>
-<p:notesMaster xmlns:a="http://schemas.openxmlformats.org/drawingml/2006/main" xmlns:p="http://schemas.openxmlformats.org/presentationml/2006/main" xmlns:r="http://schemas.openxmlformats.org/officeDocument/2006/relationships">
+<p:notesMaster xmlns:a="http://schemas.openxmlformats.org/drawingml/2006/main" xmlns:r="http://schemas.openxmlformats.org/officeDocument/2006/relationships" xmlns:p="http://schemas.openxmlformats.org/presentationml/2006/main">
   <p:cSld>
     <p:bg>
       <p:bgRef idx="1001">
@@ -192,7 +195,7 @@
         <p:spPr>
           <a:xfrm>
             <a:off x="0" y="0"/>
-            <a:ext cx="2971800" cy="457200"/>
+            <a:ext cx="2971800" cy="458788"/>
           </a:xfrm>
           <a:prstGeom prst="rect">
             <a:avLst/>
@@ -223,7 +226,7 @@
         <p:spPr>
           <a:xfrm>
             <a:off x="3884613" y="0"/>
-            <a:ext cx="2971800" cy="457200"/>
+            <a:ext cx="2971800" cy="458788"/>
           </a:xfrm>
           <a:prstGeom prst="rect">
             <a:avLst/>
@@ -237,9 +240,9 @@
             </a:lvl1pPr>
           </a:lstStyle>
           <a:p>
-            <a:fld id="{0F89C1C7-3DCD-1040-A9CF-14679D8B5DDD}" type="datetimeFigureOut">
+            <a:fld id="{B414FD46-9C41-4E77-8212-EE695A2FE528}" type="datetimeFigureOut">
               <a:rPr lang="en-US" smtClean="0"/>
-              <a:t>10/17/16</a:t>
+              <a:t>10/2/2026</a:t>
             </a:fld>
             <a:endParaRPr lang="en-US"/>
           </a:p>
@@ -257,8 +260,8 @@
         </p:nvSpPr>
         <p:spPr>
           <a:xfrm>
-            <a:off x="1143000" y="685800"/>
-            <a:ext cx="4572000" cy="3429000"/>
+            <a:off x="685800" y="1143000"/>
+            <a:ext cx="5486400" cy="3086100"/>
           </a:xfrm>
           <a:prstGeom prst="rect">
             <a:avLst/>
@@ -290,8 +293,8 @@
         </p:nvSpPr>
         <p:spPr>
           <a:xfrm>
-            <a:off x="685800" y="4343400"/>
-            <a:ext cx="5486400" cy="4114800"/>
+            <a:off x="685800" y="4400550"/>
+            <a:ext cx="5486400" cy="3600450"/>
           </a:xfrm>
           <a:prstGeom prst="rect">
             <a:avLst/>
@@ -303,38 +306,37 @@
           <a:p>
             <a:pPr lvl="0"/>
             <a:r>
-              <a:rPr lang="en-US" smtClean="0"/>
+              <a:rPr lang="en-US"/>
               <a:t>Click to edit Master text styles</a:t>
             </a:r>
           </a:p>
           <a:p>
             <a:pPr lvl="1"/>
             <a:r>
-              <a:rPr lang="en-US" smtClean="0"/>
+              <a:rPr lang="en-US"/>
               <a:t>Second level</a:t>
             </a:r>
           </a:p>
           <a:p>
             <a:pPr lvl="2"/>
             <a:r>
-              <a:rPr lang="en-US" smtClean="0"/>
+              <a:rPr lang="en-US"/>
               <a:t>Third level</a:t>
             </a:r>
           </a:p>
           <a:p>
             <a:pPr lvl="3"/>
             <a:r>
-              <a:rPr lang="en-US" smtClean="0"/>
+              <a:rPr lang="en-US"/>
               <a:t>Fourth level</a:t>
             </a:r>
           </a:p>
           <a:p>
             <a:pPr lvl="4"/>
             <a:r>
-              <a:rPr lang="en-US" smtClean="0"/>
+              <a:rPr lang="en-US"/>
               <a:t>Fifth level</a:t>
             </a:r>
-            <a:endParaRPr lang="en-US"/>
           </a:p>
         </p:txBody>
       </p:sp>
@@ -351,7 +353,7 @@
         <p:spPr>
           <a:xfrm>
             <a:off x="0" y="8685213"/>
-            <a:ext cx="2971800" cy="457200"/>
+            <a:ext cx="2971800" cy="458787"/>
           </a:xfrm>
           <a:prstGeom prst="rect">
             <a:avLst/>
@@ -382,7 +384,7 @@
         <p:spPr>
           <a:xfrm>
             <a:off x="3884613" y="8685213"/>
-            <a:ext cx="2971800" cy="457200"/>
+            <a:ext cx="2971800" cy="458787"/>
           </a:xfrm>
           <a:prstGeom prst="rect">
             <a:avLst/>
@@ -396,7 +398,7 @@
             </a:lvl1pPr>
           </a:lstStyle>
           <a:p>
-            <a:fld id="{BB5E49A5-4136-284D-997B-48E1D791AD67}" type="slidenum">
+            <a:fld id="{9917160C-44A9-423E-AA11-6BCE5A9F41C5}" type="slidenum">
               <a:rPr lang="en-US" smtClean="0"/>
               <a:t>‹#›</a:t>
             </a:fld>
@@ -407,13 +409,13 @@
     </p:spTree>
     <p:extLst>
       <p:ext uri="{BB962C8B-B14F-4D97-AF65-F5344CB8AC3E}">
-        <p14:creationId xmlns:p14="http://schemas.microsoft.com/office/powerpoint/2010/main" val="2623252185"/>
+        <p14:creationId xmlns:p14="http://schemas.microsoft.com/office/powerpoint/2010/main" val="3001696547"/>
       </p:ext>
     </p:extLst>
   </p:cSld>
   <p:clrMap bg1="lt1" tx1="dk1" bg2="lt2" tx2="dk2" accent1="accent1" accent2="accent2" accent3="accent3" accent4="accent4" accent5="accent5" accent6="accent6" hlink="hlink" folHlink="folHlink"/>
   <p:notesStyle>
-    <a:lvl1pPr marL="0" algn="l" defTabSz="457200" rtl="0" eaLnBrk="1" latinLnBrk="0" hangingPunct="1">
+    <a:lvl1pPr marL="0" algn="l" defTabSz="914400" rtl="0" eaLnBrk="1" latinLnBrk="0" hangingPunct="1">
       <a:defRPr sz="1200" kern="1200">
         <a:solidFill>
           <a:schemeClr val="tx1"/>
@@ -423,7 +425,7 @@
         <a:cs typeface="+mn-cs"/>
       </a:defRPr>
     </a:lvl1pPr>
-    <a:lvl2pPr marL="457200" algn="l" defTabSz="457200" rtl="0" eaLnBrk="1" latinLnBrk="0" hangingPunct="1">
+    <a:lvl2pPr marL="457200" algn="l" defTabSz="914400" rtl="0" eaLnBrk="1" latinLnBrk="0" hangingPunct="1">
       <a:defRPr sz="1200" kern="1200">
         <a:solidFill>
           <a:schemeClr val="tx1"/>
@@ -433,7 +435,7 @@
         <a:cs typeface="+mn-cs"/>
       </a:defRPr>
     </a:lvl2pPr>
-    <a:lvl3pPr marL="914400" algn="l" defTabSz="457200" rtl="0" eaLnBrk="1" latinLnBrk="0" hangingPunct="1">
+    <a:lvl3pPr marL="914400" algn="l" defTabSz="914400" rtl="0" eaLnBrk="1" latinLnBrk="0" hangingPunct="1">
       <a:defRPr sz="1200" kern="1200">
         <a:solidFill>
           <a:schemeClr val="tx1"/>
@@ -443,7 +445,7 @@
         <a:cs typeface="+mn-cs"/>
       </a:defRPr>
     </a:lvl3pPr>
-    <a:lvl4pPr marL="1371600" algn="l" defTabSz="457200" rtl="0" eaLnBrk="1" latinLnBrk="0" hangingPunct="1">
+    <a:lvl4pPr marL="1371600" algn="l" defTabSz="914400" rtl="0" eaLnBrk="1" latinLnBrk="0" hangingPunct="1">
       <a:defRPr sz="1200" kern="1200">
         <a:solidFill>
           <a:schemeClr val="tx1"/>
@@ -453,7 +455,7 @@
         <a:cs typeface="+mn-cs"/>
       </a:defRPr>
     </a:lvl4pPr>
-    <a:lvl5pPr marL="1828800" algn="l" defTabSz="457200" rtl="0" eaLnBrk="1" latinLnBrk="0" hangingPunct="1">
+    <a:lvl5pPr marL="1828800" algn="l" defTabSz="914400" rtl="0" eaLnBrk="1" latinLnBrk="0" hangingPunct="1">
       <a:defRPr sz="1200" kern="1200">
         <a:solidFill>
           <a:schemeClr val="tx1"/>
@@ -463,7 +465,7 @@
         <a:cs typeface="+mn-cs"/>
       </a:defRPr>
     </a:lvl5pPr>
-    <a:lvl6pPr marL="2286000" algn="l" defTabSz="457200" rtl="0" eaLnBrk="1" latinLnBrk="0" hangingPunct="1">
+    <a:lvl6pPr marL="2286000" algn="l" defTabSz="914400" rtl="0" eaLnBrk="1" latinLnBrk="0" hangingPunct="1">
       <a:defRPr sz="1200" kern="1200">
         <a:solidFill>
           <a:schemeClr val="tx1"/>
@@ -473,7 +475,7 @@
         <a:cs typeface="+mn-cs"/>
       </a:defRPr>
     </a:lvl6pPr>
-    <a:lvl7pPr marL="2743200" algn="l" defTabSz="457200" rtl="0" eaLnBrk="1" latinLnBrk="0" hangingPunct="1">
+    <a:lvl7pPr marL="2743200" algn="l" defTabSz="914400" rtl="0" eaLnBrk="1" latinLnBrk="0" hangingPunct="1">
       <a:defRPr sz="1200" kern="1200">
         <a:solidFill>
           <a:schemeClr val="tx1"/>
@@ -483,7 +485,7 @@
         <a:cs typeface="+mn-cs"/>
       </a:defRPr>
     </a:lvl7pPr>
-    <a:lvl8pPr marL="3200400" algn="l" defTabSz="457200" rtl="0" eaLnBrk="1" latinLnBrk="0" hangingPunct="1">
+    <a:lvl8pPr marL="3200400" algn="l" defTabSz="914400" rtl="0" eaLnBrk="1" latinLnBrk="0" hangingPunct="1">
       <a:defRPr sz="1200" kern="1200">
         <a:solidFill>
           <a:schemeClr val="tx1"/>
@@ -493,7 +495,7 @@
         <a:cs typeface="+mn-cs"/>
       </a:defRPr>
     </a:lvl8pPr>
-    <a:lvl9pPr marL="3657600" algn="l" defTabSz="457200" rtl="0" eaLnBrk="1" latinLnBrk="0" hangingPunct="1">
+    <a:lvl9pPr marL="3657600" algn="l" defTabSz="914400" rtl="0" eaLnBrk="1" latinLnBrk="0" hangingPunct="1">
       <a:defRPr sz="1200" kern="1200">
         <a:solidFill>
           <a:schemeClr val="tx1"/>
@@ -508,7 +510,7 @@
 </file>
 
 <file path=ppt/notesSlides/notesSlide1.xml><?xml version="1.0" encoding="utf-8"?>
-<p:notes xmlns:a="http://schemas.openxmlformats.org/drawingml/2006/main" xmlns:p="http://schemas.openxmlformats.org/presentationml/2006/main" xmlns:r="http://schemas.openxmlformats.org/officeDocument/2006/relationships">
+<p:notes xmlns:a="http://schemas.openxmlformats.org/drawingml/2006/main" xmlns:r="http://schemas.openxmlformats.org/officeDocument/2006/relationships" xmlns:p="http://schemas.openxmlformats.org/presentationml/2006/main">
   <p:cSld>
     <p:spTree>
       <p:nvGrpSpPr>
@@ -528,7 +530,7 @@
         <p:nvSpPr>
           <p:cNvPr id="2" name="Slide Image Placeholder 1"/>
           <p:cNvSpPr>
-            <a:spLocks noGrp="1"/>
+            <a:spLocks noGrp="1" noRot="1" noChangeAspect="1"/>
           </p:cNvSpPr>
           <p:nvPr>
             <p:ph type="sldImg" idx="2"/>
@@ -543,7 +545,7 @@
             <a:spLocks noGrp="1"/>
           </p:cNvSpPr>
           <p:nvPr>
-            <p:ph type="body" idx="3" sz="quarter"/>
+            <p:ph type="body" sz="quarter" idx="3"/>
           </p:nvPr>
         </p:nvSpPr>
         <p:spPr/>
@@ -574,7 +576,7 @@
             <a:spLocks noGrp="1"/>
           </p:cNvSpPr>
           <p:nvPr>
-            <p:ph type="sldNum" idx="5" sz="quarter"/>
+            <p:ph type="sldNum" sz="quarter" idx="5"/>
           </p:nvPr>
         </p:nvSpPr>
         <p:spPr/>
@@ -588,7 +590,7 @@
 </file>
 
 <file path=ppt/notesSlides/notesSlide10.xml><?xml version="1.0" encoding="utf-8"?>
-<p:notes xmlns:a="http://schemas.openxmlformats.org/drawingml/2006/main" xmlns:p="http://schemas.openxmlformats.org/presentationml/2006/main" xmlns:r="http://schemas.openxmlformats.org/officeDocument/2006/relationships">
+<p:notes xmlns:a="http://schemas.openxmlformats.org/drawingml/2006/main" xmlns:r="http://schemas.openxmlformats.org/officeDocument/2006/relationships" xmlns:p="http://schemas.openxmlformats.org/presentationml/2006/main">
   <p:cSld>
     <p:spTree>
       <p:nvGrpSpPr>
@@ -608,7 +610,7 @@
         <p:nvSpPr>
           <p:cNvPr id="2" name="Slide Image Placeholder 1"/>
           <p:cNvSpPr>
-            <a:spLocks noGrp="1"/>
+            <a:spLocks noGrp="1" noRot="1" noChangeAspect="1"/>
           </p:cNvSpPr>
           <p:nvPr>
             <p:ph type="sldImg" idx="2"/>
@@ -623,7 +625,7 @@
             <a:spLocks noGrp="1"/>
           </p:cNvSpPr>
           <p:nvPr>
-            <p:ph type="body" idx="3" sz="quarter"/>
+            <p:ph type="body" sz="quarter" idx="3"/>
           </p:nvPr>
         </p:nvSpPr>
         <p:spPr/>
@@ -664,7 +666,7 @@
             <a:spLocks noGrp="1"/>
           </p:cNvSpPr>
           <p:nvPr>
-            <p:ph type="sldNum" idx="5" sz="quarter"/>
+            <p:ph type="sldNum" sz="quarter" idx="5"/>
           </p:nvPr>
         </p:nvSpPr>
         <p:spPr/>
@@ -678,7 +680,7 @@
 </file>
 
 <file path=ppt/notesSlides/notesSlide11.xml><?xml version="1.0" encoding="utf-8"?>
-<p:notes xmlns:a="http://schemas.openxmlformats.org/drawingml/2006/main" xmlns:p="http://schemas.openxmlformats.org/presentationml/2006/main" xmlns:r="http://schemas.openxmlformats.org/officeDocument/2006/relationships">
+<p:notes xmlns:a="http://schemas.openxmlformats.org/drawingml/2006/main" xmlns:r="http://schemas.openxmlformats.org/officeDocument/2006/relationships" xmlns:p="http://schemas.openxmlformats.org/presentationml/2006/main">
   <p:cSld>
     <p:spTree>
       <p:nvGrpSpPr>
@@ -698,7 +700,7 @@
         <p:nvSpPr>
           <p:cNvPr id="2" name="Slide Image Placeholder 1"/>
           <p:cNvSpPr>
-            <a:spLocks noGrp="1"/>
+            <a:spLocks noGrp="1" noRot="1" noChangeAspect="1"/>
           </p:cNvSpPr>
           <p:nvPr>
             <p:ph type="sldImg" idx="2"/>
@@ -713,7 +715,7 @@
             <a:spLocks noGrp="1"/>
           </p:cNvSpPr>
           <p:nvPr>
-            <p:ph type="body" idx="3" sz="quarter"/>
+            <p:ph type="body" sz="quarter" idx="3"/>
           </p:nvPr>
         </p:nvSpPr>
         <p:spPr/>
@@ -749,7 +751,7 @@
             <a:spLocks noGrp="1"/>
           </p:cNvSpPr>
           <p:nvPr>
-            <p:ph type="sldNum" idx="5" sz="quarter"/>
+            <p:ph type="sldNum" sz="quarter" idx="5"/>
           </p:nvPr>
         </p:nvSpPr>
         <p:spPr/>
@@ -763,7 +765,7 @@
 </file>
 
 <file path=ppt/notesSlides/notesSlide12.xml><?xml version="1.0" encoding="utf-8"?>
-<p:notes xmlns:a="http://schemas.openxmlformats.org/drawingml/2006/main" xmlns:p="http://schemas.openxmlformats.org/presentationml/2006/main" xmlns:r="http://schemas.openxmlformats.org/officeDocument/2006/relationships">
+<p:notes xmlns:a="http://schemas.openxmlformats.org/drawingml/2006/main" xmlns:r="http://schemas.openxmlformats.org/officeDocument/2006/relationships" xmlns:p="http://schemas.openxmlformats.org/presentationml/2006/main">
   <p:cSld>
     <p:spTree>
       <p:nvGrpSpPr>
@@ -783,7 +785,7 @@
         <p:nvSpPr>
           <p:cNvPr id="2" name="Slide Image Placeholder 1"/>
           <p:cNvSpPr>
-            <a:spLocks noGrp="1"/>
+            <a:spLocks noGrp="1" noRot="1" noChangeAspect="1"/>
           </p:cNvSpPr>
           <p:nvPr>
             <p:ph type="sldImg" idx="2"/>
@@ -798,16 +800,16 @@
             <a:spLocks noGrp="1"/>
           </p:cNvSpPr>
           <p:nvPr>
-            <p:ph type="body" idx="3" sz="quarter"/>
-          </p:nvPr>
-        </p:nvSpPr>
-        <p:spPr/>
-        <p:txBody>
-          <a:bodyPr/>
-          <a:lstStyle/>
-          <a:p>
-            <a:r>
-              <a:t>何も無い空 23 か所は 10/2 に今のコードで計算し直した (値は 7 月と同じ 1.264)。ばらつき = 0 からのずれの 2 乗平均の平方根。光子が十分あるビン 2–10 (2.6–169 GeV) の 207 個から計算。</a:t>
+            <p:ph type="body" sz="quarter" idx="3"/>
+          </p:nvPr>
+        </p:nvSpPr>
+        <p:spPr/>
+        <p:txBody>
+          <a:bodyPr/>
+          <a:lstStyle/>
+          <a:p>
+            <a:r>
+              <a:t>ばらつき = 0 からのずれの 2 乗平均の平方根。光子が十分あるビン 2–10 (2.6–169 GeV) の 207 個から計算。</a:t>
             </a:r>
           </a:p>
           <a:p>
@@ -834,7 +836,7 @@
             <a:spLocks noGrp="1"/>
           </p:cNvSpPr>
           <p:nvPr>
-            <p:ph type="sldNum" idx="5" sz="quarter"/>
+            <p:ph type="sldNum" sz="quarter" idx="5"/>
           </p:nvPr>
         </p:nvSpPr>
         <p:spPr/>
@@ -848,7 +850,7 @@
 </file>
 
 <file path=ppt/notesSlides/notesSlide13.xml><?xml version="1.0" encoding="utf-8"?>
-<p:notes xmlns:a="http://schemas.openxmlformats.org/drawingml/2006/main" xmlns:p="http://schemas.openxmlformats.org/presentationml/2006/main" xmlns:r="http://schemas.openxmlformats.org/officeDocument/2006/relationships">
+<p:notes xmlns:a="http://schemas.openxmlformats.org/drawingml/2006/main" xmlns:r="http://schemas.openxmlformats.org/officeDocument/2006/relationships" xmlns:p="http://schemas.openxmlformats.org/presentationml/2006/main">
   <p:cSld>
     <p:spTree>
       <p:nvGrpSpPr>
@@ -868,7 +870,7 @@
         <p:nvSpPr>
           <p:cNvPr id="2" name="Slide Image Placeholder 1"/>
           <p:cNvSpPr>
-            <a:spLocks noGrp="1"/>
+            <a:spLocks noGrp="1" noRot="1" noChangeAspect="1"/>
           </p:cNvSpPr>
           <p:nvPr>
             <p:ph type="sldImg" idx="2"/>
@@ -883,7 +885,7 @@
             <a:spLocks noGrp="1"/>
           </p:cNvSpPr>
           <p:nvPr>
-            <p:ph type="body" idx="3" sz="quarter"/>
+            <p:ph type="body" sz="quarter" idx="3"/>
           </p:nvPr>
         </p:nvSpPr>
         <p:spPr/>
@@ -914,7 +916,7 @@
             <a:spLocks noGrp="1"/>
           </p:cNvSpPr>
           <p:nvPr>
-            <p:ph type="sldNum" idx="5" sz="quarter"/>
+            <p:ph type="sldNum" sz="quarter" idx="5"/>
           </p:nvPr>
         </p:nvSpPr>
         <p:spPr/>
@@ -928,7 +930,7 @@
 </file>
 
 <file path=ppt/notesSlides/notesSlide14.xml><?xml version="1.0" encoding="utf-8"?>
-<p:notes xmlns:a="http://schemas.openxmlformats.org/drawingml/2006/main" xmlns:p="http://schemas.openxmlformats.org/presentationml/2006/main" xmlns:r="http://schemas.openxmlformats.org/officeDocument/2006/relationships">
+<p:notes xmlns:a="http://schemas.openxmlformats.org/drawingml/2006/main" xmlns:r="http://schemas.openxmlformats.org/officeDocument/2006/relationships" xmlns:p="http://schemas.openxmlformats.org/presentationml/2006/main">
   <p:cSld>
     <p:spTree>
       <p:nvGrpSpPr>
@@ -948,7 +950,7 @@
         <p:nvSpPr>
           <p:cNvPr id="2" name="Slide Image Placeholder 1"/>
           <p:cNvSpPr>
-            <a:spLocks noGrp="1"/>
+            <a:spLocks noGrp="1" noRot="1" noChangeAspect="1"/>
           </p:cNvSpPr>
           <p:nvPr>
             <p:ph type="sldImg" idx="2"/>
@@ -963,7 +965,7 @@
             <a:spLocks noGrp="1"/>
           </p:cNvSpPr>
           <p:nvPr>
-            <p:ph type="body" idx="3" sz="quarter"/>
+            <p:ph type="body" sz="quarter" idx="3"/>
           </p:nvPr>
         </p:nvSpPr>
         <p:spPr/>
@@ -994,7 +996,7 @@
             <a:spLocks noGrp="1"/>
           </p:cNvSpPr>
           <p:nvPr>
-            <p:ph type="sldNum" idx="5" sz="quarter"/>
+            <p:ph type="sldNum" sz="quarter" idx="5"/>
           </p:nvPr>
         </p:nvSpPr>
         <p:spPr/>
@@ -1008,7 +1010,7 @@
 </file>
 
 <file path=ppt/notesSlides/notesSlide15.xml><?xml version="1.0" encoding="utf-8"?>
-<p:notes xmlns:a="http://schemas.openxmlformats.org/drawingml/2006/main" xmlns:p="http://schemas.openxmlformats.org/presentationml/2006/main" xmlns:r="http://schemas.openxmlformats.org/officeDocument/2006/relationships">
+<p:notes xmlns:a="http://schemas.openxmlformats.org/drawingml/2006/main" xmlns:r="http://schemas.openxmlformats.org/officeDocument/2006/relationships" xmlns:p="http://schemas.openxmlformats.org/presentationml/2006/main">
   <p:cSld>
     <p:spTree>
       <p:nvGrpSpPr>
@@ -1028,7 +1030,7 @@
         <p:nvSpPr>
           <p:cNvPr id="2" name="Slide Image Placeholder 1"/>
           <p:cNvSpPr>
-            <a:spLocks noGrp="1"/>
+            <a:spLocks noGrp="1" noRot="1" noChangeAspect="1"/>
           </p:cNvSpPr>
           <p:nvPr>
             <p:ph type="sldImg" idx="2"/>
@@ -1043,7 +1045,7 @@
             <a:spLocks noGrp="1"/>
           </p:cNvSpPr>
           <p:nvPr>
-            <p:ph type="body" idx="3" sz="quarter"/>
+            <p:ph type="body" sz="quarter" idx="3"/>
           </p:nvPr>
         </p:nvSpPr>
         <p:spPr/>
@@ -1064,7 +1066,7 @@
             <a:spLocks noGrp="1"/>
           </p:cNvSpPr>
           <p:nvPr>
-            <p:ph type="sldNum" idx="5" sz="quarter"/>
+            <p:ph type="sldNum" sz="quarter" idx="5"/>
           </p:nvPr>
         </p:nvSpPr>
         <p:spPr/>
@@ -1078,7 +1080,7 @@
 </file>
 
 <file path=ppt/notesSlides/notesSlide16.xml><?xml version="1.0" encoding="utf-8"?>
-<p:notes xmlns:a="http://schemas.openxmlformats.org/drawingml/2006/main" xmlns:p="http://schemas.openxmlformats.org/presentationml/2006/main" xmlns:r="http://schemas.openxmlformats.org/officeDocument/2006/relationships">
+<p:notes xmlns:a="http://schemas.openxmlformats.org/drawingml/2006/main" xmlns:r="http://schemas.openxmlformats.org/officeDocument/2006/relationships" xmlns:p="http://schemas.openxmlformats.org/presentationml/2006/main">
   <p:cSld>
     <p:spTree>
       <p:nvGrpSpPr>
@@ -1098,7 +1100,7 @@
         <p:nvSpPr>
           <p:cNvPr id="2" name="Slide Image Placeholder 1"/>
           <p:cNvSpPr>
-            <a:spLocks noGrp="1"/>
+            <a:spLocks noGrp="1" noRot="1" noChangeAspect="1"/>
           </p:cNvSpPr>
           <p:nvPr>
             <p:ph type="sldImg" idx="2"/>
@@ -1113,7 +1115,7 @@
             <a:spLocks noGrp="1"/>
           </p:cNvSpPr>
           <p:nvPr>
-            <p:ph type="body" idx="3" sz="quarter"/>
+            <p:ph type="body" sz="quarter" idx="3"/>
           </p:nvPr>
         </p:nvSpPr>
         <p:spPr/>
@@ -1144,7 +1146,7 @@
             <a:spLocks noGrp="1"/>
           </p:cNvSpPr>
           <p:nvPr>
-            <p:ph type="sldNum" idx="5" sz="quarter"/>
+            <p:ph type="sldNum" sz="quarter" idx="5"/>
           </p:nvPr>
         </p:nvSpPr>
         <p:spPr/>
@@ -1158,7 +1160,7 @@
 </file>
 
 <file path=ppt/notesSlides/notesSlide17.xml><?xml version="1.0" encoding="utf-8"?>
-<p:notes xmlns:a="http://schemas.openxmlformats.org/drawingml/2006/main" xmlns:p="http://schemas.openxmlformats.org/presentationml/2006/main" xmlns:r="http://schemas.openxmlformats.org/officeDocument/2006/relationships">
+<p:notes xmlns:a="http://schemas.openxmlformats.org/drawingml/2006/main" xmlns:r="http://schemas.openxmlformats.org/officeDocument/2006/relationships" xmlns:p="http://schemas.openxmlformats.org/presentationml/2006/main">
   <p:cSld>
     <p:spTree>
       <p:nvGrpSpPr>
@@ -1178,7 +1180,7 @@
         <p:nvSpPr>
           <p:cNvPr id="2" name="Slide Image Placeholder 1"/>
           <p:cNvSpPr>
-            <a:spLocks noGrp="1"/>
+            <a:spLocks noGrp="1" noRot="1" noChangeAspect="1"/>
           </p:cNvSpPr>
           <p:nvPr>
             <p:ph type="sldImg" idx="2"/>
@@ -1193,7 +1195,7 @@
             <a:spLocks noGrp="1"/>
           </p:cNvSpPr>
           <p:nvPr>
-            <p:ph type="body" idx="3" sz="quarter"/>
+            <p:ph type="body" sz="quarter" idx="3"/>
           </p:nvPr>
         </p:nvSpPr>
         <p:spPr/>
@@ -1224,7 +1226,7 @@
             <a:spLocks noGrp="1"/>
           </p:cNvSpPr>
           <p:nvPr>
-            <p:ph type="sldNum" idx="5" sz="quarter"/>
+            <p:ph type="sldNum" sz="quarter" idx="5"/>
           </p:nvPr>
         </p:nvSpPr>
         <p:spPr/>
@@ -1238,7 +1240,7 @@
 </file>
 
 <file path=ppt/notesSlides/notesSlide18.xml><?xml version="1.0" encoding="utf-8"?>
-<p:notes xmlns:a="http://schemas.openxmlformats.org/drawingml/2006/main" xmlns:p="http://schemas.openxmlformats.org/presentationml/2006/main" xmlns:r="http://schemas.openxmlformats.org/officeDocument/2006/relationships">
+<p:notes xmlns:a="http://schemas.openxmlformats.org/drawingml/2006/main" xmlns:r="http://schemas.openxmlformats.org/officeDocument/2006/relationships" xmlns:p="http://schemas.openxmlformats.org/presentationml/2006/main">
   <p:cSld>
     <p:spTree>
       <p:nvGrpSpPr>
@@ -1258,7 +1260,7 @@
         <p:nvSpPr>
           <p:cNvPr id="2" name="Slide Image Placeholder 1"/>
           <p:cNvSpPr>
-            <a:spLocks noGrp="1"/>
+            <a:spLocks noGrp="1" noRot="1" noChangeAspect="1"/>
           </p:cNvSpPr>
           <p:nvPr>
             <p:ph type="sldImg" idx="2"/>
@@ -1273,7 +1275,7 @@
             <a:spLocks noGrp="1"/>
           </p:cNvSpPr>
           <p:nvPr>
-            <p:ph type="body" idx="3" sz="quarter"/>
+            <p:ph type="body" sz="quarter" idx="3"/>
           </p:nvPr>
         </p:nvSpPr>
         <p:spPr/>
@@ -1297,11 +1299,6 @@
           </a:p>
           <a:p>
             <a:r>
-              <a:t>10/2 に今のコード (天の川の v20r と同じ版) で 79 か所すべてを計算し直した結果 (cloud_reports/2026-10-02_v20r_targets/)。7 月の結果との差は中央値 0.0002σ、最大 0.64σ。</a:t>
-            </a:r>
-          </a:p>
-          <a:p>
-            <a:r>
               <a:t>図は slides/figs/plot_dwarf_results.py で作った。</a:t>
             </a:r>
           </a:p>
@@ -1314,7 +1311,7 @@
             <a:spLocks noGrp="1"/>
           </p:cNvSpPr>
           <p:nvPr>
-            <p:ph type="sldNum" idx="5" sz="quarter"/>
+            <p:ph type="sldNum" sz="quarter" idx="5"/>
           </p:nvPr>
         </p:nvSpPr>
         <p:spPr/>
@@ -1328,7 +1325,7 @@
 </file>
 
 <file path=ppt/notesSlides/notesSlide19.xml><?xml version="1.0" encoding="utf-8"?>
-<p:notes xmlns:a="http://schemas.openxmlformats.org/drawingml/2006/main" xmlns:p="http://schemas.openxmlformats.org/presentationml/2006/main" xmlns:r="http://schemas.openxmlformats.org/officeDocument/2006/relationships">
+<p:notes xmlns:a="http://schemas.openxmlformats.org/drawingml/2006/main" xmlns:r="http://schemas.openxmlformats.org/officeDocument/2006/relationships" xmlns:p="http://schemas.openxmlformats.org/presentationml/2006/main">
   <p:cSld>
     <p:spTree>
       <p:nvGrpSpPr>
@@ -1348,7 +1345,7 @@
         <p:nvSpPr>
           <p:cNvPr id="2" name="Slide Image Placeholder 1"/>
           <p:cNvSpPr>
-            <a:spLocks noGrp="1"/>
+            <a:spLocks noGrp="1" noRot="1" noChangeAspect="1"/>
           </p:cNvSpPr>
           <p:nvPr>
             <p:ph type="sldImg" idx="2"/>
@@ -1363,7 +1360,7 @@
             <a:spLocks noGrp="1"/>
           </p:cNvSpPr>
           <p:nvPr>
-            <p:ph type="body" idx="3" sz="quarter"/>
+            <p:ph type="body" sz="quarter" idx="3"/>
           </p:nvPr>
         </p:nvSpPr>
         <p:spPr/>
@@ -1387,11 +1384,6 @@
           </a:p>
           <a:p>
             <a:r>
-              <a:t>天の川のハローの明るさは v20r (10/1 再計算) の値、各天体の有意度は 10/2 の再計算。v20 の値を使っても 1.73 と 0.39 は変わらない。</a:t>
-            </a:r>
-          </a:p>
-          <a:p>
-            <a:r>
               <a:t>注意: 9/28 の計算は SMC・LMC を誤って含めていた (予測 2.69σ のうち 2.06σ が SMC 1 天体)。</a:t>
             </a:r>
           </a:p>
@@ -1404,7 +1396,7 @@
             <a:spLocks noGrp="1"/>
           </p:cNvSpPr>
           <p:nvPr>
-            <p:ph type="sldNum" idx="5" sz="quarter"/>
+            <p:ph type="sldNum" sz="quarter" idx="5"/>
           </p:nvPr>
         </p:nvSpPr>
         <p:spPr/>
@@ -1418,7 +1410,7 @@
 </file>
 
 <file path=ppt/notesSlides/notesSlide2.xml><?xml version="1.0" encoding="utf-8"?>
-<p:notes xmlns:a="http://schemas.openxmlformats.org/drawingml/2006/main" xmlns:p="http://schemas.openxmlformats.org/presentationml/2006/main" xmlns:r="http://schemas.openxmlformats.org/officeDocument/2006/relationships">
+<p:notes xmlns:a="http://schemas.openxmlformats.org/drawingml/2006/main" xmlns:r="http://schemas.openxmlformats.org/officeDocument/2006/relationships" xmlns:p="http://schemas.openxmlformats.org/presentationml/2006/main">
   <p:cSld>
     <p:spTree>
       <p:nvGrpSpPr>
@@ -1438,7 +1430,7 @@
         <p:nvSpPr>
           <p:cNvPr id="2" name="Slide Image Placeholder 1"/>
           <p:cNvSpPr>
-            <a:spLocks noGrp="1"/>
+            <a:spLocks noGrp="1" noRot="1" noChangeAspect="1"/>
           </p:cNvSpPr>
           <p:nvPr>
             <p:ph type="sldImg" idx="2"/>
@@ -1453,7 +1445,7 @@
             <a:spLocks noGrp="1"/>
           </p:cNvSpPr>
           <p:nvPr>
-            <p:ph type="body" idx="3" sz="quarter"/>
+            <p:ph type="body" sz="quarter" idx="3"/>
           </p:nvPr>
         </p:nvSpPr>
         <p:spPr/>
@@ -1484,7 +1476,7 @@
             <a:spLocks noGrp="1"/>
           </p:cNvSpPr>
           <p:nvPr>
-            <p:ph type="sldNum" idx="5" sz="quarter"/>
+            <p:ph type="sldNum" sz="quarter" idx="5"/>
           </p:nvPr>
         </p:nvSpPr>
         <p:spPr/>
@@ -1498,7 +1490,7 @@
 </file>
 
 <file path=ppt/notesSlides/notesSlide20.xml><?xml version="1.0" encoding="utf-8"?>
-<p:notes xmlns:a="http://schemas.openxmlformats.org/drawingml/2006/main" xmlns:p="http://schemas.openxmlformats.org/presentationml/2006/main" xmlns:r="http://schemas.openxmlformats.org/officeDocument/2006/relationships">
+<p:notes xmlns:a="http://schemas.openxmlformats.org/drawingml/2006/main" xmlns:r="http://schemas.openxmlformats.org/officeDocument/2006/relationships" xmlns:p="http://schemas.openxmlformats.org/presentationml/2006/main">
   <p:cSld>
     <p:spTree>
       <p:nvGrpSpPr>
@@ -1518,7 +1510,7 @@
         <p:nvSpPr>
           <p:cNvPr id="2" name="Slide Image Placeholder 1"/>
           <p:cNvSpPr>
-            <a:spLocks noGrp="1"/>
+            <a:spLocks noGrp="1" noRot="1" noChangeAspect="1"/>
           </p:cNvSpPr>
           <p:nvPr>
             <p:ph type="sldImg" idx="2"/>
@@ -1533,7 +1525,7 @@
             <a:spLocks noGrp="1"/>
           </p:cNvSpPr>
           <p:nvPr>
-            <p:ph type="body" idx="3" sz="quarter"/>
+            <p:ph type="body" sz="quarter" idx="3"/>
           </p:nvPr>
         </p:nvSpPr>
         <p:spPr/>
@@ -1574,7 +1566,7 @@
             <a:spLocks noGrp="1"/>
           </p:cNvSpPr>
           <p:nvPr>
-            <p:ph type="sldNum" idx="5" sz="quarter"/>
+            <p:ph type="sldNum" sz="quarter" idx="5"/>
           </p:nvPr>
         </p:nvSpPr>
         <p:spPr/>
@@ -1588,7 +1580,7 @@
 </file>
 
 <file path=ppt/notesSlides/notesSlide21.xml><?xml version="1.0" encoding="utf-8"?>
-<p:notes xmlns:a="http://schemas.openxmlformats.org/drawingml/2006/main" xmlns:p="http://schemas.openxmlformats.org/presentationml/2006/main" xmlns:r="http://schemas.openxmlformats.org/officeDocument/2006/relationships">
+<p:notes xmlns:a="http://schemas.openxmlformats.org/drawingml/2006/main" xmlns:r="http://schemas.openxmlformats.org/officeDocument/2006/relationships" xmlns:p="http://schemas.openxmlformats.org/presentationml/2006/main">
   <p:cSld>
     <p:spTree>
       <p:nvGrpSpPr>
@@ -1608,7 +1600,7 @@
         <p:nvSpPr>
           <p:cNvPr id="2" name="Slide Image Placeholder 1"/>
           <p:cNvSpPr>
-            <a:spLocks noGrp="1"/>
+            <a:spLocks noGrp="1" noRot="1" noChangeAspect="1"/>
           </p:cNvSpPr>
           <p:nvPr>
             <p:ph type="sldImg" idx="2"/>
@@ -1623,7 +1615,7 @@
             <a:spLocks noGrp="1"/>
           </p:cNvSpPr>
           <p:nvPr>
-            <p:ph type="body" idx="3" sz="quarter"/>
+            <p:ph type="body" sz="quarter" idx="3"/>
           </p:nvPr>
         </p:nvSpPr>
         <p:spPr/>
@@ -1659,7 +1651,7 @@
             <a:spLocks noGrp="1"/>
           </p:cNvSpPr>
           <p:nvPr>
-            <p:ph type="sldNum" idx="5" sz="quarter"/>
+            <p:ph type="sldNum" sz="quarter" idx="5"/>
           </p:nvPr>
         </p:nvSpPr>
         <p:spPr/>
@@ -1673,7 +1665,7 @@
 </file>
 
 <file path=ppt/notesSlides/notesSlide22.xml><?xml version="1.0" encoding="utf-8"?>
-<p:notes xmlns:a="http://schemas.openxmlformats.org/drawingml/2006/main" xmlns:p="http://schemas.openxmlformats.org/presentationml/2006/main" xmlns:r="http://schemas.openxmlformats.org/officeDocument/2006/relationships">
+<p:notes xmlns:a="http://schemas.openxmlformats.org/drawingml/2006/main" xmlns:r="http://schemas.openxmlformats.org/officeDocument/2006/relationships" xmlns:p="http://schemas.openxmlformats.org/presentationml/2006/main">
   <p:cSld>
     <p:spTree>
       <p:nvGrpSpPr>
@@ -1693,7 +1685,7 @@
         <p:nvSpPr>
           <p:cNvPr id="2" name="Slide Image Placeholder 1"/>
           <p:cNvSpPr>
-            <a:spLocks noGrp="1"/>
+            <a:spLocks noGrp="1" noRot="1" noChangeAspect="1"/>
           </p:cNvSpPr>
           <p:nvPr>
             <p:ph type="sldImg" idx="2"/>
@@ -1708,7 +1700,7 @@
             <a:spLocks noGrp="1"/>
           </p:cNvSpPr>
           <p:nvPr>
-            <p:ph type="body" idx="3" sz="quarter"/>
+            <p:ph type="body" sz="quarter" idx="3"/>
           </p:nvPr>
         </p:nvSpPr>
         <p:spPr/>
@@ -1744,7 +1736,7 @@
             <a:spLocks noGrp="1"/>
           </p:cNvSpPr>
           <p:nvPr>
-            <p:ph type="sldNum" idx="5" sz="quarter"/>
+            <p:ph type="sldNum" sz="quarter" idx="5"/>
           </p:nvPr>
         </p:nvSpPr>
         <p:spPr/>
@@ -1758,7 +1750,7 @@
 </file>
 
 <file path=ppt/notesSlides/notesSlide23.xml><?xml version="1.0" encoding="utf-8"?>
-<p:notes xmlns:a="http://schemas.openxmlformats.org/drawingml/2006/main" xmlns:p="http://schemas.openxmlformats.org/presentationml/2006/main" xmlns:r="http://schemas.openxmlformats.org/officeDocument/2006/relationships">
+<p:notes xmlns:a="http://schemas.openxmlformats.org/drawingml/2006/main" xmlns:r="http://schemas.openxmlformats.org/officeDocument/2006/relationships" xmlns:p="http://schemas.openxmlformats.org/presentationml/2006/main">
   <p:cSld>
     <p:spTree>
       <p:nvGrpSpPr>
@@ -1778,7 +1770,7 @@
         <p:nvSpPr>
           <p:cNvPr id="2" name="Slide Image Placeholder 1"/>
           <p:cNvSpPr>
-            <a:spLocks noGrp="1"/>
+            <a:spLocks noGrp="1" noRot="1" noChangeAspect="1"/>
           </p:cNvSpPr>
           <p:nvPr>
             <p:ph type="sldImg" idx="2"/>
@@ -1793,7 +1785,7 @@
             <a:spLocks noGrp="1"/>
           </p:cNvSpPr>
           <p:nvPr>
-            <p:ph type="body" idx="3" sz="quarter"/>
+            <p:ph type="body" sz="quarter" idx="3"/>
           </p:nvPr>
         </p:nvSpPr>
         <p:spPr/>
@@ -1819,7 +1811,7 @@
             <a:spLocks noGrp="1"/>
           </p:cNvSpPr>
           <p:nvPr>
-            <p:ph type="sldNum" idx="5" sz="quarter"/>
+            <p:ph type="sldNum" sz="quarter" idx="5"/>
           </p:nvPr>
         </p:nvSpPr>
         <p:spPr/>
@@ -1833,7 +1825,7 @@
 </file>
 
 <file path=ppt/notesSlides/notesSlide24.xml><?xml version="1.0" encoding="utf-8"?>
-<p:notes xmlns:a="http://schemas.openxmlformats.org/drawingml/2006/main" xmlns:p="http://schemas.openxmlformats.org/presentationml/2006/main" xmlns:r="http://schemas.openxmlformats.org/officeDocument/2006/relationships">
+<p:notes xmlns:a="http://schemas.openxmlformats.org/drawingml/2006/main" xmlns:r="http://schemas.openxmlformats.org/officeDocument/2006/relationships" xmlns:p="http://schemas.openxmlformats.org/presentationml/2006/main">
   <p:cSld>
     <p:spTree>
       <p:nvGrpSpPr>
@@ -1853,7 +1845,7 @@
         <p:nvSpPr>
           <p:cNvPr id="2" name="Slide Image Placeholder 1"/>
           <p:cNvSpPr>
-            <a:spLocks noGrp="1"/>
+            <a:spLocks noGrp="1" noRot="1" noChangeAspect="1"/>
           </p:cNvSpPr>
           <p:nvPr>
             <p:ph type="sldImg" idx="2"/>
@@ -1868,7 +1860,7 @@
             <a:spLocks noGrp="1"/>
           </p:cNvSpPr>
           <p:nvPr>
-            <p:ph type="body" idx="3" sz="quarter"/>
+            <p:ph type="body" sz="quarter" idx="3"/>
           </p:nvPr>
         </p:nvSpPr>
         <p:spPr/>
@@ -1904,7 +1896,7 @@
             <a:spLocks noGrp="1"/>
           </p:cNvSpPr>
           <p:nvPr>
-            <p:ph type="sldNum" idx="5" sz="quarter"/>
+            <p:ph type="sldNum" sz="quarter" idx="5"/>
           </p:nvPr>
         </p:nvSpPr>
         <p:spPr/>
@@ -1918,7 +1910,7 @@
 </file>
 
 <file path=ppt/notesSlides/notesSlide25.xml><?xml version="1.0" encoding="utf-8"?>
-<p:notes xmlns:a="http://schemas.openxmlformats.org/drawingml/2006/main" xmlns:p="http://schemas.openxmlformats.org/presentationml/2006/main" xmlns:r="http://schemas.openxmlformats.org/officeDocument/2006/relationships">
+<p:notes xmlns:a="http://schemas.openxmlformats.org/drawingml/2006/main" xmlns:r="http://schemas.openxmlformats.org/officeDocument/2006/relationships" xmlns:p="http://schemas.openxmlformats.org/presentationml/2006/main">
   <p:cSld>
     <p:spTree>
       <p:nvGrpSpPr>
@@ -1938,7 +1930,7 @@
         <p:nvSpPr>
           <p:cNvPr id="2" name="Slide Image Placeholder 1"/>
           <p:cNvSpPr>
-            <a:spLocks noGrp="1"/>
+            <a:spLocks noGrp="1" noRot="1" noChangeAspect="1"/>
           </p:cNvSpPr>
           <p:nvPr>
             <p:ph type="sldImg" idx="2"/>
@@ -1953,7 +1945,7 @@
             <a:spLocks noGrp="1"/>
           </p:cNvSpPr>
           <p:nvPr>
-            <p:ph type="body" idx="3" sz="quarter"/>
+            <p:ph type="body" sz="quarter" idx="3"/>
           </p:nvPr>
         </p:nvSpPr>
         <p:spPr/>
@@ -1994,7 +1986,7 @@
             <a:spLocks noGrp="1"/>
           </p:cNvSpPr>
           <p:nvPr>
-            <p:ph type="sldNum" idx="5" sz="quarter"/>
+            <p:ph type="sldNum" sz="quarter" idx="5"/>
           </p:nvPr>
         </p:nvSpPr>
         <p:spPr/>
@@ -2008,7 +2000,7 @@
 </file>
 
 <file path=ppt/notesSlides/notesSlide26.xml><?xml version="1.0" encoding="utf-8"?>
-<p:notes xmlns:a="http://schemas.openxmlformats.org/drawingml/2006/main" xmlns:p="http://schemas.openxmlformats.org/presentationml/2006/main" xmlns:r="http://schemas.openxmlformats.org/officeDocument/2006/relationships">
+<p:notes xmlns:a="http://schemas.openxmlformats.org/drawingml/2006/main" xmlns:r="http://schemas.openxmlformats.org/officeDocument/2006/relationships" xmlns:p="http://schemas.openxmlformats.org/presentationml/2006/main">
   <p:cSld>
     <p:spTree>
       <p:nvGrpSpPr>
@@ -2028,7 +2020,7 @@
         <p:nvSpPr>
           <p:cNvPr id="2" name="Slide Image Placeholder 1"/>
           <p:cNvSpPr>
-            <a:spLocks noGrp="1"/>
+            <a:spLocks noGrp="1" noRot="1" noChangeAspect="1"/>
           </p:cNvSpPr>
           <p:nvPr>
             <p:ph type="sldImg" idx="2"/>
@@ -2043,7 +2035,7 @@
             <a:spLocks noGrp="1"/>
           </p:cNvSpPr>
           <p:nvPr>
-            <p:ph type="body" idx="3" sz="quarter"/>
+            <p:ph type="body" sz="quarter" idx="3"/>
           </p:nvPr>
         </p:nvSpPr>
         <p:spPr/>
@@ -2064,7 +2056,7 @@
             <a:spLocks noGrp="1"/>
           </p:cNvSpPr>
           <p:nvPr>
-            <p:ph type="sldNum" idx="5" sz="quarter"/>
+            <p:ph type="sldNum" sz="quarter" idx="5"/>
           </p:nvPr>
         </p:nvSpPr>
         <p:spPr/>
@@ -2078,7 +2070,7 @@
 </file>
 
 <file path=ppt/notesSlides/notesSlide27.xml><?xml version="1.0" encoding="utf-8"?>
-<p:notes xmlns:a="http://schemas.openxmlformats.org/drawingml/2006/main" xmlns:p="http://schemas.openxmlformats.org/presentationml/2006/main" xmlns:r="http://schemas.openxmlformats.org/officeDocument/2006/relationships">
+<p:notes xmlns:a="http://schemas.openxmlformats.org/drawingml/2006/main" xmlns:r="http://schemas.openxmlformats.org/officeDocument/2006/relationships" xmlns:p="http://schemas.openxmlformats.org/presentationml/2006/main">
   <p:cSld>
     <p:spTree>
       <p:nvGrpSpPr>
@@ -2098,7 +2090,7 @@
         <p:nvSpPr>
           <p:cNvPr id="2" name="Slide Image Placeholder 1"/>
           <p:cNvSpPr>
-            <a:spLocks noGrp="1"/>
+            <a:spLocks noGrp="1" noRot="1" noChangeAspect="1"/>
           </p:cNvSpPr>
           <p:nvPr>
             <p:ph type="sldImg" idx="2"/>
@@ -2113,7 +2105,7 @@
             <a:spLocks noGrp="1"/>
           </p:cNvSpPr>
           <p:nvPr>
-            <p:ph type="body" idx="3" sz="quarter"/>
+            <p:ph type="body" sz="quarter" idx="3"/>
           </p:nvPr>
         </p:nvSpPr>
         <p:spPr/>
@@ -2144,7 +2136,7 @@
             <a:spLocks noGrp="1"/>
           </p:cNvSpPr>
           <p:nvPr>
-            <p:ph type="sldNum" idx="5" sz="quarter"/>
+            <p:ph type="sldNum" sz="quarter" idx="5"/>
           </p:nvPr>
         </p:nvSpPr>
         <p:spPr/>
@@ -2158,7 +2150,7 @@
 </file>
 
 <file path=ppt/notesSlides/notesSlide28.xml><?xml version="1.0" encoding="utf-8"?>
-<p:notes xmlns:a="http://schemas.openxmlformats.org/drawingml/2006/main" xmlns:p="http://schemas.openxmlformats.org/presentationml/2006/main" xmlns:r="http://schemas.openxmlformats.org/officeDocument/2006/relationships">
+<p:notes xmlns:a="http://schemas.openxmlformats.org/drawingml/2006/main" xmlns:r="http://schemas.openxmlformats.org/officeDocument/2006/relationships" xmlns:p="http://schemas.openxmlformats.org/presentationml/2006/main">
   <p:cSld>
     <p:spTree>
       <p:nvGrpSpPr>
@@ -2178,7 +2170,7 @@
         <p:nvSpPr>
           <p:cNvPr id="2" name="Slide Image Placeholder 1"/>
           <p:cNvSpPr>
-            <a:spLocks noGrp="1"/>
+            <a:spLocks noGrp="1" noRot="1" noChangeAspect="1"/>
           </p:cNvSpPr>
           <p:nvPr>
             <p:ph type="sldImg" idx="2"/>
@@ -2193,7 +2185,7 @@
             <a:spLocks noGrp="1"/>
           </p:cNvSpPr>
           <p:nvPr>
-            <p:ph type="body" idx="3" sz="quarter"/>
+            <p:ph type="body" sz="quarter" idx="3"/>
           </p:nvPr>
         </p:nvSpPr>
         <p:spPr/>
@@ -2224,7 +2216,7 @@
             <a:spLocks noGrp="1"/>
           </p:cNvSpPr>
           <p:nvPr>
-            <p:ph type="sldNum" idx="5" sz="quarter"/>
+            <p:ph type="sldNum" sz="quarter" idx="5"/>
           </p:nvPr>
         </p:nvSpPr>
         <p:spPr/>
@@ -2238,7 +2230,7 @@
 </file>
 
 <file path=ppt/notesSlides/notesSlide29.xml><?xml version="1.0" encoding="utf-8"?>
-<p:notes xmlns:a="http://schemas.openxmlformats.org/drawingml/2006/main" xmlns:p="http://schemas.openxmlformats.org/presentationml/2006/main" xmlns:r="http://schemas.openxmlformats.org/officeDocument/2006/relationships">
+<p:notes xmlns:a="http://schemas.openxmlformats.org/drawingml/2006/main" xmlns:r="http://schemas.openxmlformats.org/officeDocument/2006/relationships" xmlns:p="http://schemas.openxmlformats.org/presentationml/2006/main">
   <p:cSld>
     <p:spTree>
       <p:nvGrpSpPr>
@@ -2258,7 +2250,7 @@
         <p:nvSpPr>
           <p:cNvPr id="2" name="Slide Image Placeholder 1"/>
           <p:cNvSpPr>
-            <a:spLocks noGrp="1"/>
+            <a:spLocks noGrp="1" noRot="1" noChangeAspect="1"/>
           </p:cNvSpPr>
           <p:nvPr>
             <p:ph type="sldImg" idx="2"/>
@@ -2273,7 +2265,7 @@
             <a:spLocks noGrp="1"/>
           </p:cNvSpPr>
           <p:nvPr>
-            <p:ph type="body" idx="3" sz="quarter"/>
+            <p:ph type="body" sz="quarter" idx="3"/>
           </p:nvPr>
         </p:nvSpPr>
         <p:spPr/>
@@ -2304,7 +2296,7 @@
             <a:spLocks noGrp="1"/>
           </p:cNvSpPr>
           <p:nvPr>
-            <p:ph type="sldNum" idx="5" sz="quarter"/>
+            <p:ph type="sldNum" sz="quarter" idx="5"/>
           </p:nvPr>
         </p:nvSpPr>
         <p:spPr/>
@@ -2318,7 +2310,7 @@
 </file>
 
 <file path=ppt/notesSlides/notesSlide3.xml><?xml version="1.0" encoding="utf-8"?>
-<p:notes xmlns:a="http://schemas.openxmlformats.org/drawingml/2006/main" xmlns:p="http://schemas.openxmlformats.org/presentationml/2006/main" xmlns:r="http://schemas.openxmlformats.org/officeDocument/2006/relationships">
+<p:notes xmlns:a="http://schemas.openxmlformats.org/drawingml/2006/main" xmlns:r="http://schemas.openxmlformats.org/officeDocument/2006/relationships" xmlns:p="http://schemas.openxmlformats.org/presentationml/2006/main">
   <p:cSld>
     <p:spTree>
       <p:nvGrpSpPr>
@@ -2338,7 +2330,7 @@
         <p:nvSpPr>
           <p:cNvPr id="2" name="Slide Image Placeholder 1"/>
           <p:cNvSpPr>
-            <a:spLocks noGrp="1"/>
+            <a:spLocks noGrp="1" noRot="1" noChangeAspect="1"/>
           </p:cNvSpPr>
           <p:nvPr>
             <p:ph type="sldImg" idx="2"/>
@@ -2353,7 +2345,7 @@
             <a:spLocks noGrp="1"/>
           </p:cNvSpPr>
           <p:nvPr>
-            <p:ph type="body" idx="3" sz="quarter"/>
+            <p:ph type="body" sz="quarter" idx="3"/>
           </p:nvPr>
         </p:nvSpPr>
         <p:spPr/>
@@ -2394,7 +2386,7 @@
             <a:spLocks noGrp="1"/>
           </p:cNvSpPr>
           <p:nvPr>
-            <p:ph type="sldNum" idx="5" sz="quarter"/>
+            <p:ph type="sldNum" sz="quarter" idx="5"/>
           </p:nvPr>
         </p:nvSpPr>
         <p:spPr/>
@@ -2408,7 +2400,7 @@
 </file>
 
 <file path=ppt/notesSlides/notesSlide30.xml><?xml version="1.0" encoding="utf-8"?>
-<p:notes xmlns:a="http://schemas.openxmlformats.org/drawingml/2006/main" xmlns:p="http://schemas.openxmlformats.org/presentationml/2006/main" xmlns:r="http://schemas.openxmlformats.org/officeDocument/2006/relationships">
+<p:notes xmlns:a="http://schemas.openxmlformats.org/drawingml/2006/main" xmlns:r="http://schemas.openxmlformats.org/officeDocument/2006/relationships" xmlns:p="http://schemas.openxmlformats.org/presentationml/2006/main">
   <p:cSld>
     <p:spTree>
       <p:nvGrpSpPr>
@@ -2428,7 +2420,7 @@
         <p:nvSpPr>
           <p:cNvPr id="2" name="Slide Image Placeholder 1"/>
           <p:cNvSpPr>
-            <a:spLocks noGrp="1"/>
+            <a:spLocks noGrp="1" noRot="1" noChangeAspect="1"/>
           </p:cNvSpPr>
           <p:nvPr>
             <p:ph type="sldImg" idx="2"/>
@@ -2443,7 +2435,7 @@
             <a:spLocks noGrp="1"/>
           </p:cNvSpPr>
           <p:nvPr>
-            <p:ph type="body" idx="3" sz="quarter"/>
+            <p:ph type="body" sz="quarter" idx="3"/>
           </p:nvPr>
         </p:nvSpPr>
         <p:spPr/>
@@ -2479,7 +2471,7 @@
             <a:spLocks noGrp="1"/>
           </p:cNvSpPr>
           <p:nvPr>
-            <p:ph type="sldNum" idx="5" sz="quarter"/>
+            <p:ph type="sldNum" sz="quarter" idx="5"/>
           </p:nvPr>
         </p:nvSpPr>
         <p:spPr/>
@@ -2493,7 +2485,7 @@
 </file>
 
 <file path=ppt/notesSlides/notesSlide31.xml><?xml version="1.0" encoding="utf-8"?>
-<p:notes xmlns:a="http://schemas.openxmlformats.org/drawingml/2006/main" xmlns:p="http://schemas.openxmlformats.org/presentationml/2006/main" xmlns:r="http://schemas.openxmlformats.org/officeDocument/2006/relationships">
+<p:notes xmlns:a="http://schemas.openxmlformats.org/drawingml/2006/main" xmlns:r="http://schemas.openxmlformats.org/officeDocument/2006/relationships" xmlns:p="http://schemas.openxmlformats.org/presentationml/2006/main">
   <p:cSld>
     <p:spTree>
       <p:nvGrpSpPr>
@@ -2513,7 +2505,7 @@
         <p:nvSpPr>
           <p:cNvPr id="2" name="Slide Image Placeholder 1"/>
           <p:cNvSpPr>
-            <a:spLocks noGrp="1"/>
+            <a:spLocks noGrp="1" noRot="1" noChangeAspect="1"/>
           </p:cNvSpPr>
           <p:nvPr>
             <p:ph type="sldImg" idx="2"/>
@@ -2528,7 +2520,7 @@
             <a:spLocks noGrp="1"/>
           </p:cNvSpPr>
           <p:nvPr>
-            <p:ph type="body" idx="3" sz="quarter"/>
+            <p:ph type="body" sz="quarter" idx="3"/>
           </p:nvPr>
         </p:nvSpPr>
         <p:spPr/>
@@ -2554,7 +2546,7 @@
             <a:spLocks noGrp="1"/>
           </p:cNvSpPr>
           <p:nvPr>
-            <p:ph type="sldNum" idx="5" sz="quarter"/>
+            <p:ph type="sldNum" sz="quarter" idx="5"/>
           </p:nvPr>
         </p:nvSpPr>
         <p:spPr/>
@@ -2568,7 +2560,7 @@
 </file>
 
 <file path=ppt/notesSlides/notesSlide32.xml><?xml version="1.0" encoding="utf-8"?>
-<p:notes xmlns:a="http://schemas.openxmlformats.org/drawingml/2006/main" xmlns:p="http://schemas.openxmlformats.org/presentationml/2006/main" xmlns:r="http://schemas.openxmlformats.org/officeDocument/2006/relationships">
+<p:notes xmlns:a="http://schemas.openxmlformats.org/drawingml/2006/main" xmlns:r="http://schemas.openxmlformats.org/officeDocument/2006/relationships" xmlns:p="http://schemas.openxmlformats.org/presentationml/2006/main">
   <p:cSld>
     <p:spTree>
       <p:nvGrpSpPr>
@@ -2588,7 +2580,7 @@
         <p:nvSpPr>
           <p:cNvPr id="2" name="Slide Image Placeholder 1"/>
           <p:cNvSpPr>
-            <a:spLocks noGrp="1"/>
+            <a:spLocks noGrp="1" noRot="1" noChangeAspect="1"/>
           </p:cNvSpPr>
           <p:nvPr>
             <p:ph type="sldImg" idx="2"/>
@@ -2603,7 +2595,7 @@
             <a:spLocks noGrp="1"/>
           </p:cNvSpPr>
           <p:nvPr>
-            <p:ph type="body" idx="3" sz="quarter"/>
+            <p:ph type="body" sz="quarter" idx="3"/>
           </p:nvPr>
         </p:nvSpPr>
         <p:spPr/>
@@ -2624,7 +2616,7 @@
             <a:spLocks noGrp="1"/>
           </p:cNvSpPr>
           <p:nvPr>
-            <p:ph type="sldNum" idx="5" sz="quarter"/>
+            <p:ph type="sldNum" sz="quarter" idx="5"/>
           </p:nvPr>
         </p:nvSpPr>
         <p:spPr/>
@@ -2638,7 +2630,7 @@
 </file>
 
 <file path=ppt/notesSlides/notesSlide33.xml><?xml version="1.0" encoding="utf-8"?>
-<p:notes xmlns:a="http://schemas.openxmlformats.org/drawingml/2006/main" xmlns:p="http://schemas.openxmlformats.org/presentationml/2006/main" xmlns:r="http://schemas.openxmlformats.org/officeDocument/2006/relationships">
+<p:notes xmlns:a="http://schemas.openxmlformats.org/drawingml/2006/main" xmlns:r="http://schemas.openxmlformats.org/officeDocument/2006/relationships" xmlns:p="http://schemas.openxmlformats.org/presentationml/2006/main">
   <p:cSld>
     <p:spTree>
       <p:nvGrpSpPr>
@@ -2658,7 +2650,7 @@
         <p:nvSpPr>
           <p:cNvPr id="2" name="Slide Image Placeholder 1"/>
           <p:cNvSpPr>
-            <a:spLocks noGrp="1"/>
+            <a:spLocks noGrp="1" noRot="1" noChangeAspect="1"/>
           </p:cNvSpPr>
           <p:nvPr>
             <p:ph type="sldImg" idx="2"/>
@@ -2673,7 +2665,7 @@
             <a:spLocks noGrp="1"/>
           </p:cNvSpPr>
           <p:nvPr>
-            <p:ph type="body" idx="3" sz="quarter"/>
+            <p:ph type="body" sz="quarter" idx="3"/>
           </p:nvPr>
         </p:nvSpPr>
         <p:spPr/>
@@ -2709,7 +2701,7 @@
             <a:spLocks noGrp="1"/>
           </p:cNvSpPr>
           <p:nvPr>
-            <p:ph type="sldNum" idx="5" sz="quarter"/>
+            <p:ph type="sldNum" sz="quarter" idx="5"/>
           </p:nvPr>
         </p:nvSpPr>
         <p:spPr/>
@@ -2723,7 +2715,7 @@
 </file>
 
 <file path=ppt/notesSlides/notesSlide34.xml><?xml version="1.0" encoding="utf-8"?>
-<p:notes xmlns:a="http://schemas.openxmlformats.org/drawingml/2006/main" xmlns:p="http://schemas.openxmlformats.org/presentationml/2006/main" xmlns:r="http://schemas.openxmlformats.org/officeDocument/2006/relationships">
+<p:notes xmlns:a="http://schemas.openxmlformats.org/drawingml/2006/main" xmlns:r="http://schemas.openxmlformats.org/officeDocument/2006/relationships" xmlns:p="http://schemas.openxmlformats.org/presentationml/2006/main">
   <p:cSld>
     <p:spTree>
       <p:nvGrpSpPr>
@@ -2743,7 +2735,7 @@
         <p:nvSpPr>
           <p:cNvPr id="2" name="Slide Image Placeholder 1"/>
           <p:cNvSpPr>
-            <a:spLocks noGrp="1"/>
+            <a:spLocks noGrp="1" noRot="1" noChangeAspect="1"/>
           </p:cNvSpPr>
           <p:nvPr>
             <p:ph type="sldImg" idx="2"/>
@@ -2758,14 +2750,16 @@
             <a:spLocks noGrp="1"/>
           </p:cNvSpPr>
           <p:nvPr>
-            <p:ph type="body" idx="3" sz="quarter"/>
-          </p:nvPr>
-        </p:nvSpPr>
-        <p:spPr/>
-        <p:txBody>
-          <a:bodyPr/>
-          <a:lstStyle/>
-          <a:p/>
+            <p:ph type="body" sz="quarter" idx="3"/>
+          </p:nvPr>
+        </p:nvSpPr>
+        <p:spPr/>
+        <p:txBody>
+          <a:bodyPr/>
+          <a:lstStyle/>
+          <a:p>
+            <a:endParaRPr/>
+          </a:p>
         </p:txBody>
       </p:sp>
       <p:sp>
@@ -2775,7 +2769,7 @@
             <a:spLocks noGrp="1"/>
           </p:cNvSpPr>
           <p:nvPr>
-            <p:ph type="sldNum" idx="5" sz="quarter"/>
+            <p:ph type="sldNum" sz="quarter" idx="5"/>
           </p:nvPr>
         </p:nvSpPr>
         <p:spPr/>
@@ -2789,7 +2783,7 @@
 </file>
 
 <file path=ppt/notesSlides/notesSlide4.xml><?xml version="1.0" encoding="utf-8"?>
-<p:notes xmlns:a="http://schemas.openxmlformats.org/drawingml/2006/main" xmlns:p="http://schemas.openxmlformats.org/presentationml/2006/main" xmlns:r="http://schemas.openxmlformats.org/officeDocument/2006/relationships">
+<p:notes xmlns:a="http://schemas.openxmlformats.org/drawingml/2006/main" xmlns:r="http://schemas.openxmlformats.org/officeDocument/2006/relationships" xmlns:p="http://schemas.openxmlformats.org/presentationml/2006/main">
   <p:cSld>
     <p:spTree>
       <p:nvGrpSpPr>
@@ -2809,7 +2803,7 @@
         <p:nvSpPr>
           <p:cNvPr id="2" name="Slide Image Placeholder 1"/>
           <p:cNvSpPr>
-            <a:spLocks noGrp="1"/>
+            <a:spLocks noGrp="1" noRot="1" noChangeAspect="1"/>
           </p:cNvSpPr>
           <p:nvPr>
             <p:ph type="sldImg" idx="2"/>
@@ -2824,7 +2818,7 @@
             <a:spLocks noGrp="1"/>
           </p:cNvSpPr>
           <p:nvPr>
-            <p:ph type="body" idx="3" sz="quarter"/>
+            <p:ph type="body" sz="quarter" idx="3"/>
           </p:nvPr>
         </p:nvSpPr>
         <p:spPr/>
@@ -2855,7 +2849,7 @@
             <a:spLocks noGrp="1"/>
           </p:cNvSpPr>
           <p:nvPr>
-            <p:ph type="sldNum" idx="5" sz="quarter"/>
+            <p:ph type="sldNum" sz="quarter" idx="5"/>
           </p:nvPr>
         </p:nvSpPr>
         <p:spPr/>
@@ -2869,7 +2863,7 @@
 </file>
 
 <file path=ppt/notesSlides/notesSlide5.xml><?xml version="1.0" encoding="utf-8"?>
-<p:notes xmlns:a="http://schemas.openxmlformats.org/drawingml/2006/main" xmlns:p="http://schemas.openxmlformats.org/presentationml/2006/main" xmlns:r="http://schemas.openxmlformats.org/officeDocument/2006/relationships">
+<p:notes xmlns:a="http://schemas.openxmlformats.org/drawingml/2006/main" xmlns:r="http://schemas.openxmlformats.org/officeDocument/2006/relationships" xmlns:p="http://schemas.openxmlformats.org/presentationml/2006/main">
   <p:cSld>
     <p:spTree>
       <p:nvGrpSpPr>
@@ -2889,7 +2883,7 @@
         <p:nvSpPr>
           <p:cNvPr id="2" name="Slide Image Placeholder 1"/>
           <p:cNvSpPr>
-            <a:spLocks noGrp="1"/>
+            <a:spLocks noGrp="1" noRot="1" noChangeAspect="1"/>
           </p:cNvSpPr>
           <p:nvPr>
             <p:ph type="sldImg" idx="2"/>
@@ -2904,7 +2898,7 @@
             <a:spLocks noGrp="1"/>
           </p:cNvSpPr>
           <p:nvPr>
-            <p:ph type="body" idx="3" sz="quarter"/>
+            <p:ph type="body" sz="quarter" idx="3"/>
           </p:nvPr>
         </p:nvSpPr>
         <p:spPr/>
@@ -2935,7 +2929,7 @@
             <a:spLocks noGrp="1"/>
           </p:cNvSpPr>
           <p:nvPr>
-            <p:ph type="sldNum" idx="5" sz="quarter"/>
+            <p:ph type="sldNum" sz="quarter" idx="5"/>
           </p:nvPr>
         </p:nvSpPr>
         <p:spPr/>
@@ -2949,7 +2943,7 @@
 </file>
 
 <file path=ppt/notesSlides/notesSlide6.xml><?xml version="1.0" encoding="utf-8"?>
-<p:notes xmlns:a="http://schemas.openxmlformats.org/drawingml/2006/main" xmlns:p="http://schemas.openxmlformats.org/presentationml/2006/main" xmlns:r="http://schemas.openxmlformats.org/officeDocument/2006/relationships">
+<p:notes xmlns:a="http://schemas.openxmlformats.org/drawingml/2006/main" xmlns:r="http://schemas.openxmlformats.org/officeDocument/2006/relationships" xmlns:p="http://schemas.openxmlformats.org/presentationml/2006/main">
   <p:cSld>
     <p:spTree>
       <p:nvGrpSpPr>
@@ -2969,7 +2963,7 @@
         <p:nvSpPr>
           <p:cNvPr id="2" name="Slide Image Placeholder 1"/>
           <p:cNvSpPr>
-            <a:spLocks noGrp="1"/>
+            <a:spLocks noGrp="1" noRot="1" noChangeAspect="1"/>
           </p:cNvSpPr>
           <p:nvPr>
             <p:ph type="sldImg" idx="2"/>
@@ -2984,7 +2978,7 @@
             <a:spLocks noGrp="1"/>
           </p:cNvSpPr>
           <p:nvPr>
-            <p:ph type="body" idx="3" sz="quarter"/>
+            <p:ph type="body" sz="quarter" idx="3"/>
           </p:nvPr>
         </p:nvSpPr>
         <p:spPr/>
@@ -3020,7 +3014,7 @@
             <a:spLocks noGrp="1"/>
           </p:cNvSpPr>
           <p:nvPr>
-            <p:ph type="sldNum" idx="5" sz="quarter"/>
+            <p:ph type="sldNum" sz="quarter" idx="5"/>
           </p:nvPr>
         </p:nvSpPr>
         <p:spPr/>
@@ -3034,7 +3028,7 @@
 </file>
 
 <file path=ppt/notesSlides/notesSlide7.xml><?xml version="1.0" encoding="utf-8"?>
-<p:notes xmlns:a="http://schemas.openxmlformats.org/drawingml/2006/main" xmlns:p="http://schemas.openxmlformats.org/presentationml/2006/main" xmlns:r="http://schemas.openxmlformats.org/officeDocument/2006/relationships">
+<p:notes xmlns:a="http://schemas.openxmlformats.org/drawingml/2006/main" xmlns:r="http://schemas.openxmlformats.org/officeDocument/2006/relationships" xmlns:p="http://schemas.openxmlformats.org/presentationml/2006/main">
   <p:cSld>
     <p:spTree>
       <p:nvGrpSpPr>
@@ -3054,7 +3048,7 @@
         <p:nvSpPr>
           <p:cNvPr id="2" name="Slide Image Placeholder 1"/>
           <p:cNvSpPr>
-            <a:spLocks noGrp="1"/>
+            <a:spLocks noGrp="1" noRot="1" noChangeAspect="1"/>
           </p:cNvSpPr>
           <p:nvPr>
             <p:ph type="sldImg" idx="2"/>
@@ -3069,7 +3063,7 @@
             <a:spLocks noGrp="1"/>
           </p:cNvSpPr>
           <p:nvPr>
-            <p:ph type="body" idx="3" sz="quarter"/>
+            <p:ph type="body" sz="quarter" idx="3"/>
           </p:nvPr>
         </p:nvSpPr>
         <p:spPr/>
@@ -3095,7 +3089,7 @@
             <a:spLocks noGrp="1"/>
           </p:cNvSpPr>
           <p:nvPr>
-            <p:ph type="sldNum" idx="5" sz="quarter"/>
+            <p:ph type="sldNum" sz="quarter" idx="5"/>
           </p:nvPr>
         </p:nvSpPr>
         <p:spPr/>
@@ -3109,7 +3103,7 @@
 </file>
 
 <file path=ppt/notesSlides/notesSlide8.xml><?xml version="1.0" encoding="utf-8"?>
-<p:notes xmlns:a="http://schemas.openxmlformats.org/drawingml/2006/main" xmlns:p="http://schemas.openxmlformats.org/presentationml/2006/main" xmlns:r="http://schemas.openxmlformats.org/officeDocument/2006/relationships">
+<p:notes xmlns:a="http://schemas.openxmlformats.org/drawingml/2006/main" xmlns:r="http://schemas.openxmlformats.org/officeDocument/2006/relationships" xmlns:p="http://schemas.openxmlformats.org/presentationml/2006/main">
   <p:cSld>
     <p:spTree>
       <p:nvGrpSpPr>
@@ -3129,7 +3123,7 @@
         <p:nvSpPr>
           <p:cNvPr id="2" name="Slide Image Placeholder 1"/>
           <p:cNvSpPr>
-            <a:spLocks noGrp="1"/>
+            <a:spLocks noGrp="1" noRot="1" noChangeAspect="1"/>
           </p:cNvSpPr>
           <p:nvPr>
             <p:ph type="sldImg" idx="2"/>
@@ -3144,7 +3138,7 @@
             <a:spLocks noGrp="1"/>
           </p:cNvSpPr>
           <p:nvPr>
-            <p:ph type="body" idx="3" sz="quarter"/>
+            <p:ph type="body" sz="quarter" idx="3"/>
           </p:nvPr>
         </p:nvSpPr>
         <p:spPr/>
@@ -3175,7 +3169,7 @@
             <a:spLocks noGrp="1"/>
           </p:cNvSpPr>
           <p:nvPr>
-            <p:ph type="sldNum" idx="5" sz="quarter"/>
+            <p:ph type="sldNum" sz="quarter" idx="5"/>
           </p:nvPr>
         </p:nvSpPr>
         <p:spPr/>
@@ -3189,7 +3183,7 @@
 </file>
 
 <file path=ppt/notesSlides/notesSlide9.xml><?xml version="1.0" encoding="utf-8"?>
-<p:notes xmlns:a="http://schemas.openxmlformats.org/drawingml/2006/main" xmlns:p="http://schemas.openxmlformats.org/presentationml/2006/main" xmlns:r="http://schemas.openxmlformats.org/officeDocument/2006/relationships">
+<p:notes xmlns:a="http://schemas.openxmlformats.org/drawingml/2006/main" xmlns:r="http://schemas.openxmlformats.org/officeDocument/2006/relationships" xmlns:p="http://schemas.openxmlformats.org/presentationml/2006/main">
   <p:cSld>
     <p:spTree>
       <p:nvGrpSpPr>
@@ -3209,7 +3203,7 @@
         <p:nvSpPr>
           <p:cNvPr id="2" name="Slide Image Placeholder 1"/>
           <p:cNvSpPr>
-            <a:spLocks noGrp="1"/>
+            <a:spLocks noGrp="1" noRot="1" noChangeAspect="1"/>
           </p:cNvSpPr>
           <p:nvPr>
             <p:ph type="sldImg" idx="2"/>
@@ -3224,7 +3218,7 @@
             <a:spLocks noGrp="1"/>
           </p:cNvSpPr>
           <p:nvPr>
-            <p:ph type="body" idx="3" sz="quarter"/>
+            <p:ph type="body" sz="quarter" idx="3"/>
           </p:nvPr>
         </p:nvSpPr>
         <p:spPr/>
@@ -3255,7 +3249,7 @@
             <a:spLocks noGrp="1"/>
           </p:cNvSpPr>
           <p:nvPr>
-            <p:ph type="sldNum" idx="5" sz="quarter"/>
+            <p:ph type="sldNum" sz="quarter" idx="5"/>
           </p:nvPr>
         </p:nvSpPr>
         <p:spPr/>
@@ -3415,7 +3409,7 @@
           <a:p>
             <a:fld id="{030FFF5C-2D96-4D39-AE5C-E4AC30C80AB5}" type="datetimeFigureOut">
               <a:rPr lang="en-US" smtClean="0"/>
-              <a:t>10/1/2026</a:t>
+              <a:t>10/2/2026</a:t>
             </a:fld>
             <a:endParaRPr lang="en-US"/>
           </a:p>
@@ -3613,7 +3607,7 @@
           <a:p>
             <a:fld id="{030FFF5C-2D96-4D39-AE5C-E4AC30C80AB5}" type="datetimeFigureOut">
               <a:rPr lang="en-US" smtClean="0"/>
-              <a:t>10/1/2026</a:t>
+              <a:t>10/2/2026</a:t>
             </a:fld>
             <a:endParaRPr lang="en-US"/>
           </a:p>
@@ -3821,7 +3815,7 @@
           <a:p>
             <a:fld id="{030FFF5C-2D96-4D39-AE5C-E4AC30C80AB5}" type="datetimeFigureOut">
               <a:rPr lang="en-US" smtClean="0"/>
-              <a:t>10/1/2026</a:t>
+              <a:t>10/2/2026</a:t>
             </a:fld>
             <a:endParaRPr lang="en-US"/>
           </a:p>
@@ -4019,7 +4013,7 @@
           <a:p>
             <a:fld id="{030FFF5C-2D96-4D39-AE5C-E4AC30C80AB5}" type="datetimeFigureOut">
               <a:rPr lang="en-US" smtClean="0"/>
-              <a:t>10/1/2026</a:t>
+              <a:t>10/2/2026</a:t>
             </a:fld>
             <a:endParaRPr lang="en-US"/>
           </a:p>
@@ -4294,7 +4288,7 @@
           <a:p>
             <a:fld id="{030FFF5C-2D96-4D39-AE5C-E4AC30C80AB5}" type="datetimeFigureOut">
               <a:rPr lang="en-US" smtClean="0"/>
-              <a:t>10/1/2026</a:t>
+              <a:t>10/2/2026</a:t>
             </a:fld>
             <a:endParaRPr lang="en-US"/>
           </a:p>
@@ -4559,7 +4553,7 @@
           <a:p>
             <a:fld id="{030FFF5C-2D96-4D39-AE5C-E4AC30C80AB5}" type="datetimeFigureOut">
               <a:rPr lang="en-US" smtClean="0"/>
-              <a:t>10/1/2026</a:t>
+              <a:t>10/2/2026</a:t>
             </a:fld>
             <a:endParaRPr lang="en-US"/>
           </a:p>
@@ -4971,7 +4965,7 @@
           <a:p>
             <a:fld id="{030FFF5C-2D96-4D39-AE5C-E4AC30C80AB5}" type="datetimeFigureOut">
               <a:rPr lang="en-US" smtClean="0"/>
-              <a:t>10/1/2026</a:t>
+              <a:t>10/2/2026</a:t>
             </a:fld>
             <a:endParaRPr lang="en-US"/>
           </a:p>
@@ -5112,7 +5106,7 @@
           <a:p>
             <a:fld id="{030FFF5C-2D96-4D39-AE5C-E4AC30C80AB5}" type="datetimeFigureOut">
               <a:rPr lang="en-US" smtClean="0"/>
-              <a:t>10/1/2026</a:t>
+              <a:t>10/2/2026</a:t>
             </a:fld>
             <a:endParaRPr lang="en-US"/>
           </a:p>
@@ -5225,7 +5219,7 @@
           <a:p>
             <a:fld id="{030FFF5C-2D96-4D39-AE5C-E4AC30C80AB5}" type="datetimeFigureOut">
               <a:rPr lang="en-US" smtClean="0"/>
-              <a:t>10/1/2026</a:t>
+              <a:t>10/2/2026</a:t>
             </a:fld>
             <a:endParaRPr lang="en-US"/>
           </a:p>
@@ -5536,7 +5530,7 @@
           <a:p>
             <a:fld id="{030FFF5C-2D96-4D39-AE5C-E4AC30C80AB5}" type="datetimeFigureOut">
               <a:rPr lang="en-US" smtClean="0"/>
-              <a:t>10/1/2026</a:t>
+              <a:t>10/2/2026</a:t>
             </a:fld>
             <a:endParaRPr lang="en-US"/>
           </a:p>
@@ -5824,7 +5818,7 @@
           <a:p>
             <a:fld id="{030FFF5C-2D96-4D39-AE5C-E4AC30C80AB5}" type="datetimeFigureOut">
               <a:rPr lang="en-US" smtClean="0"/>
-              <a:t>10/1/2026</a:t>
+              <a:t>10/2/2026</a:t>
             </a:fld>
             <a:endParaRPr lang="en-US"/>
           </a:p>
@@ -6065,7 +6059,7 @@
           <a:p>
             <a:fld id="{030FFF5C-2D96-4D39-AE5C-E4AC30C80AB5}" type="datetimeFigureOut">
               <a:rPr lang="en-US" smtClean="0"/>
-              <a:t>10/1/2026</a:t>
+              <a:t>10/2/2026</a:t>
             </a:fld>
             <a:endParaRPr lang="en-US"/>
           </a:p>
@@ -6587,7 +6581,7 @@
 </file>
 
 <file path=ppt/slides/slide10.xml><?xml version="1.0" encoding="utf-8"?>
-<p:sld xmlns:a="http://schemas.openxmlformats.org/drawingml/2006/main" xmlns:p="http://schemas.openxmlformats.org/presentationml/2006/main" xmlns:r="http://schemas.openxmlformats.org/officeDocument/2006/relationships">
+<p:sld xmlns:a="http://schemas.openxmlformats.org/drawingml/2006/main" xmlns:r="http://schemas.openxmlformats.org/officeDocument/2006/relationships" xmlns:p="http://schemas.openxmlformats.org/presentationml/2006/main">
   <p:cSld>
     <p:spTree>
       <p:nvGrpSpPr>
@@ -6595,7 +6589,14 @@
         <p:cNvGrpSpPr/>
         <p:nvPr/>
       </p:nvGrpSpPr>
-      <p:grpSpPr/>
+      <p:grpSpPr>
+        <a:xfrm>
+          <a:off x="0" y="0"/>
+          <a:ext cx="0" cy="0"/>
+          <a:chOff x="0" y="0"/>
+          <a:chExt cx="0" cy="0"/>
+        </a:xfrm>
+      </p:grpSpPr>
       <p:sp>
         <p:nvSpPr>
           <p:cNvPr id="2" name="Title 1"/>
@@ -6638,7 +6639,6 @@
           <a:bodyPr/>
           <a:lstStyle/>
           <a:p>
-            <a:pPr/>
             <a:r>
               <a:rPr sz="2400"/>
               <a:t>① バブル領域を外すと 19.0σ → 5.0σ に落ちる</a:t>
@@ -6652,7 +6652,6 @@
             </a:r>
           </a:p>
           <a:p>
-            <a:pPr/>
             <a:r>
               <a:rPr sz="2400"/>
               <a:t>② 何も無い空でも、最大 4.5σ が出る</a:t>
@@ -6666,7 +6665,6 @@
             </a:r>
           </a:p>
           <a:p>
-            <a:pPr/>
             <a:r>
               <a:rPr sz="2400"/>
               <a:t>③ 7/23 に出した 19.1σ が再現できない</a:t>
@@ -6680,7 +6678,6 @@
             </a:r>
           </a:p>
           <a:p>
-            <a:pPr/>
             <a:r>
               <a:rPr sz="2400"/>
               <a:t>→ 次から、1 つずつ調べた結果</a:t>
@@ -6697,7 +6694,7 @@
 </file>
 
 <file path=ppt/slides/slide11.xml><?xml version="1.0" encoding="utf-8"?>
-<p:sld xmlns:a="http://schemas.openxmlformats.org/drawingml/2006/main" xmlns:p="http://schemas.openxmlformats.org/presentationml/2006/main" xmlns:r="http://schemas.openxmlformats.org/officeDocument/2006/relationships">
+<p:sld xmlns:a="http://schemas.openxmlformats.org/drawingml/2006/main" xmlns:r="http://schemas.openxmlformats.org/officeDocument/2006/relationships" xmlns:p="http://schemas.openxmlformats.org/presentationml/2006/main">
   <p:cSld>
     <p:spTree>
       <p:nvGrpSpPr>
@@ -6705,7 +6702,14 @@
         <p:cNvGrpSpPr/>
         <p:nvPr/>
       </p:nvGrpSpPr>
-      <p:grpSpPr/>
+      <p:grpSpPr>
+        <a:xfrm>
+          <a:off x="0" y="0"/>
+          <a:ext cx="0" cy="0"/>
+          <a:chOff x="0" y="0"/>
+          <a:chExt cx="0" cy="0"/>
+        </a:xfrm>
+      </p:grpSpPr>
       <p:sp>
         <p:nvSpPr>
           <p:cNvPr id="2" name="Title 1"/>
@@ -6748,14 +6752,12 @@
           <a:bodyPr/>
           <a:lstStyle/>
           <a:p>
-            <a:pPr/>
             <a:r>
               <a:rPr sz="2200"/>
               <a:t>フィッシャー情報：データがパラメータをどれだけ決められるか</a:t>
             </a:r>
           </a:p>
           <a:p>
-            <a:pPr/>
             <a:r>
               <a:rPr sz="2200"/>
               <a:t>ICS など他の成分では説明できない「ハローだけの手がかり」を、空の場所ごとに計算</a:t>
@@ -6769,21 +6771,18 @@
             </a:r>
           </a:p>
           <a:p>
-            <a:pPr/>
             <a:r>
               <a:rPr sz="2200"/>
               <a:t>手がかりの減り方だけで予測すると 6.4σ、実測 5.0σ</a:t>
             </a:r>
           </a:p>
           <a:p>
-            <a:pPr/>
             <a:r>
               <a:rPr sz="2200"/>
               <a:t>同じ形の領域を横にずらして外すと 13〜16σ（予測とも一致）</a:t>
             </a:r>
           </a:p>
           <a:p>
-            <a:pPr/>
             <a:r>
               <a:rPr sz="2200"/>
               <a:t>→ 19 → 5σ は「手がかりを捨てた」から。汚染の証拠ではない</a:t>
@@ -6800,7 +6799,7 @@
 </file>
 
 <file path=ppt/slides/slide12.xml><?xml version="1.0" encoding="utf-8"?>
-<p:sld xmlns:a="http://schemas.openxmlformats.org/drawingml/2006/main" xmlns:p="http://schemas.openxmlformats.org/presentationml/2006/main" xmlns:r="http://schemas.openxmlformats.org/officeDocument/2006/relationships">
+<p:sld xmlns:a="http://schemas.openxmlformats.org/drawingml/2006/main" xmlns:r="http://schemas.openxmlformats.org/officeDocument/2006/relationships" xmlns:p="http://schemas.openxmlformats.org/presentationml/2006/main">
   <p:cSld>
     <p:spTree>
       <p:nvGrpSpPr>
@@ -6808,7 +6807,14 @@
         <p:cNvGrpSpPr/>
         <p:nvPr/>
       </p:nvGrpSpPr>
-      <p:grpSpPr/>
+      <p:grpSpPr>
+        <a:xfrm>
+          <a:off x="0" y="0"/>
+          <a:ext cx="0" cy="0"/>
+          <a:chOff x="0" y="0"/>
+          <a:chExt cx="0" cy="0"/>
+        </a:xfrm>
+      </p:grpSpPr>
       <p:sp>
         <p:nvSpPr>
           <p:cNvPr id="2" name="Title 1"/>
@@ -6851,7 +6857,6 @@
           <a:bodyPr/>
           <a:lstStyle/>
           <a:p>
-            <a:pPr/>
             <a:r>
               <a:rPr sz="2200"/>
               <a:t>ICS をバブルの内と外で別々の明るさにして当てはめた</a:t>
@@ -6865,7 +6870,6 @@
             </a:r>
           </a:p>
           <a:p>
-            <a:pPr/>
             <a:r>
               <a:rPr sz="2200"/>
               <a:t>ICS の計算の近似（等方近似）を直しても 1.1〜1.3 倍</a:t>
@@ -6879,7 +6883,6 @@
             </a:r>
           </a:p>
           <a:p>
-            <a:pPr/>
             <a:r>
               <a:rPr sz="2200"/>
               <a:t>ICS を 3 種類に分けて、それぞれ自由に動かしても</a:t>
@@ -6893,7 +6896,6 @@
             </a:r>
           </a:p>
           <a:p>
-            <a:pPr/>
             <a:r>
               <a:rPr sz="2200"/>
               <a:t>→ ICS の「明るさ」の間違いでは、ハローを説明できない</a:t>
@@ -6930,7 +6932,7 @@
           <a:lstStyle/>
           <a:p>
             <a:r>
-              <a:rPr lang="en-US" b="1" sz="1400"/>
+              <a:rPr lang="en-US" sz="1400" b="1"/>
               <a:t>Reference:</a:t>
             </a:r>
             <a:r>
@@ -6950,7 +6952,7 @@
 </file>
 
 <file path=ppt/slides/slide13.xml><?xml version="1.0" encoding="utf-8"?>
-<p:sld xmlns:a="http://schemas.openxmlformats.org/drawingml/2006/main" xmlns:p="http://schemas.openxmlformats.org/presentationml/2006/main" xmlns:r="http://schemas.openxmlformats.org/officeDocument/2006/relationships">
+<p:sld xmlns:a="http://schemas.openxmlformats.org/drawingml/2006/main" xmlns:r="http://schemas.openxmlformats.org/officeDocument/2006/relationships" xmlns:p="http://schemas.openxmlformats.org/presentationml/2006/main">
   <p:cSld>
     <p:spTree>
       <p:nvGrpSpPr>
@@ -6958,7 +6960,14 @@
         <p:cNvGrpSpPr/>
         <p:nvPr/>
       </p:nvGrpSpPr>
-      <p:grpSpPr/>
+      <p:grpSpPr>
+        <a:xfrm>
+          <a:off x="0" y="0"/>
+          <a:ext cx="0" cy="0"/>
+          <a:chOff x="0" y="0"/>
+          <a:chExt cx="0" cy="0"/>
+        </a:xfrm>
+      </p:grpSpPr>
       <p:sp>
         <p:nvSpPr>
           <p:cNvPr id="2" name="Title 1"/>
@@ -7001,14 +7010,12 @@
           <a:bodyPr/>
           <a:lstStyle/>
           <a:p>
-            <a:pPr/>
             <a:r>
               <a:rPr sz="2200"/>
               <a:t>何も無い空 23 か所で、天の川と同じ解析をした</a:t>
             </a:r>
           </a:p>
           <a:p>
-            <a:pPr/>
             <a:r>
               <a:rPr sz="2200"/>
               <a:t>本物の信号が無ければ、σ は「平均 0、ばらつき 1」になるはず</a:t>
@@ -7022,7 +7029,6 @@
             </a:r>
           </a:p>
           <a:p>
-            <a:pPr/>
             <a:r>
               <a:rPr sz="2200"/>
               <a:t>実際のばらつき：1.26（95% 区間 1.14–1.39）</a:t>
@@ -7036,7 +7042,6 @@
             </a:r>
           </a:p>
           <a:p>
-            <a:pPr/>
             <a:r>
               <a:rPr sz="2200"/>
               <a:t>19.0σ を較正すると 19.0 ÷ 1.26 ≈ 15σ（13.7–16.6σ）</a:t>
@@ -7073,7 +7078,7 @@
           <a:lstStyle/>
           <a:p>
             <a:r>
-              <a:rPr lang="en-US" b="1" sz="1400"/>
+              <a:rPr lang="en-US" sz="1400" b="1"/>
               <a:t>Reference:</a:t>
             </a:r>
             <a:r>
@@ -7093,7 +7098,7 @@
 </file>
 
 <file path=ppt/slides/slide14.xml><?xml version="1.0" encoding="utf-8"?>
-<p:sld xmlns:a="http://schemas.openxmlformats.org/drawingml/2006/main" xmlns:p="http://schemas.openxmlformats.org/presentationml/2006/main" xmlns:r="http://schemas.openxmlformats.org/officeDocument/2006/relationships">
+<p:sld xmlns:a="http://schemas.openxmlformats.org/drawingml/2006/main" xmlns:r="http://schemas.openxmlformats.org/officeDocument/2006/relationships" xmlns:p="http://schemas.openxmlformats.org/presentationml/2006/main">
   <p:cSld>
     <p:spTree>
       <p:nvGrpSpPr>
@@ -7101,7 +7106,14 @@
         <p:cNvGrpSpPr/>
         <p:nvPr/>
       </p:nvGrpSpPr>
-      <p:grpSpPr/>
+      <p:grpSpPr>
+        <a:xfrm>
+          <a:off x="0" y="0"/>
+          <a:ext cx="0" cy="0"/>
+          <a:chOff x="0" y="0"/>
+          <a:chExt cx="0" cy="0"/>
+        </a:xfrm>
+      </p:grpSpPr>
       <p:sp>
         <p:nvSpPr>
           <p:cNvPr id="2" name="Title 1"/>
@@ -7133,7 +7145,7 @@
           <p:nvPr/>
         </p:nvPicPr>
         <p:blipFill>
-          <a:blip r:embed="rId2"/>
+          <a:blip r:embed="rId3"/>
           <a:stretch>
             <a:fillRect/>
           </a:stretch>
@@ -7186,7 +7198,7 @@
 </file>
 
 <file path=ppt/slides/slide15.xml><?xml version="1.0" encoding="utf-8"?>
-<p:sld xmlns:a="http://schemas.openxmlformats.org/drawingml/2006/main" xmlns:p="http://schemas.openxmlformats.org/presentationml/2006/main" xmlns:r="http://schemas.openxmlformats.org/officeDocument/2006/relationships">
+<p:sld xmlns:a="http://schemas.openxmlformats.org/drawingml/2006/main" xmlns:r="http://schemas.openxmlformats.org/officeDocument/2006/relationships" xmlns:p="http://schemas.openxmlformats.org/presentationml/2006/main">
   <p:cSld>
     <p:spTree>
       <p:nvGrpSpPr>
@@ -7194,7 +7206,14 @@
         <p:cNvGrpSpPr/>
         <p:nvPr/>
       </p:nvGrpSpPr>
-      <p:grpSpPr/>
+      <p:grpSpPr>
+        <a:xfrm>
+          <a:off x="0" y="0"/>
+          <a:ext cx="0" cy="0"/>
+          <a:chOff x="0" y="0"/>
+          <a:chExt cx="0" cy="0"/>
+        </a:xfrm>
+      </p:grpSpPr>
       <p:sp>
         <p:nvSpPr>
           <p:cNvPr id="2" name="Title 1"/>
@@ -7237,28 +7256,24 @@
           <a:bodyPr/>
           <a:lstStyle/>
           <a:p>
-            <a:pPr/>
             <a:r>
               <a:rPr sz="2400"/>
               <a:t>7/23 の計算の直後にコードを直していて、当時の状態が残っていなかった</a:t>
             </a:r>
           </a:p>
           <a:p>
-            <a:pPr/>
             <a:r>
               <a:rPr sz="2400"/>
               <a:t>今のコードは、何度計算しても同じ答えになる（10/1 に確認）</a:t>
             </a:r>
           </a:p>
           <a:p>
-            <a:pPr/>
             <a:r>
               <a:rPr sz="2400"/>
               <a:t>結果ファイルに、コードの版と設定を自動で記録するようにした</a:t>
             </a:r>
           </a:p>
           <a:p>
-            <a:pPr/>
             <a:r>
               <a:rPr sz="2400"/>
               <a:t>→ 主結果を 19.0σ（10/1 の再計算）に統一</a:t>
@@ -7275,7 +7290,7 @@
 </file>
 
 <file path=ppt/slides/slide16.xml><?xml version="1.0" encoding="utf-8"?>
-<p:sld xmlns:a="http://schemas.openxmlformats.org/drawingml/2006/main" xmlns:p="http://schemas.openxmlformats.org/presentationml/2006/main" xmlns:r="http://schemas.openxmlformats.org/officeDocument/2006/relationships">
+<p:sld xmlns:a="http://schemas.openxmlformats.org/drawingml/2006/main" xmlns:r="http://schemas.openxmlformats.org/officeDocument/2006/relationships" xmlns:p="http://schemas.openxmlformats.org/presentationml/2006/main">
   <p:cSld>
     <p:spTree>
       <p:nvGrpSpPr>
@@ -7283,7 +7298,14 @@
         <p:cNvGrpSpPr/>
         <p:nvPr/>
       </p:nvGrpSpPr>
-      <p:grpSpPr/>
+      <p:grpSpPr>
+        <a:xfrm>
+          <a:off x="0" y="0"/>
+          <a:ext cx="0" cy="0"/>
+          <a:chOff x="0" y="0"/>
+          <a:chExt cx="0" cy="0"/>
+        </a:xfrm>
+      </p:grpSpPr>
       <p:sp>
         <p:nvSpPr>
           <p:cNvPr id="2" name="Title 1"/>
@@ -7326,21 +7348,18 @@
           <a:bodyPr/>
           <a:lstStyle/>
           <a:p>
-            <a:pPr/>
             <a:r>
               <a:rPr sz="2400"/>
               <a:t>ICS の明るさ・バブル・計算の近似の間違いでは、超過を説明できない</a:t>
             </a:r>
           </a:p>
           <a:p>
-            <a:pPr/>
             <a:r>
               <a:rPr sz="2400"/>
               <a:t>σ は 1.26 倍の過大評価 → 較正すると約 15σ</a:t>
             </a:r>
           </a:p>
           <a:p>
-            <a:pPr/>
             <a:r>
               <a:rPr sz="2400"/>
               <a:t>ただし、暗黒物質の証拠ではない</a:t>
@@ -7354,7 +7373,6 @@
             </a:r>
           </a:p>
           <a:p>
-            <a:pPr/>
             <a:r>
               <a:rPr sz="2400"/>
               <a:t>→ 独立な確認として、矮小銀河を見る</a:t>
@@ -7371,7 +7389,7 @@
 </file>
 
 <file path=ppt/slides/slide17.xml><?xml version="1.0" encoding="utf-8"?>
-<p:sld xmlns:a="http://schemas.openxmlformats.org/drawingml/2006/main" xmlns:p="http://schemas.openxmlformats.org/presentationml/2006/main" xmlns:r="http://schemas.openxmlformats.org/officeDocument/2006/relationships">
+<p:sld xmlns:a="http://schemas.openxmlformats.org/drawingml/2006/main" xmlns:r="http://schemas.openxmlformats.org/officeDocument/2006/relationships" xmlns:p="http://schemas.openxmlformats.org/presentationml/2006/main">
   <p:cSld>
     <p:spTree>
       <p:nvGrpSpPr>
@@ -7379,7 +7397,14 @@
         <p:cNvGrpSpPr/>
         <p:nvPr/>
       </p:nvGrpSpPr>
-      <p:grpSpPr/>
+      <p:grpSpPr>
+        <a:xfrm>
+          <a:off x="0" y="0"/>
+          <a:ext cx="0" cy="0"/>
+          <a:chOff x="0" y="0"/>
+          <a:chExt cx="0" cy="0"/>
+        </a:xfrm>
+      </p:grpSpPr>
       <p:sp>
         <p:nvSpPr>
           <p:cNvPr id="2" name="Title 1"/>
@@ -7422,7 +7447,6 @@
           <a:bodyPr/>
           <a:lstStyle/>
           <a:p>
-            <a:pPr/>
             <a:r>
               <a:rPr sz="2400"/>
               <a:t>矮小銀河：天の川のまわりの小さな銀河</a:t>
@@ -7436,14 +7460,12 @@
             </a:r>
           </a:p>
           <a:p>
-            <a:pPr/>
             <a:r>
               <a:rPr sz="2400"/>
               <a:t>暗黒物質なら、矮小銀河からも同じ 20 GeV の光が来るはず</a:t>
             </a:r>
           </a:p>
           <a:p>
-            <a:pPr/>
             <a:r>
               <a:rPr sz="2400"/>
               <a:t>同じ手法を、各天体のまわり半径 10° に使った</a:t>
@@ -7457,7 +7479,6 @@
             </a:r>
           </a:p>
           <a:p>
-            <a:pPr/>
             <a:r>
               <a:rPr sz="2400"/>
               <a:t>矮小銀河は小さい（0.2〜0.4°）ので、広がった ICS とは縮退しない</a:t>
@@ -7494,7 +7515,7 @@
           <a:lstStyle/>
           <a:p>
             <a:r>
-              <a:rPr lang="en-US" b="1" sz="1400"/>
+              <a:rPr lang="en-US" sz="1400" b="1"/>
               <a:t>Reference:</a:t>
             </a:r>
             <a:r>
@@ -7514,7 +7535,7 @@
 </file>
 
 <file path=ppt/slides/slide18.xml><?xml version="1.0" encoding="utf-8"?>
-<p:sld xmlns:a="http://schemas.openxmlformats.org/drawingml/2006/main" xmlns:p="http://schemas.openxmlformats.org/presentationml/2006/main" xmlns:r="http://schemas.openxmlformats.org/officeDocument/2006/relationships">
+<p:sld xmlns:a="http://schemas.openxmlformats.org/drawingml/2006/main" xmlns:r="http://schemas.openxmlformats.org/officeDocument/2006/relationships" xmlns:p="http://schemas.openxmlformats.org/presentationml/2006/main">
   <p:cSld>
     <p:spTree>
       <p:nvGrpSpPr>
@@ -7522,7 +7543,14 @@
         <p:cNvGrpSpPr/>
         <p:nvPr/>
       </p:nvGrpSpPr>
-      <p:grpSpPr/>
+      <p:grpSpPr>
+        <a:xfrm>
+          <a:off x="0" y="0"/>
+          <a:ext cx="0" cy="0"/>
+          <a:chOff x="0" y="0"/>
+          <a:chExt cx="0" cy="0"/>
+        </a:xfrm>
+      </p:grpSpPr>
       <p:sp>
         <p:nvSpPr>
           <p:cNvPr id="2" name="Title 1"/>
@@ -7565,21 +7593,18 @@
           <a:bodyPr/>
           <a:lstStyle/>
           <a:p>
-            <a:pPr/>
             <a:r>
               <a:rPr sz="2400"/>
               <a:t>対消滅の明るさ：F = ⟨σv⟩ / (8π m²) × dN/dE × J</a:t>
             </a:r>
           </a:p>
           <a:p>
-            <a:pPr/>
             <a:r>
               <a:rPr sz="2400"/>
               <a:t>J ファクター = 暗黒物質の密度の 2 乗を、視線方向に足し合わせた量</a:t>
             </a:r>
           </a:p>
           <a:p>
-            <a:pPr/>
             <a:r>
               <a:rPr sz="2400"/>
               <a:t>天の川と矮小銀河で粒子は同じ → 比をとると J の比だけが残る</a:t>
@@ -7593,14 +7618,12 @@
             </a:r>
           </a:p>
           <a:p>
-            <a:pPr/>
             <a:r>
               <a:rPr sz="2400"/>
               <a:t>粒子の質量などを仮定せずに「何σ見えるはずか」が出る</a:t>
             </a:r>
           </a:p>
           <a:p>
-            <a:pPr/>
             <a:r>
               <a:rPr sz="2400"/>
               <a:t>矮小銀河の J は、星の動きから推定する</a:t>
@@ -7637,7 +7660,7 @@
           <a:lstStyle/>
           <a:p>
             <a:r>
-              <a:rPr lang="en-US" b="1" sz="1400"/>
+              <a:rPr lang="en-US" sz="1400" b="1"/>
               <a:t>Reference:</a:t>
             </a:r>
             <a:r>
@@ -7657,7 +7680,7 @@
 </file>
 
 <file path=ppt/slides/slide19.xml><?xml version="1.0" encoding="utf-8"?>
-<p:sld xmlns:a="http://schemas.openxmlformats.org/drawingml/2006/main" xmlns:p="http://schemas.openxmlformats.org/presentationml/2006/main" xmlns:r="http://schemas.openxmlformats.org/officeDocument/2006/relationships">
+<p:sld xmlns:a="http://schemas.openxmlformats.org/drawingml/2006/main" xmlns:r="http://schemas.openxmlformats.org/officeDocument/2006/relationships" xmlns:p="http://schemas.openxmlformats.org/presentationml/2006/main">
   <p:cSld>
     <p:spTree>
       <p:nvGrpSpPr>
@@ -7665,7 +7688,14 @@
         <p:cNvGrpSpPr/>
         <p:nvPr/>
       </p:nvGrpSpPr>
-      <p:grpSpPr/>
+      <p:grpSpPr>
+        <a:xfrm>
+          <a:off x="0" y="0"/>
+          <a:ext cx="0" cy="0"/>
+          <a:chOff x="0" y="0"/>
+          <a:chExt cx="0" cy="0"/>
+        </a:xfrm>
+      </p:grpSpPr>
       <p:sp>
         <p:nvSpPr>
           <p:cNvPr id="2" name="Title 1"/>
@@ -7697,7 +7727,7 @@
           <p:nvPr/>
         </p:nvPicPr>
         <p:blipFill>
-          <a:blip r:embed="rId2"/>
+          <a:blip r:embed="rId3"/>
           <a:stretch>
             <a:fillRect/>
           </a:stretch>
@@ -7750,7 +7780,7 @@
 </file>
 
 <file path=ppt/slides/slide2.xml><?xml version="1.0" encoding="utf-8"?>
-<p:sld xmlns:a="http://schemas.openxmlformats.org/drawingml/2006/main" xmlns:p="http://schemas.openxmlformats.org/presentationml/2006/main" xmlns:r="http://schemas.openxmlformats.org/officeDocument/2006/relationships">
+<p:sld xmlns:a="http://schemas.openxmlformats.org/drawingml/2006/main" xmlns:r="http://schemas.openxmlformats.org/officeDocument/2006/relationships" xmlns:p="http://schemas.openxmlformats.org/presentationml/2006/main">
   <p:cSld>
     <p:spTree>
       <p:nvGrpSpPr>
@@ -7758,7 +7788,14 @@
         <p:cNvGrpSpPr/>
         <p:nvPr/>
       </p:nvGrpSpPr>
-      <p:grpSpPr/>
+      <p:grpSpPr>
+        <a:xfrm>
+          <a:off x="0" y="0"/>
+          <a:ext cx="0" cy="0"/>
+          <a:chOff x="0" y="0"/>
+          <a:chExt cx="0" cy="0"/>
+        </a:xfrm>
+      </p:grpSpPr>
       <p:sp>
         <p:nvSpPr>
           <p:cNvPr id="2" name="Title 1"/>
@@ -7775,9 +7812,10 @@
           <a:lstStyle/>
           <a:p>
             <a:r>
-              <a:rPr sz="3400"/>
-              <a:t>研究の目的</a:t>
-            </a:r>
+              <a:rPr lang="ja-JP" altLang="en-US" sz="3400" b="1"/>
+              <a:t>卒業研究の目的</a:t>
+            </a:r>
+            <a:endParaRPr sz="3400" b="1"/>
           </a:p>
         </p:txBody>
       </p:sp>
@@ -7794,25 +7832,48 @@
         <p:spPr>
           <a:xfrm>
             <a:off x="841248" y="1463040"/>
-            <a:ext cx="10515600" cy="4114800"/>
+            <a:ext cx="11089306" cy="3076876"/>
           </a:xfrm>
         </p:spPr>
         <p:txBody>
-          <a:bodyPr/>
-          <a:lstStyle/>
-          <a:p>
-            <a:pPr/>
+          <a:bodyPr>
+            <a:normAutofit/>
+          </a:bodyPr>
+          <a:lstStyle/>
+          <a:p>
             <a:r>
               <a:rPr sz="2400"/>
-              <a:t>暗黒物質どうしがぶつかると消えて、ガンマ線を出すと考えられている（対消滅）</a:t>
-            </a:r>
-          </a:p>
-          <a:p>
-            <a:pPr/>
+              <a:t>暗黒物質どうしがぶつかると消えて、ガンマ線を出すと考えられている</a:t>
+            </a:r>
+            <a:endParaRPr lang="en-US" sz="2400"/>
+          </a:p>
+          <a:p>
+            <a:pPr marL="0" indent="0">
+              <a:buNone/>
+            </a:pPr>
+            <a:r>
+              <a:rPr sz="2400"/>
+              <a:t>（対消滅）</a:t>
+            </a:r>
+          </a:p>
+          <a:p>
             <a:r>
               <a:rPr sz="2400"/>
               <a:t>天の川は暗黒物質の「ハロー」に包まれている</a:t>
             </a:r>
+            <a:r>
+              <a:rPr lang="ja-JP" altLang="en-US" sz="2400"/>
+              <a:t>のではないか→（</a:t>
+            </a:r>
+            <a:r>
+              <a:rPr lang="en-US" altLang="ja-JP" sz="2400"/>
+              <a:t>NFW</a:t>
+            </a:r>
+            <a:r>
+              <a:rPr lang="ja-JP" altLang="en-US" sz="2400"/>
+              <a:t>）</a:t>
+            </a:r>
+            <a:endParaRPr sz="2400"/>
           </a:p>
           <a:p>
             <a:pPr lvl="1"/>
@@ -7822,18 +7883,32 @@
             </a:r>
           </a:p>
           <a:p>
-            <a:pPr/>
             <a:r>
               <a:rPr sz="2400"/>
               <a:t>Totani (2025)：20 GeV 付近にハロー型の超過を報告（13–19σ）</a:t>
             </a:r>
           </a:p>
           <a:p>
-            <a:pPr/>
-            <a:r>
-              <a:rPr sz="2400"/>
-              <a:t>僕の研究：これを自分で再現し、本物かどうか確かめる</a:t>
-            </a:r>
+            <a:r>
+              <a:rPr sz="2400" b="1"/>
+              <a:t>研究</a:t>
+            </a:r>
+            <a:r>
+              <a:rPr lang="ja-JP" altLang="en-US" sz="2400" b="1"/>
+              <a:t>卒業</a:t>
+            </a:r>
+            <a:r>
+              <a:rPr sz="2400" b="1"/>
+              <a:t>：これを自分で再現し、本物かどうか確かめる</a:t>
+            </a:r>
+            <a:endParaRPr lang="en-US" sz="2400" b="1"/>
+          </a:p>
+          <a:p>
+            <a:r>
+              <a:rPr lang="ja-JP" altLang="en-US" sz="2400" b="1"/>
+              <a:t>　　　→矮小銀河やほかの銀河にも適用したらどうなるか（拡張要素の原案）</a:t>
+            </a:r>
+            <a:endParaRPr sz="2400" b="1"/>
           </a:p>
         </p:txBody>
       </p:sp>
@@ -7866,7 +7941,7 @@
           <a:lstStyle/>
           <a:p>
             <a:r>
-              <a:rPr lang="en-US" b="1" sz="1400"/>
+              <a:rPr lang="en-US" sz="1400" b="1"/>
               <a:t>Reference:</a:t>
             </a:r>
             <a:r>
@@ -7886,7 +7961,7 @@
 </file>
 
 <file path=ppt/slides/slide20.xml><?xml version="1.0" encoding="utf-8"?>
-<p:sld xmlns:a="http://schemas.openxmlformats.org/drawingml/2006/main" xmlns:p="http://schemas.openxmlformats.org/presentationml/2006/main" xmlns:r="http://schemas.openxmlformats.org/officeDocument/2006/relationships">
+<p:sld xmlns:a="http://schemas.openxmlformats.org/drawingml/2006/main" xmlns:r="http://schemas.openxmlformats.org/officeDocument/2006/relationships" xmlns:p="http://schemas.openxmlformats.org/presentationml/2006/main">
   <p:cSld>
     <p:spTree>
       <p:nvGrpSpPr>
@@ -7894,7 +7969,14 @@
         <p:cNvGrpSpPr/>
         <p:nvPr/>
       </p:nvGrpSpPr>
-      <p:grpSpPr/>
+      <p:grpSpPr>
+        <a:xfrm>
+          <a:off x="0" y="0"/>
+          <a:ext cx="0" cy="0"/>
+          <a:chOff x="0" y="0"/>
+          <a:chExt cx="0" cy="0"/>
+        </a:xfrm>
+      </p:grpSpPr>
       <p:sp>
         <p:nvSpPr>
           <p:cNvPr id="2" name="Title 1"/>
@@ -7937,14 +8019,12 @@
           <a:bodyPr/>
           <a:lstStyle/>
           <a:p>
-            <a:pPr/>
             <a:r>
               <a:rPr sz="2400"/>
               <a:t>1 個ずつでは弱いので、J が求まる 43 天体をまとめる</a:t>
             </a:r>
           </a:p>
           <a:p>
-            <a:pPr/>
             <a:r>
               <a:rPr sz="2400"/>
               <a:t>T = Σ w_i z_i / √( Σ w_i² )、重み w_i = 天体 i の予測 σ</a:t>
@@ -7958,28 +8038,24 @@
             </a:r>
           </a:p>
           <a:p>
-            <a:pPr/>
             <a:r>
               <a:rPr sz="2400"/>
               <a:t>暗黒物質が無ければ：T は平均 0、ばらつき 1</a:t>
             </a:r>
           </a:p>
           <a:p>
-            <a:pPr/>
             <a:r>
               <a:rPr sz="2400"/>
               <a:t>暗黒物質があれば：T の平均 = √( Σ pred_i² ) = 1.73</a:t>
             </a:r>
           </a:p>
           <a:p>
-            <a:pPr/>
             <a:r>
               <a:rPr sz="2400"/>
               <a:t>実測 T = 0.39 → ずれ 1.3σ</a:t>
             </a:r>
           </a:p>
           <a:p>
-            <a:pPr/>
             <a:r>
               <a:rPr sz="2400"/>
               <a:t>ただし、ここでは J に誤差は無いとしていた</a:t>
@@ -7996,7 +8072,7 @@
 </file>
 
 <file path=ppt/slides/slide21.xml><?xml version="1.0" encoding="utf-8"?>
-<p:sld xmlns:a="http://schemas.openxmlformats.org/drawingml/2006/main" xmlns:p="http://schemas.openxmlformats.org/presentationml/2006/main" xmlns:r="http://schemas.openxmlformats.org/officeDocument/2006/relationships">
+<p:sld xmlns:a="http://schemas.openxmlformats.org/drawingml/2006/main" xmlns:r="http://schemas.openxmlformats.org/officeDocument/2006/relationships" xmlns:p="http://schemas.openxmlformats.org/presentationml/2006/main">
   <p:cSld>
     <p:spTree>
       <p:nvGrpSpPr>
@@ -8004,7 +8080,14 @@
         <p:cNvGrpSpPr/>
         <p:nvPr/>
       </p:nvGrpSpPr>
-      <p:grpSpPr/>
+      <p:grpSpPr>
+        <a:xfrm>
+          <a:off x="0" y="0"/>
+          <a:ext cx="0" cy="0"/>
+          <a:chOff x="0" y="0"/>
+          <a:chExt cx="0" cy="0"/>
+        </a:xfrm>
+      </p:grpSpPr>
       <p:sp>
         <p:nvSpPr>
           <p:cNvPr id="2" name="Title 1"/>
@@ -8047,14 +8130,12 @@
           <a:bodyPr/>
           <a:lstStyle/>
           <a:p>
-            <a:pPr/>
             <a:r>
               <a:rPr sz="2400"/>
               <a:t>文献ごとの J の値は、書かれた誤差よりも大きくばらつく</a:t>
             </a:r>
           </a:p>
           <a:p>
-            <a:pPr/>
             <a:r>
               <a:rPr sz="2400"/>
               <a:t>見落とされがちな誤差の原因（8 つ）</a:t>
@@ -8082,7 +8163,6 @@
             </a:r>
           </a:p>
           <a:p>
-            <a:pPr/>
             <a:r>
               <a:rPr sz="2400"/>
               <a:t>Δlog₁₀J ≈ 0.5（約 3 倍）以上の誤差を見込むべき</a:t>
@@ -8119,7 +8199,7 @@
           <a:lstStyle/>
           <a:p>
             <a:r>
-              <a:rPr lang="en-US" b="1" sz="1400"/>
+              <a:rPr lang="en-US" sz="1400" b="1"/>
               <a:t>Reference:</a:t>
             </a:r>
             <a:r>
@@ -8139,7 +8219,7 @@
 </file>
 
 <file path=ppt/slides/slide22.xml><?xml version="1.0" encoding="utf-8"?>
-<p:sld xmlns:a="http://schemas.openxmlformats.org/drawingml/2006/main" xmlns:p="http://schemas.openxmlformats.org/presentationml/2006/main" xmlns:r="http://schemas.openxmlformats.org/officeDocument/2006/relationships">
+<p:sld xmlns:a="http://schemas.openxmlformats.org/drawingml/2006/main" xmlns:r="http://schemas.openxmlformats.org/officeDocument/2006/relationships" xmlns:p="http://schemas.openxmlformats.org/presentationml/2006/main">
   <p:cSld>
     <p:spTree>
       <p:nvGrpSpPr>
@@ -8147,7 +8227,14 @@
         <p:cNvGrpSpPr/>
         <p:nvPr/>
       </p:nvGrpSpPr>
-      <p:grpSpPr/>
+      <p:grpSpPr>
+        <a:xfrm>
+          <a:off x="0" y="0"/>
+          <a:ext cx="0" cy="0"/>
+          <a:chOff x="0" y="0"/>
+          <a:chExt cx="0" cy="0"/>
+        </a:xfrm>
+      </p:grpSpPr>
       <p:sp>
         <p:nvSpPr>
           <p:cNvPr id="2" name="Title 1"/>
@@ -8190,7 +8277,6 @@
           <a:bodyPr/>
           <a:lstStyle/>
           <a:p>
-            <a:pPr/>
             <a:r>
               <a:rPr sz="2200"/>
               <a:t>Fermi-LAT の観測を計算機の中で作る（FermiTools、fermipy）</a:t>
@@ -8204,14 +8290,12 @@
             </a:r>
           </a:p>
           <a:p>
-            <a:pPr/>
             <a:r>
               <a:rPr sz="2200"/>
               <a:t>背景：銀河の拡散光＋等方の光から、ポアソン乱数で光子を作る</a:t>
             </a:r>
           </a:p>
           <a:p>
-            <a:pPr/>
             <a:r>
               <a:rPr sz="2200"/>
               <a:t>暗黒物質の信号を入れる</a:t>
@@ -8232,7 +8316,6 @@
             </a:r>
           </a:p>
           <a:p>
-            <a:pPr/>
             <a:r>
               <a:rPr sz="2200"/>
               <a:t>対象：Ursa Minor 1 個と、27 個の矮小銀河</a:t>
@@ -8269,7 +8352,7 @@
           <a:lstStyle/>
           <a:p>
             <a:r>
-              <a:rPr lang="en-US" b="1" sz="1400"/>
+              <a:rPr lang="en-US" sz="1400" b="1"/>
               <a:t>Reference:</a:t>
             </a:r>
             <a:r>
@@ -8289,7 +8372,7 @@
 </file>
 
 <file path=ppt/slides/slide23.xml><?xml version="1.0" encoding="utf-8"?>
-<p:sld xmlns:a="http://schemas.openxmlformats.org/drawingml/2006/main" xmlns:p="http://schemas.openxmlformats.org/presentationml/2006/main" xmlns:r="http://schemas.openxmlformats.org/officeDocument/2006/relationships">
+<p:sld xmlns:a="http://schemas.openxmlformats.org/drawingml/2006/main" xmlns:r="http://schemas.openxmlformats.org/officeDocument/2006/relationships" xmlns:p="http://schemas.openxmlformats.org/presentationml/2006/main">
   <p:cSld>
     <p:spTree>
       <p:nvGrpSpPr>
@@ -8297,7 +8380,14 @@
         <p:cNvGrpSpPr/>
         <p:nvPr/>
       </p:nvGrpSpPr>
-      <p:grpSpPr/>
+      <p:grpSpPr>
+        <a:xfrm>
+          <a:off x="0" y="0"/>
+          <a:ext cx="0" cy="0"/>
+          <a:chOff x="0" y="0"/>
+          <a:chExt cx="0" cy="0"/>
+        </a:xfrm>
+      </p:grpSpPr>
       <p:sp>
         <p:nvSpPr>
           <p:cNvPr id="2" name="Title 1"/>
@@ -8340,7 +8430,6 @@
           <a:bodyPr/>
           <a:lstStyle/>
           <a:p>
-            <a:pPr/>
             <a:r>
               <a:rPr sz="2200"/>
               <a:t>各天体の尤度 = 光子のポアソン尤度 × J の尤度</a:t>
@@ -8354,14 +8443,12 @@
             </a:r>
           </a:p>
           <a:p>
-            <a:pPr/>
             <a:r>
               <a:rPr sz="2200"/>
               <a:t>27 個は尤度の積でまとめる（⟨σv⟩ は共通、J は天体ごと）</a:t>
             </a:r>
           </a:p>
           <a:p>
-            <a:pPr/>
             <a:r>
               <a:rPr sz="2200"/>
               <a:t>2 つの誤差を分けて動かす</a:t>
@@ -8382,7 +8469,6 @@
             </a:r>
           </a:p>
           <a:p>
-            <a:pPr/>
             <a:r>
               <a:rPr sz="2200"/>
               <a:t>95% 上限：TS が最大値から 2.71 下がる点（Wilks の定理を仮定）</a:t>
@@ -8419,7 +8505,7 @@
           <a:lstStyle/>
           <a:p>
             <a:r>
-              <a:rPr lang="en-US" b="1" sz="1400"/>
+              <a:rPr lang="en-US" sz="1400" b="1"/>
               <a:t>Reference:</a:t>
             </a:r>
             <a:r>
@@ -8439,7 +8525,7 @@
 </file>
 
 <file path=ppt/slides/slide24.xml><?xml version="1.0" encoding="utf-8"?>
-<p:sld xmlns:a="http://schemas.openxmlformats.org/drawingml/2006/main" xmlns:p="http://schemas.openxmlformats.org/presentationml/2006/main" xmlns:r="http://schemas.openxmlformats.org/officeDocument/2006/relationships">
+<p:sld xmlns:a="http://schemas.openxmlformats.org/drawingml/2006/main" xmlns:r="http://schemas.openxmlformats.org/officeDocument/2006/relationships" xmlns:p="http://schemas.openxmlformats.org/presentationml/2006/main">
   <p:cSld>
     <p:spTree>
       <p:nvGrpSpPr>
@@ -8447,7 +8533,14 @@
         <p:cNvGrpSpPr/>
         <p:nvPr/>
       </p:nvGrpSpPr>
-      <p:grpSpPr/>
+      <p:grpSpPr>
+        <a:xfrm>
+          <a:off x="0" y="0"/>
+          <a:ext cx="0" cy="0"/>
+          <a:chOff x="0" y="0"/>
+          <a:chExt cx="0" cy="0"/>
+        </a:xfrm>
+      </p:grpSpPr>
       <p:sp>
         <p:nvSpPr>
           <p:cNvPr id="2" name="Title 1"/>
@@ -8490,7 +8583,6 @@
           <a:bodyPr/>
           <a:lstStyle/>
           <a:p>
-            <a:pPr/>
             <a:r>
               <a:rPr sz="2400"/>
               <a:t>本物の信号を入れた仮想データを何度も作る</a:t>
@@ -8504,21 +8596,18 @@
             </a:r>
           </a:p>
           <a:p>
-            <a:pPr/>
             <a:r>
               <a:rPr sz="2400"/>
               <a:t>それぞれで 95% 上限を出す</a:t>
             </a:r>
           </a:p>
           <a:p>
-            <a:pPr/>
             <a:r>
               <a:rPr sz="2400"/>
               <a:t>上限が本物の ⟨σv⟩ より下 =「本物を無いと間違えた」</a:t>
             </a:r>
           </a:p>
           <a:p>
-            <a:pPr/>
             <a:r>
               <a:rPr sz="2400"/>
               <a:t>95% 上限なら、間違いは 5% 以下のはず</a:t>
@@ -8562,7 +8651,7 @@
           <a:lstStyle/>
           <a:p>
             <a:r>
-              <a:rPr lang="en-US" b="1" sz="1400"/>
+              <a:rPr lang="en-US" sz="1400" b="1"/>
               <a:t>Reference:</a:t>
             </a:r>
             <a:r>
@@ -8582,7 +8671,7 @@
 </file>
 
 <file path=ppt/slides/slide25.xml><?xml version="1.0" encoding="utf-8"?>
-<p:sld xmlns:a="http://schemas.openxmlformats.org/drawingml/2006/main" xmlns:p="http://schemas.openxmlformats.org/presentationml/2006/main" xmlns:r="http://schemas.openxmlformats.org/officeDocument/2006/relationships">
+<p:sld xmlns:a="http://schemas.openxmlformats.org/drawingml/2006/main" xmlns:r="http://schemas.openxmlformats.org/officeDocument/2006/relationships" xmlns:p="http://schemas.openxmlformats.org/presentationml/2006/main">
   <p:cSld>
     <p:spTree>
       <p:nvGrpSpPr>
@@ -8590,7 +8679,14 @@
         <p:cNvGrpSpPr/>
         <p:nvPr/>
       </p:nvGrpSpPr>
-      <p:grpSpPr/>
+      <p:grpSpPr>
+        <a:xfrm>
+          <a:off x="0" y="0"/>
+          <a:ext cx="0" cy="0"/>
+          <a:chOff x="0" y="0"/>
+          <a:chExt cx="0" cy="0"/>
+        </a:xfrm>
+      </p:grpSpPr>
       <p:sp>
         <p:nvSpPr>
           <p:cNvPr id="2" name="Title 1"/>
@@ -8633,7 +8729,6 @@
           <a:bodyPr/>
           <a:lstStyle/>
           <a:p>
-            <a:pPr/>
             <a:r>
               <a:rPr sz="2400"/>
               <a:t>σ_L を 0.3 / 0.5 / 1.0 だけ大きくすると</a:t>
@@ -8647,7 +8742,6 @@
             </a:r>
           </a:p>
           <a:p>
-            <a:pPr/>
             <a:r>
               <a:rPr sz="2400"/>
               <a:t>本当の誤差 σ だけ大きく、σ_L は小さいままだと</a:t>
@@ -8668,7 +8762,6 @@
             </a:r>
           </a:p>
           <a:p>
-            <a:pPr/>
             <a:r>
               <a:rPr sz="2400"/>
               <a:t>形の間違い：球対称 NFW で解析 → 上限 2.4 倍厳しく</a:t>
@@ -8712,7 +8805,7 @@
           <a:lstStyle/>
           <a:p>
             <a:r>
-              <a:rPr lang="en-US" b="1" sz="1400"/>
+              <a:rPr lang="en-US" sz="1400" b="1"/>
               <a:t>Reference:</a:t>
             </a:r>
             <a:r>
@@ -8732,7 +8825,7 @@
 </file>
 
 <file path=ppt/slides/slide26.xml><?xml version="1.0" encoding="utf-8"?>
-<p:sld xmlns:a="http://schemas.openxmlformats.org/drawingml/2006/main" xmlns:p="http://schemas.openxmlformats.org/presentationml/2006/main" xmlns:r="http://schemas.openxmlformats.org/officeDocument/2006/relationships">
+<p:sld xmlns:a="http://schemas.openxmlformats.org/drawingml/2006/main" xmlns:r="http://schemas.openxmlformats.org/officeDocument/2006/relationships" xmlns:p="http://schemas.openxmlformats.org/presentationml/2006/main">
   <p:cSld>
     <p:spTree>
       <p:nvGrpSpPr>
@@ -8740,7 +8833,14 @@
         <p:cNvGrpSpPr/>
         <p:nvPr/>
       </p:nvGrpSpPr>
-      <p:grpSpPr/>
+      <p:grpSpPr>
+        <a:xfrm>
+          <a:off x="0" y="0"/>
+          <a:ext cx="0" cy="0"/>
+          <a:chOff x="0" y="0"/>
+          <a:chExt cx="0" cy="0"/>
+        </a:xfrm>
+      </p:grpSpPr>
       <p:sp>
         <p:nvSpPr>
           <p:cNvPr id="2" name="Title 1"/>
@@ -8783,14 +8883,12 @@
           <a:bodyPr/>
           <a:lstStyle/>
           <a:p>
-            <a:pPr/>
             <a:r>
               <a:rPr sz="2200"/>
               <a:t>σ_L を 0.3 / 0.5 / 1.0 → 上限 1.14 / 1.44 / 3.23 倍ゆるく</a:t>
             </a:r>
           </a:p>
           <a:p>
-            <a:pPr/>
             <a:r>
               <a:rPr sz="2200"/>
               <a:t>誤差を正しく入れても、本物を除外する割合 21%（5% のはず）</a:t>
@@ -8804,7 +8902,6 @@
             </a:r>
           </a:p>
           <a:p>
-            <a:pPr/>
             <a:r>
               <a:rPr sz="2200"/>
               <a:t>本当の誤差を 0.3 / 0.5 / 1.0 大きくすると 31% / 49% / 88%</a:t>
@@ -8818,14 +8915,12 @@
             </a:r>
           </a:p>
           <a:p>
-            <a:pPr/>
             <a:r>
               <a:rPr sz="2200"/>
               <a:t>原因：J が上に振れた天体が、上限を決めてしまう</a:t>
             </a:r>
           </a:p>
           <a:p>
-            <a:pPr/>
             <a:r>
               <a:rPr sz="2200"/>
               <a:t>対策の一つ：何も無い領域で較正する</a:t>
@@ -8862,7 +8957,7 @@
           <a:lstStyle/>
           <a:p>
             <a:r>
-              <a:rPr lang="en-US" b="1" sz="1400"/>
+              <a:rPr lang="en-US" sz="1400" b="1"/>
               <a:t>Reference:</a:t>
             </a:r>
             <a:r>
@@ -8882,7 +8977,7 @@
 </file>
 
 <file path=ppt/slides/slide27.xml><?xml version="1.0" encoding="utf-8"?>
-<p:sld xmlns:a="http://schemas.openxmlformats.org/drawingml/2006/main" xmlns:p="http://schemas.openxmlformats.org/presentationml/2006/main" xmlns:r="http://schemas.openxmlformats.org/officeDocument/2006/relationships">
+<p:sld xmlns:a="http://schemas.openxmlformats.org/drawingml/2006/main" xmlns:r="http://schemas.openxmlformats.org/officeDocument/2006/relationships" xmlns:p="http://schemas.openxmlformats.org/presentationml/2006/main">
   <p:cSld>
     <p:spTree>
       <p:nvGrpSpPr>
@@ -8890,7 +8985,14 @@
         <p:cNvGrpSpPr/>
         <p:nvPr/>
       </p:nvGrpSpPr>
-      <p:grpSpPr/>
+      <p:grpSpPr>
+        <a:xfrm>
+          <a:off x="0" y="0"/>
+          <a:ext cx="0" cy="0"/>
+          <a:chOff x="0" y="0"/>
+          <a:chExt cx="0" cy="0"/>
+        </a:xfrm>
+      </p:grpSpPr>
       <p:sp>
         <p:nvSpPr>
           <p:cNvPr id="2" name="Title 1"/>
@@ -8933,21 +9035,18 @@
           <a:bodyPr/>
           <a:lstStyle/>
           <a:p>
-            <a:pPr/>
             <a:r>
               <a:rPr sz="2400"/>
               <a:t>J の誤差や形を雑に扱うと、上限は厳しく出すぎ、本物の信号を除外しやすい</a:t>
             </a:r>
           </a:p>
           <a:p>
-            <a:pPr/>
             <a:r>
               <a:rPr sz="2400"/>
               <a:t>「銀河中心と矮小銀河が矛盾する」とは、まだ言えない</a:t>
             </a:r>
           </a:p>
           <a:p>
-            <a:pPr/>
             <a:r>
               <a:rPr sz="2400"/>
               <a:t>Δlog₁₀J ≈ 0.5 程度の誤差を見込むべき</a:t>
@@ -8984,7 +9083,7 @@
           <a:lstStyle/>
           <a:p>
             <a:r>
-              <a:rPr lang="en-US" b="1" sz="1400"/>
+              <a:rPr lang="en-US" sz="1400" b="1"/>
               <a:t>Reference:</a:t>
             </a:r>
             <a:r>
@@ -9004,7 +9103,7 @@
 </file>
 
 <file path=ppt/slides/slide28.xml><?xml version="1.0" encoding="utf-8"?>
-<p:sld xmlns:a="http://schemas.openxmlformats.org/drawingml/2006/main" xmlns:p="http://schemas.openxmlformats.org/presentationml/2006/main" xmlns:r="http://schemas.openxmlformats.org/officeDocument/2006/relationships">
+<p:sld xmlns:a="http://schemas.openxmlformats.org/drawingml/2006/main" xmlns:r="http://schemas.openxmlformats.org/officeDocument/2006/relationships" xmlns:p="http://schemas.openxmlformats.org/presentationml/2006/main">
   <p:cSld>
     <p:spTree>
       <p:nvGrpSpPr>
@@ -9012,7 +9111,14 @@
         <p:cNvGrpSpPr/>
         <p:nvPr/>
       </p:nvGrpSpPr>
-      <p:grpSpPr/>
+      <p:grpSpPr>
+        <a:xfrm>
+          <a:off x="0" y="0"/>
+          <a:ext cx="0" cy="0"/>
+          <a:chOff x="0" y="0"/>
+          <a:chExt cx="0" cy="0"/>
+        </a:xfrm>
+      </p:grpSpPr>
       <p:sp>
         <p:nvSpPr>
           <p:cNvPr id="2" name="Title 1"/>
@@ -9055,14 +9161,12 @@
           <a:bodyPr/>
           <a:lstStyle/>
           <a:p>
-            <a:pPr/>
             <a:r>
               <a:rPr sz="2400"/>
               <a:t>これまで：J の誤差 = 0（J は推定値そのまま）</a:t>
             </a:r>
           </a:p>
           <a:p>
-            <a:pPr/>
             <a:r>
               <a:rPr sz="2400"/>
               <a:t>今回：各天体の本当の J = 推定値 × 10^δ_i</a:t>
@@ -9083,14 +9187,12 @@
             </a:r>
           </a:p>
           <a:p>
-            <a:pPr/>
             <a:r>
               <a:rPr sz="2400"/>
               <a:t>予測 σ は J に比例 → pred_i × 10^δ_i</a:t>
             </a:r>
           </a:p>
           <a:p>
-            <a:pPr/>
             <a:r>
               <a:rPr sz="2400"/>
               <a:t>論文と同じく「J をずらした世界」をたくさん作る（20 万回）</a:t>
@@ -9127,7 +9229,7 @@
           <a:lstStyle/>
           <a:p>
             <a:r>
-              <a:rPr lang="en-US" b="1" sz="1400"/>
+              <a:rPr lang="en-US" sz="1400" b="1"/>
               <a:t>Reference:</a:t>
             </a:r>
             <a:r>
@@ -9147,7 +9249,7 @@
 </file>
 
 <file path=ppt/slides/slide29.xml><?xml version="1.0" encoding="utf-8"?>
-<p:sld xmlns:a="http://schemas.openxmlformats.org/drawingml/2006/main" xmlns:p="http://schemas.openxmlformats.org/presentationml/2006/main" xmlns:r="http://schemas.openxmlformats.org/officeDocument/2006/relationships">
+<p:sld xmlns:a="http://schemas.openxmlformats.org/drawingml/2006/main" xmlns:r="http://schemas.openxmlformats.org/officeDocument/2006/relationships" xmlns:p="http://schemas.openxmlformats.org/presentationml/2006/main">
   <p:cSld>
     <p:spTree>
       <p:nvGrpSpPr>
@@ -9155,7 +9257,14 @@
         <p:cNvGrpSpPr/>
         <p:nvPr/>
       </p:nvGrpSpPr>
-      <p:grpSpPr/>
+      <p:grpSpPr>
+        <a:xfrm>
+          <a:off x="0" y="0"/>
+          <a:ext cx="0" cy="0"/>
+          <a:chOff x="0" y="0"/>
+          <a:chExt cx="0" cy="0"/>
+        </a:xfrm>
+      </p:grpSpPr>
       <p:sp>
         <p:nvSpPr>
           <p:cNvPr id="2" name="Title 1"/>
@@ -9198,7 +9307,6 @@
           <a:bodyPr/>
           <a:lstStyle/>
           <a:p>
-            <a:pPr/>
             <a:r>
               <a:rPr sz="2400"/>
               <a:t>暗黒物質ありで期待される T</a:t>
@@ -9219,14 +9327,12 @@
             </a:r>
           </a:p>
           <a:p>
-            <a:pPr/>
             <a:r>
               <a:rPr sz="2400"/>
               <a:t>実測 T にも測定の揺れ s がある（s = 1、または空で測った 1.26）</a:t>
             </a:r>
           </a:p>
           <a:p>
-            <a:pPr/>
             <a:r>
               <a:rPr sz="2400"/>
               <a:t>暗黒物質ありで、実測 0.39 以下になる確率</a:t>
@@ -9240,7 +9346,6 @@
             </a:r>
           </a:p>
           <a:p>
-            <a:pPr/>
             <a:r>
               <a:rPr sz="2400"/>
               <a:t>p を σ に直したもの =「ずれ」</a:t>
@@ -9257,7 +9362,7 @@
 </file>
 
 <file path=ppt/slides/slide3.xml><?xml version="1.0" encoding="utf-8"?>
-<p:sld xmlns:a="http://schemas.openxmlformats.org/drawingml/2006/main" xmlns:p="http://schemas.openxmlformats.org/presentationml/2006/main" xmlns:r="http://schemas.openxmlformats.org/officeDocument/2006/relationships">
+<p:sld xmlns:a="http://schemas.openxmlformats.org/drawingml/2006/main" xmlns:r="http://schemas.openxmlformats.org/officeDocument/2006/relationships" xmlns:p="http://schemas.openxmlformats.org/presentationml/2006/main">
   <p:cSld>
     <p:spTree>
       <p:nvGrpSpPr>
@@ -9265,7 +9370,14 @@
         <p:cNvGrpSpPr/>
         <p:nvPr/>
       </p:nvGrpSpPr>
-      <p:grpSpPr/>
+      <p:grpSpPr>
+        <a:xfrm>
+          <a:off x="0" y="0"/>
+          <a:ext cx="0" cy="0"/>
+          <a:chOff x="0" y="0"/>
+          <a:chExt cx="0" cy="0"/>
+        </a:xfrm>
+      </p:grpSpPr>
       <p:sp>
         <p:nvSpPr>
           <p:cNvPr id="2" name="Title 1"/>
@@ -9274,33 +9386,38 @@
           </p:cNvSpPr>
           <p:nvPr>
             <p:ph type="title"/>
-          </p:nvPr>
-        </p:nvSpPr>
-        <p:spPr/>
-        <p:txBody>
-          <a:bodyPr/>
-          <a:lstStyle/>
-          <a:p>
-            <a:r>
-              <a:rPr sz="3400"/>
-              <a:t>データ：光子を数える</a:t>
-            </a:r>
-          </a:p>
-        </p:txBody>
-      </p:sp>
-      <p:sp>
-        <p:nvSpPr>
-          <p:cNvPr id="3" name="Content Placeholder 2"/>
-          <p:cNvSpPr>
-            <a:spLocks noGrp="1"/>
-          </p:cNvSpPr>
-          <p:nvPr>
-            <p:ph idx="1"/>
           </p:nvPr>
         </p:nvSpPr>
         <p:spPr>
           <a:xfrm>
-            <a:off x="841248" y="1463040"/>
+            <a:off x="0" y="-194592"/>
+            <a:ext cx="10515600" cy="1325563"/>
+          </a:xfrm>
+        </p:spPr>
+        <p:txBody>
+          <a:bodyPr/>
+          <a:lstStyle/>
+          <a:p>
+            <a:r>
+              <a:rPr sz="3400"/>
+              <a:t>光子を数える</a:t>
+            </a:r>
+          </a:p>
+        </p:txBody>
+      </p:sp>
+      <p:sp>
+        <p:nvSpPr>
+          <p:cNvPr id="3" name="Content Placeholder 2"/>
+          <p:cNvSpPr>
+            <a:spLocks noGrp="1"/>
+          </p:cNvSpPr>
+          <p:nvPr>
+            <p:ph idx="1"/>
+          </p:nvPr>
+        </p:nvSpPr>
+        <p:spPr>
+          <a:xfrm>
+            <a:off x="0" y="774644"/>
             <a:ext cx="10515600" cy="4114800"/>
           </a:xfrm>
         </p:spPr>
@@ -9308,7 +9425,6 @@
           <a:bodyPr/>
           <a:lstStyle/>
           <a:p>
-            <a:pPr/>
             <a:r>
               <a:rPr sz="2400"/>
               <a:t>Fermi-LAT 衛星が集めたガンマ線の光子（約 15 年分）</a:t>
@@ -9322,28 +9438,18 @@
             </a:r>
           </a:p>
           <a:p>
-            <a:pPr/>
             <a:r>
               <a:rPr sz="2400"/>
-              <a:t>空の範囲：銀経・銀緯とも ±60°（銀河面 |b| &lt; 10° は除く）</a:t>
-            </a:r>
-          </a:p>
-          <a:p>
-            <a:pPr/>
+              <a:t>空の範囲：銀経・銀緯とも ±60°（銀河面 |b| &lt; 10° 除く）</a:t>
+            </a:r>
+          </a:p>
+          <a:p>
             <a:r>
               <a:rPr sz="2400"/>
               <a:t>エネルギーを 13 個のビンに分ける（1.5 〜 814 GeV）</a:t>
             </a:r>
           </a:p>
           <a:p>
-            <a:pPr lvl="1"/>
-            <a:r>
-              <a:rPr sz="2000"/>
-              <a:t>ビンごとに別々に解析する</a:t>
-            </a:r>
-          </a:p>
-          <a:p>
-            <a:pPr/>
             <a:r>
               <a:rPr sz="2400"/>
               <a:t>各ビンで「空のどこに、光子が何個来たか」の地図を作る</a:t>
@@ -9351,12 +9457,100 @@
           </a:p>
         </p:txBody>
       </p:sp>
-      <p:sp>
-        <p:nvSpPr>
-          <p:cNvPr id="8" name="TextBox 7">
+      <p:pic>
+        <p:nvPicPr>
+          <p:cNvPr id="5" name="Picture 4">
             <a:extLst>
               <a:ext uri="{FF2B5EF4-FFF2-40B4-BE49-F238E27FC236}">
-                <a16:creationId xmlns:a16="http://schemas.microsoft.com/office/drawing/2014/main" id="{F85CD606-E3CE-F314-B3EE-F3D7028115CB}"/>
+                <a16:creationId xmlns:a16="http://schemas.microsoft.com/office/drawing/2014/main" id="{B2B30F14-F3FD-3F53-EC7E-3A869D50EC03}"/>
+              </a:ext>
+            </a:extLst>
+          </p:cNvPr>
+          <p:cNvPicPr>
+            <a:picLocks noChangeAspect="1"/>
+          </p:cNvPicPr>
+          <p:nvPr/>
+        </p:nvPicPr>
+        <p:blipFill>
+          <a:blip r:embed="rId3"/>
+          <a:srcRect r="49322"/>
+          <a:stretch>
+            <a:fillRect/>
+          </a:stretch>
+        </p:blipFill>
+        <p:spPr>
+          <a:xfrm>
+            <a:off x="5364481" y="2971718"/>
+            <a:ext cx="3708400" cy="3835451"/>
+          </a:xfrm>
+          <a:prstGeom prst="rect">
+            <a:avLst/>
+          </a:prstGeom>
+        </p:spPr>
+      </p:pic>
+      <p:sp>
+        <p:nvSpPr>
+          <p:cNvPr id="6" name="Arrow: Down 5">
+            <a:extLst>
+              <a:ext uri="{FF2B5EF4-FFF2-40B4-BE49-F238E27FC236}">
+                <a16:creationId xmlns:a16="http://schemas.microsoft.com/office/drawing/2014/main" id="{DDE5FA2F-AF5D-1CB3-11B6-5BBAE35CD7BA}"/>
+              </a:ext>
+            </a:extLst>
+          </p:cNvPr>
+          <p:cNvSpPr/>
+          <p:nvPr/>
+        </p:nvSpPr>
+        <p:spPr>
+          <a:xfrm rot="5400000">
+            <a:off x="9581969" y="3647825"/>
+            <a:ext cx="2036163" cy="2792425"/>
+          </a:xfrm>
+          <a:prstGeom prst="downArrow">
+            <a:avLst>
+              <a:gd name="adj1" fmla="val 44651"/>
+              <a:gd name="adj2" fmla="val 58348"/>
+            </a:avLst>
+          </a:prstGeom>
+          <a:solidFill>
+            <a:schemeClr val="bg1"/>
+          </a:solidFill>
+          <a:ln>
+            <a:solidFill>
+              <a:schemeClr val="tx1"/>
+            </a:solidFill>
+          </a:ln>
+        </p:spPr>
+        <p:style>
+          <a:lnRef idx="2">
+            <a:schemeClr val="accent1">
+              <a:shade val="15000"/>
+            </a:schemeClr>
+          </a:lnRef>
+          <a:fillRef idx="1">
+            <a:schemeClr val="accent1"/>
+          </a:fillRef>
+          <a:effectRef idx="0">
+            <a:schemeClr val="accent1"/>
+          </a:effectRef>
+          <a:fontRef idx="minor">
+            <a:schemeClr val="lt1"/>
+          </a:fontRef>
+        </p:style>
+        <p:txBody>
+          <a:bodyPr rtlCol="0" anchor="ctr"/>
+          <a:lstStyle/>
+          <a:p>
+            <a:pPr algn="ctr"/>
+            <a:endParaRPr lang="en-US"/>
+          </a:p>
+        </p:txBody>
+      </p:sp>
+      <p:sp>
+        <p:nvSpPr>
+          <p:cNvPr id="7" name="TextBox 6">
+            <a:extLst>
+              <a:ext uri="{FF2B5EF4-FFF2-40B4-BE49-F238E27FC236}">
+                <a16:creationId xmlns:a16="http://schemas.microsoft.com/office/drawing/2014/main" id="{0C0F810D-B137-252F-B137-69AD8335E4B7}"/>
               </a:ext>
             </a:extLst>
           </p:cNvPr>
@@ -9365,8 +9559,8 @@
         </p:nvSpPr>
         <p:spPr>
           <a:xfrm>
-            <a:off x="5837182" y="5663239"/>
-            <a:ext cx="6093372" cy="923330"/>
+            <a:off x="9995606" y="4690094"/>
+            <a:ext cx="1753564" cy="707886"/>
           </a:xfrm>
           <a:prstGeom prst="rect">
             <a:avLst/>
@@ -9374,20 +9568,19 @@
           <a:noFill/>
         </p:spPr>
         <p:txBody>
-          <a:bodyPr wrap="square">
+          <a:bodyPr wrap="square" rtlCol="0">
             <a:spAutoFit/>
           </a:bodyPr>
           <a:lstStyle/>
           <a:p>
             <a:r>
-              <a:rPr lang="en-US" b="1" sz="1400"/>
-              <a:t>Reference:</a:t>
-            </a:r>
-            <a:r>
-              <a:rPr lang="en-US" sz="1400"/>
-              <a:t> T. Totani (2025), arXiv:2507.07209 §2.1</a:t>
-            </a:r>
-            <a:endParaRPr lang="en-US"/>
+              <a:rPr lang="ja-JP" altLang="en-US" sz="4000"/>
+              <a:t>６</a:t>
+            </a:r>
+            <a:r>
+              <a:rPr lang="en-US" altLang="ja-JP" sz="4000"/>
+              <a:t>bin</a:t>
+            </a:r>
           </a:p>
         </p:txBody>
       </p:sp>
@@ -9400,7 +9593,7 @@
 </file>
 
 <file path=ppt/slides/slide30.xml><?xml version="1.0" encoding="utf-8"?>
-<p:sld xmlns:a="http://schemas.openxmlformats.org/drawingml/2006/main" xmlns:p="http://schemas.openxmlformats.org/presentationml/2006/main" xmlns:r="http://schemas.openxmlformats.org/officeDocument/2006/relationships">
+<p:sld xmlns:a="http://schemas.openxmlformats.org/drawingml/2006/main" xmlns:r="http://schemas.openxmlformats.org/officeDocument/2006/relationships" xmlns:p="http://schemas.openxmlformats.org/presentationml/2006/main">
   <p:cSld>
     <p:spTree>
       <p:nvGrpSpPr>
@@ -9408,7 +9601,14 @@
         <p:cNvGrpSpPr/>
         <p:nvPr/>
       </p:nvGrpSpPr>
-      <p:grpSpPr/>
+      <p:grpSpPr>
+        <a:xfrm>
+          <a:off x="0" y="0"/>
+          <a:ext cx="0" cy="0"/>
+          <a:chOff x="0" y="0"/>
+          <a:chExt cx="0" cy="0"/>
+        </a:xfrm>
+      </p:grpSpPr>
       <p:sp>
         <p:nvSpPr>
           <p:cNvPr id="2" name="Title 1"/>
@@ -9440,7 +9640,7 @@
           <p:nvPr/>
         </p:nvPicPr>
         <p:blipFill>
-          <a:blip r:embed="rId2"/>
+          <a:blip r:embed="rId3"/>
           <a:stretch>
             <a:fillRect/>
           </a:stretch>
@@ -9493,7 +9693,7 @@
 </file>
 
 <file path=ppt/slides/slide31.xml><?xml version="1.0" encoding="utf-8"?>
-<p:sld xmlns:a="http://schemas.openxmlformats.org/drawingml/2006/main" xmlns:p="http://schemas.openxmlformats.org/presentationml/2006/main" xmlns:r="http://schemas.openxmlformats.org/officeDocument/2006/relationships">
+<p:sld xmlns:a="http://schemas.openxmlformats.org/drawingml/2006/main" xmlns:r="http://schemas.openxmlformats.org/officeDocument/2006/relationships" xmlns:p="http://schemas.openxmlformats.org/presentationml/2006/main">
   <p:cSld>
     <p:spTree>
       <p:nvGrpSpPr>
@@ -9501,7 +9701,14 @@
         <p:cNvGrpSpPr/>
         <p:nvPr/>
       </p:nvGrpSpPr>
-      <p:grpSpPr/>
+      <p:grpSpPr>
+        <a:xfrm>
+          <a:off x="0" y="0"/>
+          <a:ext cx="0" cy="0"/>
+          <a:chOff x="0" y="0"/>
+          <a:chExt cx="0" cy="0"/>
+        </a:xfrm>
+      </p:grpSpPr>
       <p:sp>
         <p:nvSpPr>
           <p:cNvPr id="2" name="Title 1"/>
@@ -9544,7 +9751,6 @@
           <a:bodyPr/>
           <a:lstStyle/>
           <a:p>
-            <a:pPr/>
             <a:r>
               <a:rPr sz="2400"/>
               <a:t>局所密度 0.42 GeV/cm³ の場合（43 天体、20 GeV）</a:t>
@@ -9565,7 +9771,6 @@
             </a:r>
           </a:p>
           <a:p>
-            <a:pPr/>
             <a:r>
               <a:rPr sz="2400"/>
               <a:t>天の川側の局所密度を 0.3〜0.6 GeV/cm³ で動かしても</a:t>
@@ -9579,7 +9784,6 @@
             </a:r>
           </a:p>
           <a:p>
-            <a:pPr/>
             <a:r>
               <a:rPr sz="2400"/>
               <a:t>→ 暗黒物質と矛盾はしないが、確認もできない（判定できない）</a:t>
@@ -9596,7 +9800,7 @@
 </file>
 
 <file path=ppt/slides/slide32.xml><?xml version="1.0" encoding="utf-8"?>
-<p:sld xmlns:a="http://schemas.openxmlformats.org/drawingml/2006/main" xmlns:p="http://schemas.openxmlformats.org/presentationml/2006/main" xmlns:r="http://schemas.openxmlformats.org/officeDocument/2006/relationships">
+<p:sld xmlns:a="http://schemas.openxmlformats.org/drawingml/2006/main" xmlns:r="http://schemas.openxmlformats.org/officeDocument/2006/relationships" xmlns:p="http://schemas.openxmlformats.org/presentationml/2006/main">
   <p:cSld>
     <p:spTree>
       <p:nvGrpSpPr>
@@ -9604,7 +9808,14 @@
         <p:cNvGrpSpPr/>
         <p:nvPr/>
       </p:nvGrpSpPr>
-      <p:grpSpPr/>
+      <p:grpSpPr>
+        <a:xfrm>
+          <a:off x="0" y="0"/>
+          <a:ext cx="0" cy="0"/>
+          <a:chOff x="0" y="0"/>
+          <a:chExt cx="0" cy="0"/>
+        </a:xfrm>
+      </p:grpSpPr>
       <p:sp>
         <p:nvSpPr>
           <p:cNvPr id="2" name="Title 1"/>
@@ -9647,7 +9858,6 @@
           <a:bodyPr/>
           <a:lstStyle/>
           <a:p>
-            <a:pPr/>
             <a:r>
               <a:rPr sz="2400"/>
               <a:t>約 15σ：天の川のハロー超過の強さ</a:t>
@@ -9668,7 +9878,6 @@
             </a:r>
           </a:p>
           <a:p>
-            <a:pPr/>
             <a:r>
               <a:rPr sz="2400"/>
               <a:t>1.3σ：矮小銀河での「予測と実測のずれ」</a:t>
@@ -9682,7 +9891,6 @@
             </a:r>
           </a:p>
           <a:p>
-            <a:pPr/>
             <a:r>
               <a:rPr sz="2400"/>
               <a:t>別のものを測った、別の数字</a:t>
@@ -9699,7 +9907,7 @@
 </file>
 
 <file path=ppt/slides/slide33.xml><?xml version="1.0" encoding="utf-8"?>
-<p:sld xmlns:a="http://schemas.openxmlformats.org/drawingml/2006/main" xmlns:p="http://schemas.openxmlformats.org/presentationml/2006/main" xmlns:r="http://schemas.openxmlformats.org/officeDocument/2006/relationships">
+<p:sld xmlns:a="http://schemas.openxmlformats.org/drawingml/2006/main" xmlns:r="http://schemas.openxmlformats.org/officeDocument/2006/relationships" xmlns:p="http://schemas.openxmlformats.org/presentationml/2006/main">
   <p:cSld>
     <p:spTree>
       <p:nvGrpSpPr>
@@ -9707,7 +9915,14 @@
         <p:cNvGrpSpPr/>
         <p:nvPr/>
       </p:nvGrpSpPr>
-      <p:grpSpPr/>
+      <p:grpSpPr>
+        <a:xfrm>
+          <a:off x="0" y="0"/>
+          <a:ext cx="0" cy="0"/>
+          <a:chOff x="0" y="0"/>
+          <a:chExt cx="0" cy="0"/>
+        </a:xfrm>
+      </p:grpSpPr>
       <p:sp>
         <p:nvSpPr>
           <p:cNvPr id="2" name="Title 1"/>
@@ -9750,14 +9965,12 @@
           <a:bodyPr/>
           <a:lstStyle/>
           <a:p>
-            <a:pPr/>
             <a:r>
               <a:rPr sz="2400"/>
               <a:t>Totani の超過を再現（名目 19.0σ、較正後 約 15σ）</a:t>
             </a:r>
           </a:p>
           <a:p>
-            <a:pPr/>
             <a:r>
               <a:rPr sz="2400"/>
               <a:t>ICS の明るさ・バブル・計算の近似の間違いでは説明できない</a:t>
@@ -9771,7 +9984,6 @@
             </a:r>
           </a:p>
           <a:p>
-            <a:pPr/>
             <a:r>
               <a:rPr sz="2400"/>
               <a:t>矮小銀河では非検出</a:t>
@@ -9795,7 +10007,7 @@
 </file>
 
 <file path=ppt/slides/slide34.xml><?xml version="1.0" encoding="utf-8"?>
-<p:sld xmlns:a="http://schemas.openxmlformats.org/drawingml/2006/main" xmlns:p="http://schemas.openxmlformats.org/presentationml/2006/main" xmlns:r="http://schemas.openxmlformats.org/officeDocument/2006/relationships">
+<p:sld xmlns:a="http://schemas.openxmlformats.org/drawingml/2006/main" xmlns:r="http://schemas.openxmlformats.org/officeDocument/2006/relationships" xmlns:p="http://schemas.openxmlformats.org/presentationml/2006/main">
   <p:cSld>
     <p:spTree>
       <p:nvGrpSpPr>
@@ -9803,7 +10015,14 @@
         <p:cNvGrpSpPr/>
         <p:nvPr/>
       </p:nvGrpSpPr>
-      <p:grpSpPr/>
+      <p:grpSpPr>
+        <a:xfrm>
+          <a:off x="0" y="0"/>
+          <a:ext cx="0" cy="0"/>
+          <a:chOff x="0" y="0"/>
+          <a:chExt cx="0" cy="0"/>
+        </a:xfrm>
+      </p:grpSpPr>
       <p:sp>
         <p:nvSpPr>
           <p:cNvPr id="2" name="Title 1"/>
@@ -9846,7 +10065,6 @@
           <a:bodyPr/>
           <a:lstStyle/>
           <a:p>
-            <a:pPr/>
             <a:r>
               <a:rPr sz="2400"/>
               <a:t>σ が 1.26 倍に膨らんだ原因</a:t>
@@ -9867,14 +10085,12 @@
             </a:r>
           </a:p>
           <a:p>
-            <a:pPr/>
             <a:r>
               <a:rPr sz="2400"/>
               <a:t>データ同化：シミュレーションの誤差と観測の誤差を分けて、統計モデルに入れる枠組み</a:t>
             </a:r>
           </a:p>
           <a:p>
-            <a:pPr/>
             <a:r>
               <a:rPr sz="2400"/>
               <a:t>J をずらして何度も計算したのも、分布をたくさんのサンプルで表すという同じ発想</a:t>
@@ -9918,7 +10134,7 @@
           <a:lstStyle/>
           <a:p>
             <a:r>
-              <a:rPr lang="en-US" b="1" sz="1400"/>
+              <a:rPr lang="en-US" sz="1400" b="1"/>
               <a:t>Reference:</a:t>
             </a:r>
             <a:r>
@@ -9938,7 +10154,7 @@
 </file>
 
 <file path=ppt/slides/slide35.xml><?xml version="1.0" encoding="utf-8"?>
-<p:sld xmlns:a="http://schemas.openxmlformats.org/drawingml/2006/main" xmlns:p="http://schemas.openxmlformats.org/presentationml/2006/main" xmlns:r="http://schemas.openxmlformats.org/officeDocument/2006/relationships">
+<p:sld xmlns:a="http://schemas.openxmlformats.org/drawingml/2006/main" xmlns:r="http://schemas.openxmlformats.org/officeDocument/2006/relationships" xmlns:p="http://schemas.openxmlformats.org/presentationml/2006/main">
   <p:cSld>
     <p:spTree>
       <p:nvGrpSpPr>
@@ -9946,7 +10162,14 @@
         <p:cNvGrpSpPr/>
         <p:nvPr/>
       </p:nvGrpSpPr>
-      <p:grpSpPr/>
+      <p:grpSpPr>
+        <a:xfrm>
+          <a:off x="0" y="0"/>
+          <a:ext cx="0" cy="0"/>
+          <a:chOff x="0" y="0"/>
+          <a:chExt cx="0" cy="0"/>
+        </a:xfrm>
+      </p:grpSpPr>
       <p:sp>
         <p:nvSpPr>
           <p:cNvPr id="2" name="Title 1"/>
@@ -9989,63 +10212,54 @@
           <a:bodyPr/>
           <a:lstStyle/>
           <a:p>
-            <a:pPr/>
             <a:r>
               <a:rPr sz="1800"/>
               <a:t>T. Totani (2025), arXiv:2507.07209</a:t>
             </a:r>
           </a:p>
           <a:p>
-            <a:pPr/>
             <a:r>
               <a:rPr sz="1800"/>
               <a:t>Bertólez-Martínez, Hooper &amp; Khatee Zathul (2026), arXiv:2609.20944</a:t>
             </a:r>
           </a:p>
           <a:p>
-            <a:pPr/>
             <a:r>
               <a:rPr sz="1800"/>
               <a:t>S. S. Wilks (1938), Ann. Math. Stat. 9, 60</a:t>
             </a:r>
           </a:p>
           <a:p>
-            <a:pPr/>
             <a:r>
               <a:rPr sz="1800"/>
               <a:t>D. Foreman-Mackey et al. (2013), PASP 125, 306</a:t>
             </a:r>
           </a:p>
           <a:p>
-            <a:pPr/>
             <a:r>
               <a:rPr sz="1800"/>
               <a:t>I. V. Moskalenko &amp; A. W. Strong (2000), ApJ 528, 357</a:t>
             </a:r>
           </a:p>
           <a:p>
-            <a:pPr/>
             <a:r>
               <a:rPr sz="1800"/>
               <a:t>B. Efron &amp; R. J. Tibshirani (1993), An Introduction to the Bootstrap</a:t>
             </a:r>
           </a:p>
           <a:p>
-            <a:pPr/>
             <a:r>
               <a:rPr sz="1800"/>
               <a:t>A. B. Pace (2025), Open J. Astrophys. 8, 142</a:t>
             </a:r>
           </a:p>
           <a:p>
-            <a:pPr/>
             <a:r>
               <a:rPr sz="1800"/>
               <a:t>A. B. Pace &amp; L. E. Strigari (2019), MNRAS 482, 3480</a:t>
             </a:r>
           </a:p>
           <a:p>
-            <a:pPr/>
             <a:r>
               <a:rPr sz="1800"/>
               <a:t>中村和幸 (2017), 数理解析研究所講究録 2057, 59–66</a:t>
@@ -10062,7 +10276,7 @@
 </file>
 
 <file path=ppt/slides/slide4.xml><?xml version="1.0" encoding="utf-8"?>
-<p:sld xmlns:a="http://schemas.openxmlformats.org/drawingml/2006/main" xmlns:p="http://schemas.openxmlformats.org/presentationml/2006/main" xmlns:r="http://schemas.openxmlformats.org/officeDocument/2006/relationships">
+<p:sld xmlns:a="http://schemas.openxmlformats.org/drawingml/2006/main" xmlns:r="http://schemas.openxmlformats.org/officeDocument/2006/relationships" xmlns:p="http://schemas.openxmlformats.org/presentationml/2006/main">
   <p:cSld>
     <p:spTree>
       <p:nvGrpSpPr>
@@ -10070,7 +10284,14 @@
         <p:cNvGrpSpPr/>
         <p:nvPr/>
       </p:nvGrpSpPr>
-      <p:grpSpPr/>
+      <p:grpSpPr>
+        <a:xfrm>
+          <a:off x="0" y="0"/>
+          <a:ext cx="0" cy="0"/>
+          <a:chOff x="0" y="0"/>
+          <a:chExt cx="0" cy="0"/>
+        </a:xfrm>
+      </p:grpSpPr>
       <p:sp>
         <p:nvSpPr>
           <p:cNvPr id="2" name="Title 1"/>
@@ -10081,7 +10302,12 @@
             <p:ph type="title"/>
           </p:nvPr>
         </p:nvSpPr>
-        <p:spPr/>
+        <p:spPr>
+          <a:xfrm>
+            <a:off x="148389" y="0"/>
+            <a:ext cx="10515600" cy="1325563"/>
+          </a:xfrm>
+        </p:spPr>
         <p:txBody>
           <a:bodyPr/>
           <a:lstStyle/>
@@ -10089,6 +10315,151 @@
             <a:r>
               <a:rPr sz="3400"/>
               <a:t>手法①：テンプレートフィット</a:t>
+            </a:r>
+          </a:p>
+        </p:txBody>
+      </p:sp>
+      <p:sp>
+        <p:nvSpPr>
+          <p:cNvPr id="3" name="Content Placeholder 2"/>
+          <p:cNvSpPr>
+            <a:spLocks noGrp="1"/>
+          </p:cNvSpPr>
+          <p:nvPr>
+            <p:ph idx="1"/>
+          </p:nvPr>
+        </p:nvSpPr>
+        <p:spPr>
+          <a:xfrm>
+            <a:off x="440194" y="1371599"/>
+            <a:ext cx="11490359" cy="4716379"/>
+          </a:xfrm>
+        </p:spPr>
+        <p:txBody>
+          <a:bodyPr/>
+          <a:lstStyle/>
+          <a:p>
+            <a:r>
+              <a:rPr sz="2400"/>
+              <a:t>空の光を「</a:t>
+            </a:r>
+            <a:r>
+              <a:rPr lang="ja-JP" altLang="en-US" sz="2400"/>
+              <a:t>既知の要素</a:t>
+            </a:r>
+            <a:r>
+              <a:rPr sz="2400"/>
+              <a:t>の足し算」で表す</a:t>
+            </a:r>
+          </a:p>
+          <a:p>
+            <a:pPr lvl="1"/>
+            <a:r>
+              <a:rPr sz="2000"/>
+              <a:t>予測 = Σ（倍率 f_l）×（</a:t>
+            </a:r>
+            <a:r>
+              <a:rPr lang="ja-JP" altLang="en-US" sz="2000"/>
+              <a:t>要素</a:t>
+            </a:r>
+            <a:r>
+              <a:rPr sz="2000"/>
+              <a:t> l）</a:t>
+            </a:r>
+          </a:p>
+          <a:p>
+            <a:r>
+              <a:rPr lang="ja-JP" altLang="en-US" sz="2400"/>
+              <a:t>要素</a:t>
+            </a:r>
+            <a:r>
+              <a:rPr sz="2400"/>
+              <a:t>は 9 枚</a:t>
+            </a:r>
+          </a:p>
+          <a:p>
+            <a:r>
+              <a:rPr sz="2000"/>
+              <a:t>等方背景、ガス（π⁰ 崩壊＋制動放射）</a:t>
+            </a:r>
+            <a:r>
+              <a:rPr lang="en-US" sz="2000"/>
+              <a:t>(</a:t>
+            </a:r>
+            <a:r>
+              <a:rPr lang="en-US" sz="2400"/>
+              <a:t>GALPROP)</a:t>
+            </a:r>
+            <a:r>
+              <a:rPr lang="en-US" sz="2000"/>
+              <a:t>、ICS、</a:t>
+            </a:r>
+            <a:r>
+              <a:rPr lang="ja-JP" altLang="en-US" sz="2000"/>
+              <a:t>点源</a:t>
+            </a:r>
+          </a:p>
+          <a:p>
+            <a:pPr lvl="1"/>
+            <a:r>
+              <a:rPr sz="2000"/>
+              <a:t>Loop I（2 枚）、フェルミバブル（正・負）、ハロー</a:t>
+            </a:r>
+          </a:p>
+          <a:p>
+            <a:pPr marL="0" indent="0">
+              <a:buNone/>
+            </a:pPr>
+            <a:r>
+              <a:rPr sz="2400"/>
+              <a:t>倍率 f_l をデータに合うように決める</a:t>
+            </a:r>
+          </a:p>
+        </p:txBody>
+      </p:sp>
+    </p:spTree>
+  </p:cSld>
+  <p:clrMapOvr>
+    <a:masterClrMapping/>
+  </p:clrMapOvr>
+</p:sld>
+</file>
+
+<file path=ppt/slides/slide5.xml><?xml version="1.0" encoding="utf-8"?>
+<p:sld xmlns:a="http://schemas.openxmlformats.org/drawingml/2006/main" xmlns:r="http://schemas.openxmlformats.org/officeDocument/2006/relationships" xmlns:p="http://schemas.openxmlformats.org/presentationml/2006/main">
+  <p:cSld>
+    <p:spTree>
+      <p:nvGrpSpPr>
+        <p:cNvPr id="1" name=""/>
+        <p:cNvGrpSpPr/>
+        <p:nvPr/>
+      </p:nvGrpSpPr>
+      <p:grpSpPr>
+        <a:xfrm>
+          <a:off x="0" y="0"/>
+          <a:ext cx="0" cy="0"/>
+          <a:chOff x="0" y="0"/>
+          <a:chExt cx="0" cy="0"/>
+        </a:xfrm>
+      </p:grpSpPr>
+      <p:sp>
+        <p:nvSpPr>
+          <p:cNvPr id="2" name="Title 1"/>
+          <p:cNvSpPr>
+            <a:spLocks noGrp="1"/>
+          </p:cNvSpPr>
+          <p:nvPr>
+            <p:ph type="title"/>
+          </p:nvPr>
+        </p:nvSpPr>
+        <p:spPr/>
+        <p:txBody>
+          <a:bodyPr/>
+          <a:lstStyle/>
+          <a:p>
+            <a:r>
+              <a:rPr sz="3400"/>
+              <a:t>手法②：尤度（どれだけ合っているか）</a:t>
             </a:r>
           </a:p>
         </p:txBody>
@@ -10113,52 +10484,170 @@
           <a:bodyPr/>
           <a:lstStyle/>
           <a:p>
-            <a:pPr/>
             <a:r>
               <a:rPr sz="2400"/>
-              <a:t>空の光を「知っている光源の型紙の足し算」で表す</a:t>
+              <a:t>光子の数はポアソン分布でばらつく</a:t>
+            </a:r>
+          </a:p>
+          <a:p>
+            <a:r>
+              <a:rPr sz="2400"/>
+              <a:t>尤度：ln L = Σ_i [ C_obs,i ln C_exp,i − C_exp,i ]</a:t>
             </a:r>
           </a:p>
           <a:p>
             <a:pPr lvl="1"/>
             <a:r>
               <a:rPr sz="2000"/>
-              <a:t>予測 = Σ（倍率 f_l）×（型紙 l）</a:t>
-            </a:r>
-          </a:p>
-          <a:p>
-            <a:pPr/>
+              <a:t>C_obs：観測した光子数、C_exp：予測した光子数</a:t>
+            </a:r>
+          </a:p>
+          <a:p>
+            <a:pPr lvl="1"/>
+            <a:r>
+              <a:rPr sz="2000"/>
+              <a:t>i：10° × 10° のセル（空をマス目に分ける）</a:t>
+            </a:r>
+          </a:p>
+          <a:p>
             <a:r>
               <a:rPr sz="2400"/>
-              <a:t>型紙は 9 枚</a:t>
+              <a:t>ln L が最大になる倍率 f を探す（最尤推定）</a:t>
+            </a:r>
+          </a:p>
+        </p:txBody>
+      </p:sp>
+      <p:pic>
+        <p:nvPicPr>
+          <p:cNvPr id="5" name="Picture 4">
+            <a:extLst>
+              <a:ext uri="{FF2B5EF4-FFF2-40B4-BE49-F238E27FC236}">
+                <a16:creationId xmlns:a16="http://schemas.microsoft.com/office/drawing/2014/main" id="{1322290E-F674-5B31-CE05-04E65EC1C03F}"/>
+              </a:ext>
+            </a:extLst>
+          </p:cNvPr>
+          <p:cNvPicPr>
+            <a:picLocks noChangeAspect="1"/>
+          </p:cNvPicPr>
+          <p:nvPr/>
+        </p:nvPicPr>
+        <p:blipFill>
+          <a:blip r:embed="rId3"/>
+          <a:stretch>
+            <a:fillRect/>
+          </a:stretch>
+        </p:blipFill>
+        <p:spPr>
+          <a:xfrm>
+            <a:off x="2551565" y="3749403"/>
+            <a:ext cx="5751094" cy="3014367"/>
+          </a:xfrm>
+          <a:prstGeom prst="rect">
+            <a:avLst/>
+          </a:prstGeom>
+        </p:spPr>
+      </p:pic>
+    </p:spTree>
+  </p:cSld>
+  <p:clrMapOvr>
+    <a:masterClrMapping/>
+  </p:clrMapOvr>
+</p:sld>
+</file>
+
+<file path=ppt/slides/slide6.xml><?xml version="1.0" encoding="utf-8"?>
+<p:sld xmlns:a="http://schemas.openxmlformats.org/drawingml/2006/main" xmlns:r="http://schemas.openxmlformats.org/officeDocument/2006/relationships" xmlns:p="http://schemas.openxmlformats.org/presentationml/2006/main">
+  <p:cSld>
+    <p:spTree>
+      <p:nvGrpSpPr>
+        <p:cNvPr id="1" name=""/>
+        <p:cNvGrpSpPr/>
+        <p:nvPr/>
+      </p:nvGrpSpPr>
+      <p:grpSpPr>
+        <a:xfrm>
+          <a:off x="0" y="0"/>
+          <a:ext cx="0" cy="0"/>
+          <a:chOff x="0" y="0"/>
+          <a:chExt cx="0" cy="0"/>
+        </a:xfrm>
+      </p:grpSpPr>
+      <p:sp>
+        <p:nvSpPr>
+          <p:cNvPr id="2" name="Title 1"/>
+          <p:cNvSpPr>
+            <a:spLocks noGrp="1"/>
+          </p:cNvSpPr>
+          <p:nvPr>
+            <p:ph type="title"/>
+          </p:nvPr>
+        </p:nvSpPr>
+        <p:spPr/>
+        <p:txBody>
+          <a:bodyPr/>
+          <a:lstStyle/>
+          <a:p>
+            <a:r>
+              <a:rPr sz="3400"/>
+              <a:t>手法③：有意度 σ の出し方</a:t>
+            </a:r>
+          </a:p>
+        </p:txBody>
+      </p:sp>
+      <p:sp>
+        <p:nvSpPr>
+          <p:cNvPr id="3" name="Content Placeholder 2"/>
+          <p:cNvSpPr>
+            <a:spLocks noGrp="1"/>
+          </p:cNvSpPr>
+          <p:nvPr>
+            <p:ph idx="1"/>
+          </p:nvPr>
+        </p:nvSpPr>
+        <p:spPr>
+          <a:xfrm>
+            <a:off x="841248" y="1463040"/>
+            <a:ext cx="10515600" cy="4114800"/>
+          </a:xfrm>
+        </p:spPr>
+        <p:txBody>
+          <a:bodyPr/>
+          <a:lstStyle/>
+          <a:p>
+            <a:r>
+              <a:rPr sz="2400"/>
+              <a:t>ハロー「あり」と「なし」の 2 通りで当てはめる</a:t>
+            </a:r>
+          </a:p>
+          <a:p>
+            <a:r>
+              <a:rPr sz="2400"/>
+              <a:t>差 Δln L = ln L(あり) − ln L(なし)</a:t>
+            </a:r>
+          </a:p>
+          <a:p>
+            <a:r>
+              <a:rPr sz="2400"/>
+              <a:t>有意度 σ = √( 2 Δln L )</a:t>
+            </a:r>
+          </a:p>
+          <a:p>
+            <a:r>
+              <a:rPr sz="2400"/>
+              <a:t>根拠：Wilks の定理</a:t>
             </a:r>
           </a:p>
           <a:p>
             <a:pPr lvl="1"/>
             <a:r>
               <a:rPr sz="2000"/>
-              <a:t>等方背景、ガス（π⁰ 崩壊＋制動放射）、ICS、点源</a:t>
-            </a:r>
-          </a:p>
-          <a:p>
-            <a:pPr lvl="1"/>
-            <a:r>
-              <a:rPr sz="2000"/>
-              <a:t>Loop I（2 枚）、フェルミバブル（正・負）、ハロー</a:t>
-            </a:r>
-          </a:p>
-          <a:p>
-            <a:pPr/>
+              <a:t>データが十分多いと、2Δln L は自由度 1 の χ² 分布に従う</a:t>
+            </a:r>
+          </a:p>
+          <a:p>
             <a:r>
               <a:rPr sz="2400"/>
-              <a:t>ガスと ICS の型紙は、宇宙線のシミュレーション GALPROP で計算</a:t>
-            </a:r>
-          </a:p>
-          <a:p>
-            <a:pPr/>
-            <a:r>
-              <a:rPr sz="2400"/>
-              <a:t>倍率 f_l をデータに合うように決める（ハローの f は負も許す）</a:t>
+              <a:t>→ この定理が本当に成り立つかが、後で問題になる</a:t>
             </a:r>
           </a:p>
         </p:txBody>
@@ -10192,12 +10681,12 @@
           <a:lstStyle/>
           <a:p>
             <a:r>
-              <a:rPr lang="en-US" b="1" sz="1400"/>
+              <a:rPr lang="en-US" sz="1400" b="1"/>
               <a:t>Reference:</a:t>
             </a:r>
             <a:r>
               <a:rPr lang="en-US" sz="1400"/>
-              <a:t> T. Totani (2025), arXiv:2507.07209 §2.3</a:t>
+              <a:t> S. S. Wilks (1938), Ann. Math. Stat. 9, 60</a:t>
             </a:r>
             <a:endParaRPr lang="en-US"/>
           </a:p>
@@ -10211,8 +10700,8 @@
 </p:sld>
 </file>
 
-<file path=ppt/slides/slide5.xml><?xml version="1.0" encoding="utf-8"?>
-<p:sld xmlns:a="http://schemas.openxmlformats.org/drawingml/2006/main" xmlns:p="http://schemas.openxmlformats.org/presentationml/2006/main" xmlns:r="http://schemas.openxmlformats.org/officeDocument/2006/relationships">
+<file path=ppt/slides/slide7.xml><?xml version="1.0" encoding="utf-8"?>
+<p:sld xmlns:a="http://schemas.openxmlformats.org/drawingml/2006/main" xmlns:r="http://schemas.openxmlformats.org/officeDocument/2006/relationships" xmlns:p="http://schemas.openxmlformats.org/presentationml/2006/main">
   <p:cSld>
     <p:spTree>
       <p:nvGrpSpPr>
@@ -10220,7 +10709,14 @@
         <p:cNvGrpSpPr/>
         <p:nvPr/>
       </p:nvGrpSpPr>
-      <p:grpSpPr/>
+      <p:grpSpPr>
+        <a:xfrm>
+          <a:off x="0" y="0"/>
+          <a:ext cx="0" cy="0"/>
+          <a:chOff x="0" y="0"/>
+          <a:chExt cx="0" cy="0"/>
+        </a:xfrm>
+      </p:grpSpPr>
       <p:sp>
         <p:nvSpPr>
           <p:cNvPr id="2" name="Title 1"/>
@@ -10238,7 +10734,7 @@
           <a:p>
             <a:r>
               <a:rPr sz="3400"/>
-              <a:t>手法②：尤度（どれだけ合っているか）</a:t>
+              <a:t>手法④：MCMC（誤差の見積もり）</a:t>
             </a:r>
           </a:p>
         </p:txBody>
@@ -10263,38 +10759,41 @@
           <a:bodyPr/>
           <a:lstStyle/>
           <a:p>
-            <a:pPr/>
             <a:r>
               <a:rPr sz="2400"/>
-              <a:t>光子の数はポアソン分布でばらつく</a:t>
-            </a:r>
-          </a:p>
-          <a:p>
-            <a:pPr/>
+              <a:t>最尤の 1 点だけでなく、倍率 f が「どれくらいの範囲にありうるか」を知りたい</a:t>
+            </a:r>
+          </a:p>
+          <a:p>
             <a:r>
               <a:rPr sz="2400"/>
-              <a:t>尤度：ln L = Σ_i [ C_obs,i ln C_exp,i − C_exp,i ]</a:t>
+              <a:t>MCMC：尤度に比例する確率で、パラメータの空間を歩き回る</a:t>
             </a:r>
           </a:p>
           <a:p>
             <a:pPr lvl="1"/>
             <a:r>
               <a:rPr sz="2000"/>
-              <a:t>C_obs：観測した光子数、C_exp：予測した光子数</a:t>
+              <a:t>歩いた跡の分布 = パラメータの事後分布 → 誤差棒</a:t>
+            </a:r>
+          </a:p>
+          <a:p>
+            <a:r>
+              <a:rPr sz="2400"/>
+              <a:t>emcee を使用：32 本の歩行者、最初の 400 歩は捨てる</a:t>
             </a:r>
           </a:p>
           <a:p>
             <a:pPr lvl="1"/>
             <a:r>
               <a:rPr sz="2000"/>
-              <a:t>i：10° × 10° のセル（空をマス目に分ける）</a:t>
-            </a:r>
-          </a:p>
-          <a:p>
-            <a:pPr/>
+              <a:t>自己相関時間の 50 倍以上の長さがあるか確認</a:t>
+            </a:r>
+          </a:p>
+          <a:p>
             <a:r>
               <a:rPr sz="2400"/>
-              <a:t>ln L が最大になる倍率 f を探す（最尤推定）</a:t>
+              <a:t>有意度 σ は Δln L から出すので、MCMC の有無で変わらない</a:t>
             </a:r>
           </a:p>
         </p:txBody>
@@ -10328,293 +10827,7 @@
           <a:lstStyle/>
           <a:p>
             <a:r>
-              <a:rPr lang="en-US" b="1" sz="1400"/>
-              <a:t>Reference:</a:t>
-            </a:r>
-            <a:r>
-              <a:rPr lang="en-US" sz="1400"/>
-              <a:t> T. Totani (2025), arXiv:2507.07209 式 (2.1)</a:t>
-            </a:r>
-            <a:endParaRPr lang="en-US"/>
-          </a:p>
-        </p:txBody>
-      </p:sp>
-    </p:spTree>
-  </p:cSld>
-  <p:clrMapOvr>
-    <a:masterClrMapping/>
-  </p:clrMapOvr>
-</p:sld>
-</file>
-
-<file path=ppt/slides/slide6.xml><?xml version="1.0" encoding="utf-8"?>
-<p:sld xmlns:a="http://schemas.openxmlformats.org/drawingml/2006/main" xmlns:p="http://schemas.openxmlformats.org/presentationml/2006/main" xmlns:r="http://schemas.openxmlformats.org/officeDocument/2006/relationships">
-  <p:cSld>
-    <p:spTree>
-      <p:nvGrpSpPr>
-        <p:cNvPr id="1" name=""/>
-        <p:cNvGrpSpPr/>
-        <p:nvPr/>
-      </p:nvGrpSpPr>
-      <p:grpSpPr/>
-      <p:sp>
-        <p:nvSpPr>
-          <p:cNvPr id="2" name="Title 1"/>
-          <p:cNvSpPr>
-            <a:spLocks noGrp="1"/>
-          </p:cNvSpPr>
-          <p:nvPr>
-            <p:ph type="title"/>
-          </p:nvPr>
-        </p:nvSpPr>
-        <p:spPr/>
-        <p:txBody>
-          <a:bodyPr/>
-          <a:lstStyle/>
-          <a:p>
-            <a:r>
-              <a:rPr sz="3400"/>
-              <a:t>手法③：有意度 σ の出し方</a:t>
-            </a:r>
-          </a:p>
-        </p:txBody>
-      </p:sp>
-      <p:sp>
-        <p:nvSpPr>
-          <p:cNvPr id="3" name="Content Placeholder 2"/>
-          <p:cNvSpPr>
-            <a:spLocks noGrp="1"/>
-          </p:cNvSpPr>
-          <p:nvPr>
-            <p:ph idx="1"/>
-          </p:nvPr>
-        </p:nvSpPr>
-        <p:spPr>
-          <a:xfrm>
-            <a:off x="841248" y="1463040"/>
-            <a:ext cx="10515600" cy="4114800"/>
-          </a:xfrm>
-        </p:spPr>
-        <p:txBody>
-          <a:bodyPr/>
-          <a:lstStyle/>
-          <a:p>
-            <a:pPr/>
-            <a:r>
-              <a:rPr sz="2400"/>
-              <a:t>ハロー「あり」と「なし」の 2 通りで当てはめる</a:t>
-            </a:r>
-          </a:p>
-          <a:p>
-            <a:pPr/>
-            <a:r>
-              <a:rPr sz="2400"/>
-              <a:t>差 Δln L = ln L(あり) − ln L(なし)</a:t>
-            </a:r>
-          </a:p>
-          <a:p>
-            <a:pPr/>
-            <a:r>
-              <a:rPr sz="2400"/>
-              <a:t>有意度 σ = √( 2 Δln L )</a:t>
-            </a:r>
-          </a:p>
-          <a:p>
-            <a:pPr/>
-            <a:r>
-              <a:rPr sz="2400"/>
-              <a:t>根拠：Wilks の定理</a:t>
-            </a:r>
-          </a:p>
-          <a:p>
-            <a:pPr lvl="1"/>
-            <a:r>
-              <a:rPr sz="2000"/>
-              <a:t>データが十分多いと、2Δln L は自由度 1 の χ² 分布に従う</a:t>
-            </a:r>
-          </a:p>
-          <a:p>
-            <a:pPr/>
-            <a:r>
-              <a:rPr sz="2400"/>
-              <a:t>→ この定理が本当に成り立つかが、後で問題になる</a:t>
-            </a:r>
-          </a:p>
-        </p:txBody>
-      </p:sp>
-      <p:sp>
-        <p:nvSpPr>
-          <p:cNvPr id="8" name="TextBox 7">
-            <a:extLst>
-              <a:ext uri="{FF2B5EF4-FFF2-40B4-BE49-F238E27FC236}">
-                <a16:creationId xmlns:a16="http://schemas.microsoft.com/office/drawing/2014/main" id="{F85CD606-E3CE-F314-B3EE-F3D7028115CB}"/>
-              </a:ext>
-            </a:extLst>
-          </p:cNvPr>
-          <p:cNvSpPr txBox="1"/>
-          <p:nvPr/>
-        </p:nvSpPr>
-        <p:spPr>
-          <a:xfrm>
-            <a:off x="5837182" y="5663239"/>
-            <a:ext cx="6093372" cy="923330"/>
-          </a:xfrm>
-          <a:prstGeom prst="rect">
-            <a:avLst/>
-          </a:prstGeom>
-          <a:noFill/>
-        </p:spPr>
-        <p:txBody>
-          <a:bodyPr wrap="square">
-            <a:spAutoFit/>
-          </a:bodyPr>
-          <a:lstStyle/>
-          <a:p>
-            <a:r>
-              <a:rPr lang="en-US" b="1" sz="1400"/>
-              <a:t>Reference:</a:t>
-            </a:r>
-            <a:r>
-              <a:rPr lang="en-US" sz="1400"/>
-              <a:t> S. S. Wilks (1938), Ann. Math. Stat. 9, 60</a:t>
-            </a:r>
-            <a:endParaRPr lang="en-US"/>
-          </a:p>
-        </p:txBody>
-      </p:sp>
-    </p:spTree>
-  </p:cSld>
-  <p:clrMapOvr>
-    <a:masterClrMapping/>
-  </p:clrMapOvr>
-</p:sld>
-</file>
-
-<file path=ppt/slides/slide7.xml><?xml version="1.0" encoding="utf-8"?>
-<p:sld xmlns:a="http://schemas.openxmlformats.org/drawingml/2006/main" xmlns:p="http://schemas.openxmlformats.org/presentationml/2006/main" xmlns:r="http://schemas.openxmlformats.org/officeDocument/2006/relationships">
-  <p:cSld>
-    <p:spTree>
-      <p:nvGrpSpPr>
-        <p:cNvPr id="1" name=""/>
-        <p:cNvGrpSpPr/>
-        <p:nvPr/>
-      </p:nvGrpSpPr>
-      <p:grpSpPr/>
-      <p:sp>
-        <p:nvSpPr>
-          <p:cNvPr id="2" name="Title 1"/>
-          <p:cNvSpPr>
-            <a:spLocks noGrp="1"/>
-          </p:cNvSpPr>
-          <p:nvPr>
-            <p:ph type="title"/>
-          </p:nvPr>
-        </p:nvSpPr>
-        <p:spPr/>
-        <p:txBody>
-          <a:bodyPr/>
-          <a:lstStyle/>
-          <a:p>
-            <a:r>
-              <a:rPr sz="3400"/>
-              <a:t>手法④：MCMC（誤差の見積もり）</a:t>
-            </a:r>
-          </a:p>
-        </p:txBody>
-      </p:sp>
-      <p:sp>
-        <p:nvSpPr>
-          <p:cNvPr id="3" name="Content Placeholder 2"/>
-          <p:cNvSpPr>
-            <a:spLocks noGrp="1"/>
-          </p:cNvSpPr>
-          <p:nvPr>
-            <p:ph idx="1"/>
-          </p:nvPr>
-        </p:nvSpPr>
-        <p:spPr>
-          <a:xfrm>
-            <a:off x="841248" y="1463040"/>
-            <a:ext cx="10515600" cy="4114800"/>
-          </a:xfrm>
-        </p:spPr>
-        <p:txBody>
-          <a:bodyPr/>
-          <a:lstStyle/>
-          <a:p>
-            <a:pPr/>
-            <a:r>
-              <a:rPr sz="2400"/>
-              <a:t>最尤の 1 点だけでなく、倍率 f が「どれくらいの範囲にありうるか」を知りたい</a:t>
-            </a:r>
-          </a:p>
-          <a:p>
-            <a:pPr/>
-            <a:r>
-              <a:rPr sz="2400"/>
-              <a:t>MCMC：尤度に比例する確率で、パラメータの空間を歩き回る</a:t>
-            </a:r>
-          </a:p>
-          <a:p>
-            <a:pPr lvl="1"/>
-            <a:r>
-              <a:rPr sz="2000"/>
-              <a:t>歩いた跡の分布 = パラメータの事後分布 → 誤差棒</a:t>
-            </a:r>
-          </a:p>
-          <a:p>
-            <a:pPr/>
-            <a:r>
-              <a:rPr sz="2400"/>
-              <a:t>emcee を使用：32 本の歩行者、最初の 400 歩は捨てる</a:t>
-            </a:r>
-          </a:p>
-          <a:p>
-            <a:pPr lvl="1"/>
-            <a:r>
-              <a:rPr sz="2000"/>
-              <a:t>自己相関時間の 50 倍以上の長さがあるか確認</a:t>
-            </a:r>
-          </a:p>
-          <a:p>
-            <a:pPr/>
-            <a:r>
-              <a:rPr sz="2400"/>
-              <a:t>有意度 σ は Δln L から出すので、MCMC の有無で変わらない</a:t>
-            </a:r>
-          </a:p>
-        </p:txBody>
-      </p:sp>
-      <p:sp>
-        <p:nvSpPr>
-          <p:cNvPr id="8" name="TextBox 7">
-            <a:extLst>
-              <a:ext uri="{FF2B5EF4-FFF2-40B4-BE49-F238E27FC236}">
-                <a16:creationId xmlns:a16="http://schemas.microsoft.com/office/drawing/2014/main" id="{F85CD606-E3CE-F314-B3EE-F3D7028115CB}"/>
-              </a:ext>
-            </a:extLst>
-          </p:cNvPr>
-          <p:cNvSpPr txBox="1"/>
-          <p:nvPr/>
-        </p:nvSpPr>
-        <p:spPr>
-          <a:xfrm>
-            <a:off x="5837182" y="5663239"/>
-            <a:ext cx="6093372" cy="923330"/>
-          </a:xfrm>
-          <a:prstGeom prst="rect">
-            <a:avLst/>
-          </a:prstGeom>
-          <a:noFill/>
-        </p:spPr>
-        <p:txBody>
-          <a:bodyPr wrap="square">
-            <a:spAutoFit/>
-          </a:bodyPr>
-          <a:lstStyle/>
-          <a:p>
-            <a:r>
-              <a:rPr lang="en-US" b="1" sz="1400"/>
+              <a:rPr lang="en-US" sz="1400" b="1"/>
               <a:t>Reference:</a:t>
             </a:r>
             <a:r>
@@ -10634,7 +10847,7 @@
 </file>
 
 <file path=ppt/slides/slide8.xml><?xml version="1.0" encoding="utf-8"?>
-<p:sld xmlns:a="http://schemas.openxmlformats.org/drawingml/2006/main" xmlns:p="http://schemas.openxmlformats.org/presentationml/2006/main" xmlns:r="http://schemas.openxmlformats.org/officeDocument/2006/relationships">
+<p:sld xmlns:a="http://schemas.openxmlformats.org/drawingml/2006/main" xmlns:r="http://schemas.openxmlformats.org/officeDocument/2006/relationships" xmlns:p="http://schemas.openxmlformats.org/presentationml/2006/main">
   <p:cSld>
     <p:spTree>
       <p:nvGrpSpPr>
@@ -10642,7 +10855,14 @@
         <p:cNvGrpSpPr/>
         <p:nvPr/>
       </p:nvGrpSpPr>
-      <p:grpSpPr/>
+      <p:grpSpPr>
+        <a:xfrm>
+          <a:off x="0" y="0"/>
+          <a:ext cx="0" cy="0"/>
+          <a:chOff x="0" y="0"/>
+          <a:chExt cx="0" cy="0"/>
+        </a:xfrm>
+      </p:grpSpPr>
       <p:sp>
         <p:nvSpPr>
           <p:cNvPr id="2" name="Title 1"/>
@@ -10674,7 +10894,7 @@
           <p:nvPr/>
         </p:nvPicPr>
         <p:blipFill>
-          <a:blip r:embed="rId2"/>
+          <a:blip r:embed="rId3"/>
           <a:stretch>
             <a:fillRect/>
           </a:stretch>
@@ -10747,7 +10967,7 @@
           <a:lstStyle/>
           <a:p>
             <a:r>
-              <a:rPr lang="en-US" b="1" sz="1400"/>
+              <a:rPr lang="en-US" sz="1400" b="1"/>
               <a:t>Reference:</a:t>
             </a:r>
             <a:r>
@@ -10767,7 +10987,7 @@
 </file>
 
 <file path=ppt/slides/slide9.xml><?xml version="1.0" encoding="utf-8"?>
-<p:sld xmlns:a="http://schemas.openxmlformats.org/drawingml/2006/main" xmlns:p="http://schemas.openxmlformats.org/presentationml/2006/main" xmlns:r="http://schemas.openxmlformats.org/officeDocument/2006/relationships">
+<p:sld xmlns:a="http://schemas.openxmlformats.org/drawingml/2006/main" xmlns:r="http://schemas.openxmlformats.org/officeDocument/2006/relationships" xmlns:p="http://schemas.openxmlformats.org/presentationml/2006/main">
   <p:cSld>
     <p:spTree>
       <p:nvGrpSpPr>
@@ -10775,7 +10995,14 @@
         <p:cNvGrpSpPr/>
         <p:nvPr/>
       </p:nvGrpSpPr>
-      <p:grpSpPr/>
+      <p:grpSpPr>
+        <a:xfrm>
+          <a:off x="0" y="0"/>
+          <a:ext cx="0" cy="0"/>
+          <a:chOff x="0" y="0"/>
+          <a:chExt cx="0" cy="0"/>
+        </a:xfrm>
+      </p:grpSpPr>
       <p:sp>
         <p:nvSpPr>
           <p:cNvPr id="2" name="Title 1"/>
@@ -10818,7 +11045,6 @@
           <a:bodyPr/>
           <a:lstStyle/>
           <a:p>
-            <a:pPr/>
             <a:r>
               <a:rPr sz="2200"/>
               <a:t>ICS とハローは、空の上での形がよく似ている</a:t>
@@ -10832,14 +11058,12 @@
             </a:r>
           </a:p>
           <a:p>
-            <a:pPr/>
             <a:r>
               <a:rPr sz="2200"/>
               <a:t>違いは「銀河中心の方向に集まっているか」だけ</a:t>
             </a:r>
           </a:p>
           <a:p>
-            <a:pPr/>
             <a:r>
               <a:rPr sz="2200"/>
               <a:t>ハローを入れると、その分 ICS が暗くなる</a:t>
@@ -11212,44 +11436,44 @@
         <a:sysClr val="window" lastClr="FFFFFF"/>
       </a:lt1>
       <a:dk2>
-        <a:srgbClr val="1F497D"/>
+        <a:srgbClr val="0E2841"/>
       </a:dk2>
       <a:lt2>
-        <a:srgbClr val="EEECE1"/>
+        <a:srgbClr val="E8E8E8"/>
       </a:lt2>
       <a:accent1>
-        <a:srgbClr val="4F81BD"/>
+        <a:srgbClr val="156082"/>
       </a:accent1>
       <a:accent2>
-        <a:srgbClr val="C0504D"/>
+        <a:srgbClr val="E97132"/>
       </a:accent2>
       <a:accent3>
-        <a:srgbClr val="9BBB59"/>
+        <a:srgbClr val="196B24"/>
       </a:accent3>
       <a:accent4>
-        <a:srgbClr val="8064A2"/>
+        <a:srgbClr val="0F9ED5"/>
       </a:accent4>
       <a:accent5>
-        <a:srgbClr val="4BACC6"/>
+        <a:srgbClr val="A02B93"/>
       </a:accent5>
       <a:accent6>
-        <a:srgbClr val="F79646"/>
+        <a:srgbClr val="4EA72E"/>
       </a:accent6>
       <a:hlink>
-        <a:srgbClr val="0000FF"/>
+        <a:srgbClr val="467886"/>
       </a:hlink>
       <a:folHlink>
-        <a:srgbClr val="800080"/>
+        <a:srgbClr val="96607D"/>
       </a:folHlink>
     </a:clrScheme>
     <a:fontScheme name="Office">
       <a:majorFont>
-        <a:latin typeface="Calibri"/>
+        <a:latin typeface="Aptos Display" panose="02110004020202020204"/>
         <a:ea typeface=""/>
         <a:cs typeface=""/>
-        <a:font script="Jpan" typeface="ＭＳ Ｐゴシック"/>
+        <a:font script="Jpan" typeface="游ゴシック Light"/>
         <a:font script="Hang" typeface="맑은 고딕"/>
-        <a:font script="Hans" typeface="宋体"/>
+        <a:font script="Hans" typeface="等线 Light"/>
         <a:font script="Hant" typeface="新細明體"/>
         <a:font script="Arab" typeface="Times New Roman"/>
         <a:font script="Hebr" typeface="Times New Roman"/>
@@ -11277,14 +11501,31 @@
         <a:font script="Viet" typeface="Times New Roman"/>
         <a:font script="Uigh" typeface="Microsoft Uighur"/>
         <a:font script="Geor" typeface="Sylfaen"/>
+        <a:font script="Armn" typeface="Arial"/>
+        <a:font script="Bugi" typeface="Leelawadee UI"/>
+        <a:font script="Bopo" typeface="Microsoft JhengHei"/>
+        <a:font script="Java" typeface="Javanese Text"/>
+        <a:font script="Lisu" typeface="Segoe UI"/>
+        <a:font script="Mymr" typeface="Myanmar Text"/>
+        <a:font script="Nkoo" typeface="Ebrima"/>
+        <a:font script="Olck" typeface="Nirmala UI"/>
+        <a:font script="Osma" typeface="Ebrima"/>
+        <a:font script="Phag" typeface="Phagspa"/>
+        <a:font script="Syrn" typeface="Estrangelo Edessa"/>
+        <a:font script="Syrj" typeface="Estrangelo Edessa"/>
+        <a:font script="Syre" typeface="Estrangelo Edessa"/>
+        <a:font script="Sora" typeface="Nirmala UI"/>
+        <a:font script="Tale" typeface="Microsoft Tai Le"/>
+        <a:font script="Talu" typeface="Microsoft New Tai Lue"/>
+        <a:font script="Tfng" typeface="Ebrima"/>
       </a:majorFont>
       <a:minorFont>
-        <a:latin typeface="Calibri"/>
+        <a:latin typeface="Aptos" panose="02110004020202020204"/>
         <a:ea typeface=""/>
         <a:cs typeface=""/>
-        <a:font script="Jpan" typeface="ＭＳ Ｐゴシック"/>
+        <a:font script="Jpan" typeface="游ゴシック"/>
         <a:font script="Hang" typeface="맑은 고딕"/>
-        <a:font script="Hans" typeface="宋体"/>
+        <a:font script="Hans" typeface="等线"/>
         <a:font script="Hant" typeface="新細明體"/>
         <a:font script="Arab" typeface="Arial"/>
         <a:font script="Hebr" typeface="Arial"/>
@@ -11312,6 +11553,23 @@
         <a:font script="Viet" typeface="Arial"/>
         <a:font script="Uigh" typeface="Microsoft Uighur"/>
         <a:font script="Geor" typeface="Sylfaen"/>
+        <a:font script="Armn" typeface="Arial"/>
+        <a:font script="Bugi" typeface="Leelawadee UI"/>
+        <a:font script="Bopo" typeface="Microsoft JhengHei"/>
+        <a:font script="Java" typeface="Javanese Text"/>
+        <a:font script="Lisu" typeface="Segoe UI"/>
+        <a:font script="Mymr" typeface="Myanmar Text"/>
+        <a:font script="Nkoo" typeface="Ebrima"/>
+        <a:font script="Olck" typeface="Nirmala UI"/>
+        <a:font script="Osma" typeface="Ebrima"/>
+        <a:font script="Phag" typeface="Phagspa"/>
+        <a:font script="Syrn" typeface="Estrangelo Edessa"/>
+        <a:font script="Syrj" typeface="Estrangelo Edessa"/>
+        <a:font script="Syre" typeface="Estrangelo Edessa"/>
+        <a:font script="Sora" typeface="Nirmala UI"/>
+        <a:font script="Tale" typeface="Microsoft Tai Le"/>
+        <a:font script="Talu" typeface="Microsoft New Tai Lue"/>
+        <a:font script="Tfng" typeface="Ebrima"/>
       </a:minorFont>
     </a:fontScheme>
     <a:fmtScheme name="Office">
@@ -11323,180 +11581,136 @@
           <a:gsLst>
             <a:gs pos="0">
               <a:schemeClr val="phClr">
-                <a:tint val="50000"/>
-                <a:satMod val="300000"/>
+                <a:lumMod val="110000"/>
+                <a:satMod val="105000"/>
+                <a:tint val="67000"/>
               </a:schemeClr>
             </a:gs>
-            <a:gs pos="35000">
+            <a:gs pos="50000">
               <a:schemeClr val="phClr">
-                <a:tint val="37000"/>
-                <a:satMod val="300000"/>
+                <a:lumMod val="105000"/>
+                <a:satMod val="103000"/>
+                <a:tint val="73000"/>
               </a:schemeClr>
             </a:gs>
             <a:gs pos="100000">
               <a:schemeClr val="phClr">
-                <a:tint val="15000"/>
-                <a:satMod val="350000"/>
+                <a:lumMod val="105000"/>
+                <a:satMod val="109000"/>
+                <a:tint val="81000"/>
               </a:schemeClr>
             </a:gs>
           </a:gsLst>
-          <a:lin ang="16200000" scaled="1"/>
+          <a:lin ang="5400000" scaled="0"/>
         </a:gradFill>
         <a:gradFill rotWithShape="1">
           <a:gsLst>
             <a:gs pos="0">
               <a:schemeClr val="phClr">
-                <a:tint val="100000"/>
+                <a:satMod val="103000"/>
+                <a:lumMod val="102000"/>
+                <a:tint val="94000"/>
+              </a:schemeClr>
+            </a:gs>
+            <a:gs pos="50000">
+              <a:schemeClr val="phClr">
+                <a:satMod val="110000"/>
+                <a:lumMod val="100000"/>
                 <a:shade val="100000"/>
-                <a:satMod val="130000"/>
               </a:schemeClr>
             </a:gs>
             <a:gs pos="100000">
               <a:schemeClr val="phClr">
-                <a:tint val="50000"/>
-                <a:shade val="100000"/>
-                <a:satMod val="350000"/>
+                <a:lumMod val="99000"/>
+                <a:satMod val="120000"/>
+                <a:shade val="78000"/>
               </a:schemeClr>
             </a:gs>
           </a:gsLst>
-          <a:lin ang="16200000" scaled="0"/>
+          <a:lin ang="5400000" scaled="0"/>
         </a:gradFill>
       </a:fillStyleLst>
       <a:lnStyleLst>
-        <a:ln w="9525" cap="flat" cmpd="sng" algn="ctr">
+        <a:ln w="12700" cap="flat" cmpd="sng" algn="ctr">
           <a:solidFill>
-            <a:schemeClr val="phClr">
-              <a:shade val="95000"/>
-              <a:satMod val="105000"/>
-            </a:schemeClr>
+            <a:schemeClr val="phClr"/>
           </a:solidFill>
           <a:prstDash val="solid"/>
+          <a:miter lim="800000"/>
+        </a:ln>
+        <a:ln w="19050" cap="flat" cmpd="sng" algn="ctr">
+          <a:solidFill>
+            <a:schemeClr val="phClr"/>
+          </a:solidFill>
+          <a:prstDash val="solid"/>
+          <a:miter lim="800000"/>
         </a:ln>
         <a:ln w="25400" cap="flat" cmpd="sng" algn="ctr">
           <a:solidFill>
             <a:schemeClr val="phClr"/>
           </a:solidFill>
           <a:prstDash val="solid"/>
-        </a:ln>
-        <a:ln w="38100" cap="flat" cmpd="sng" algn="ctr">
-          <a:solidFill>
-            <a:schemeClr val="phClr"/>
-          </a:solidFill>
-          <a:prstDash val="solid"/>
+          <a:miter lim="800000"/>
         </a:ln>
       </a:lnStyleLst>
       <a:effectStyleLst>
         <a:effectStyle>
+          <a:effectLst/>
+        </a:effectStyle>
+        <a:effectStyle>
+          <a:effectLst/>
+        </a:effectStyle>
+        <a:effectStyle>
           <a:effectLst>
-            <a:outerShdw blurRad="40000" dist="20000" dir="5400000" rotWithShape="0">
+            <a:outerShdw blurRad="57150" dist="19050" dir="5400000" algn="ctr" rotWithShape="0">
               <a:srgbClr val="000000">
-                <a:alpha val="38000"/>
+                <a:alpha val="63000"/>
               </a:srgbClr>
             </a:outerShdw>
           </a:effectLst>
-        </a:effectStyle>
-        <a:effectStyle>
-          <a:effectLst>
-            <a:outerShdw blurRad="40000" dist="23000" dir="5400000" rotWithShape="0">
-              <a:srgbClr val="000000">
-                <a:alpha val="35000"/>
-              </a:srgbClr>
-            </a:outerShdw>
-          </a:effectLst>
-        </a:effectStyle>
-        <a:effectStyle>
-          <a:effectLst>
-            <a:outerShdw blurRad="40000" dist="23000" dir="5400000" rotWithShape="0">
-              <a:srgbClr val="000000">
-                <a:alpha val="35000"/>
-              </a:srgbClr>
-            </a:outerShdw>
-          </a:effectLst>
-          <a:scene3d>
-            <a:camera prst="orthographicFront">
-              <a:rot lat="0" lon="0" rev="0"/>
-            </a:camera>
-            <a:lightRig rig="threePt" dir="t">
-              <a:rot lat="0" lon="0" rev="1200000"/>
-            </a:lightRig>
-          </a:scene3d>
-          <a:sp3d>
-            <a:bevelT w="63500" h="25400"/>
-          </a:sp3d>
         </a:effectStyle>
       </a:effectStyleLst>
       <a:bgFillStyleLst>
         <a:solidFill>
           <a:schemeClr val="phClr"/>
         </a:solidFill>
+        <a:solidFill>
+          <a:schemeClr val="phClr">
+            <a:tint val="95000"/>
+            <a:satMod val="170000"/>
+          </a:schemeClr>
+        </a:solidFill>
         <a:gradFill rotWithShape="1">
           <a:gsLst>
             <a:gs pos="0">
               <a:schemeClr val="phClr">
-                <a:tint val="40000"/>
-                <a:satMod val="350000"/>
+                <a:tint val="93000"/>
+                <a:satMod val="150000"/>
+                <a:shade val="98000"/>
+                <a:lumMod val="102000"/>
               </a:schemeClr>
             </a:gs>
-            <a:gs pos="40000">
+            <a:gs pos="50000">
               <a:schemeClr val="phClr">
-                <a:tint val="45000"/>
-                <a:shade val="99000"/>
-                <a:satMod val="350000"/>
+                <a:tint val="98000"/>
+                <a:satMod val="130000"/>
+                <a:shade val="90000"/>
+                <a:lumMod val="103000"/>
               </a:schemeClr>
             </a:gs>
             <a:gs pos="100000">
               <a:schemeClr val="phClr">
-                <a:shade val="20000"/>
-                <a:satMod val="255000"/>
+                <a:shade val="63000"/>
+                <a:satMod val="120000"/>
               </a:schemeClr>
             </a:gs>
           </a:gsLst>
-          <a:path path="circle">
-            <a:fillToRect l="50000" t="-80000" r="50000" b="180000"/>
-          </a:path>
-        </a:gradFill>
-        <a:gradFill rotWithShape="1">
-          <a:gsLst>
-            <a:gs pos="0">
-              <a:schemeClr val="phClr">
-                <a:tint val="80000"/>
-                <a:satMod val="300000"/>
-              </a:schemeClr>
-            </a:gs>
-            <a:gs pos="100000">
-              <a:schemeClr val="phClr">
-                <a:shade val="30000"/>
-                <a:satMod val="200000"/>
-              </a:schemeClr>
-            </a:gs>
-          </a:gsLst>
-          <a:path path="circle">
-            <a:fillToRect l="50000" t="50000" r="50000" b="50000"/>
-          </a:path>
+          <a:lin ang="5400000" scaled="0"/>
         </a:gradFill>
       </a:bgFillStyleLst>
     </a:fmtScheme>
   </a:themeElements>
   <a:objectDefaults>
-    <a:spDef>
-      <a:spPr/>
-      <a:bodyPr/>
-      <a:lstStyle/>
-      <a:style>
-        <a:lnRef idx="1">
-          <a:schemeClr val="accent1"/>
-        </a:lnRef>
-        <a:fillRef idx="3">
-          <a:schemeClr val="accent1"/>
-        </a:fillRef>
-        <a:effectRef idx="2">
-          <a:schemeClr val="accent1"/>
-        </a:effectRef>
-        <a:fontRef idx="minor">
-          <a:schemeClr val="lt1"/>
-        </a:fontRef>
-      </a:style>
-    </a:spDef>
     <a:lnDef>
       <a:spPr/>
       <a:bodyPr/>
@@ -11518,5 +11732,10 @@
     </a:lnDef>
   </a:objectDefaults>
   <a:extraClrSchemeLst/>
+  <a:extLst>
+    <a:ext uri="{05A4C25C-085E-4340-85A3-A5531E510DB2}">
+      <thm15:themeFamily xmlns:thm15="http://schemas.microsoft.com/office/thememl/2012/main" name="Office Theme" id="{2E142A2C-CD16-42D6-873A-C26D2A0506FA}" vid="{1BDDFF52-6CD6-40A5-AB3C-68EB2F1E4D0A}"/>
+    </a:ext>
+  </a:extLst>
 </a:theme>
 </file>
</xml_diff>

<commit_message>
slides: 本人の編集版を更新 (10-02 10:26)
</commit_message>
<xml_diff>
--- a/slides/2026-10-02_研究進捗報告.pptx
+++ b/slides/2026-10-02_研究進捗報告.pptx
@@ -158,6 +158,58 @@
     </p:ext>
   </p:extLst>
 </p:presentation>
+</file>
+
+<file path=ppt/revisionInfo.xml><?xml version="1.0" encoding="utf-8"?>
+<p1510:revInfo xmlns:a="http://schemas.openxmlformats.org/drawingml/2006/main" xmlns:r="http://schemas.openxmlformats.org/officeDocument/2006/relationships" xmlns:p1510="http://schemas.microsoft.com/office/powerpoint/2015/10/main">
+  <p1510:revLst>
+    <p1510:client id="{0C18A6C4-2C47-4DAD-A1DF-DD0206B853E7}" v="2" dt="2026-10-02T01:15:06.370"/>
+  </p1510:revLst>
+</p1510:revInfo>
+</file>
+
+<file path=ppt/changesInfos/changesInfo1.xml><?xml version="1.0" encoding="utf-8"?>
+<pc:chgInfo xmlns:a="http://schemas.openxmlformats.org/drawingml/2006/main" xmlns:r="http://schemas.openxmlformats.org/officeDocument/2006/relationships" xmlns:ac="http://schemas.microsoft.com/office/drawing/2013/main/command" xmlns:pc="http://schemas.microsoft.com/office/powerpoint/2013/main/command">
+  <pc:docChgLst>
+    <pc:chgData name="202304239" userId="ab1adf7a-b8eb-4038-b404-de23e20d8a3a" providerId="ADAL" clId="{6C0E59ED-D716-49AF-B2FA-B94E7B8E5A8C}"/>
+    <pc:docChg chg="modSld">
+      <pc:chgData name="202304239" userId="ab1adf7a-b8eb-4038-b404-de23e20d8a3a" providerId="ADAL" clId="{6C0E59ED-D716-49AF-B2FA-B94E7B8E5A8C}" dt="2026-10-02T01:15:41.310" v="14" actId="1076"/>
+      <pc:docMkLst>
+        <pc:docMk/>
+      </pc:docMkLst>
+      <pc:sldChg chg="modSp mod">
+        <pc:chgData name="202304239" userId="ab1adf7a-b8eb-4038-b404-de23e20d8a3a" providerId="ADAL" clId="{6C0E59ED-D716-49AF-B2FA-B94E7B8E5A8C}" dt="2026-10-02T01:15:41.310" v="14" actId="1076"/>
+        <pc:sldMkLst>
+          <pc:docMk/>
+          <pc:sldMk cId="0" sldId="258"/>
+        </pc:sldMkLst>
+        <pc:spChg chg="mod">
+          <ac:chgData name="202304239" userId="ab1adf7a-b8eb-4038-b404-de23e20d8a3a" providerId="ADAL" clId="{6C0E59ED-D716-49AF-B2FA-B94E7B8E5A8C}" dt="2026-10-02T01:15:41.310" v="14" actId="1076"/>
+          <ac:spMkLst>
+            <pc:docMk/>
+            <pc:sldMk cId="0" sldId="258"/>
+            <ac:spMk id="7" creationId="{0C0F810D-B137-252F-B137-69AD8335E4B7}"/>
+          </ac:spMkLst>
+        </pc:spChg>
+      </pc:sldChg>
+      <pc:sldChg chg="modSp">
+        <pc:chgData name="202304239" userId="ab1adf7a-b8eb-4038-b404-de23e20d8a3a" providerId="ADAL" clId="{6C0E59ED-D716-49AF-B2FA-B94E7B8E5A8C}" dt="2026-10-02T01:13:59.581" v="0"/>
+        <pc:sldMkLst>
+          <pc:docMk/>
+          <pc:sldMk cId="0" sldId="259"/>
+        </pc:sldMkLst>
+        <pc:spChg chg="mod">
+          <ac:chgData name="202304239" userId="ab1adf7a-b8eb-4038-b404-de23e20d8a3a" providerId="ADAL" clId="{6C0E59ED-D716-49AF-B2FA-B94E7B8E5A8C}" dt="2026-10-02T01:13:59.581" v="0"/>
+          <ac:spMkLst>
+            <pc:docMk/>
+            <pc:sldMk cId="0" sldId="259"/>
+            <ac:spMk id="3" creationId="{00000000-0000-0000-0000-000000000000}"/>
+          </ac:spMkLst>
+        </pc:spChg>
+      </pc:sldChg>
+    </pc:docChg>
+  </pc:docChgLst>
+</pc:chgInfo>
 </file>
 
 <file path=ppt/notesMasters/notesMaster1.xml><?xml version="1.0" encoding="utf-8"?>
@@ -9559,8 +9611,8 @@
         </p:nvSpPr>
         <p:spPr>
           <a:xfrm>
-            <a:off x="9995606" y="4690094"/>
-            <a:ext cx="1753564" cy="707886"/>
+            <a:off x="9496448" y="4625926"/>
+            <a:ext cx="2630772" cy="954107"/>
           </a:xfrm>
           <a:prstGeom prst="rect">
             <a:avLst/>
@@ -9574,13 +9626,24 @@
           <a:lstStyle/>
           <a:p>
             <a:r>
-              <a:rPr lang="ja-JP" altLang="en-US" sz="4000"/>
+              <a:rPr lang="ja-JP" altLang="en-US" sz="2800"/>
               <a:t>６</a:t>
             </a:r>
             <a:r>
-              <a:rPr lang="en-US" altLang="ja-JP" sz="4000"/>
+              <a:rPr lang="en-US" altLang="ja-JP" sz="2800"/>
               <a:t>bin</a:t>
             </a:r>
+            <a:r>
+              <a:rPr lang="en-US" sz="2800"/>
+              <a:t> </a:t>
+            </a:r>
+          </a:p>
+          <a:p>
+            <a:r>
+              <a:rPr lang="en-US" sz="2800"/>
+              <a:t>（20.8 GeV）</a:t>
+            </a:r>
+            <a:endParaRPr lang="en-US" altLang="ja-JP" sz="2800"/>
           </a:p>
         </p:txBody>
       </p:sp>
@@ -10392,7 +10455,23 @@
             </a:r>
             <a:r>
               <a:rPr lang="en-US" sz="2000"/>
-              <a:t>、ICS、</a:t>
+              <a:t>、ICS</a:t>
+            </a:r>
+            <a:r>
+              <a:rPr lang="en-US" sz="1800"/>
+              <a:t> (</a:t>
+            </a:r>
+            <a:r>
+              <a:rPr lang="en-US" sz="2000"/>
+              <a:t>GALPROP)</a:t>
+            </a:r>
+            <a:r>
+              <a:rPr lang="en-US" sz="1800"/>
+              <a:t>、 </a:t>
+            </a:r>
+            <a:r>
+              <a:rPr lang="en-US" sz="2000"/>
+              <a:t>、</a:t>
             </a:r>
             <a:r>
               <a:rPr lang="ja-JP" altLang="en-US" sz="2000"/>

</xml_diff>

<commit_message>
slides: 本人の編集版を更新 (10-02 10:42)
</commit_message>
<xml_diff>
--- a/slides/2026-10-02_研究進捗報告.pptx
+++ b/slides/2026-10-02_研究進捗報告.pptx
@@ -173,10 +173,25 @@
   <pc:docChgLst>
     <pc:chgData name="202304239" userId="ab1adf7a-b8eb-4038-b404-de23e20d8a3a" providerId="ADAL" clId="{6C0E59ED-D716-49AF-B2FA-B94E7B8E5A8C}"/>
     <pc:docChg chg="modSld">
-      <pc:chgData name="202304239" userId="ab1adf7a-b8eb-4038-b404-de23e20d8a3a" providerId="ADAL" clId="{6C0E59ED-D716-49AF-B2FA-B94E7B8E5A8C}" dt="2026-10-02T01:15:41.310" v="14" actId="1076"/>
+      <pc:chgData name="202304239" userId="ab1adf7a-b8eb-4038-b404-de23e20d8a3a" providerId="ADAL" clId="{6C0E59ED-D716-49AF-B2FA-B94E7B8E5A8C}" dt="2026-10-02T01:41:32.636" v="29" actId="20577"/>
       <pc:docMkLst>
         <pc:docMk/>
       </pc:docMkLst>
+      <pc:sldChg chg="modSp mod">
+        <pc:chgData name="202304239" userId="ab1adf7a-b8eb-4038-b404-de23e20d8a3a" providerId="ADAL" clId="{6C0E59ED-D716-49AF-B2FA-B94E7B8E5A8C}" dt="2026-10-02T01:41:32.636" v="29" actId="20577"/>
+        <pc:sldMkLst>
+          <pc:docMk/>
+          <pc:sldMk cId="0" sldId="257"/>
+        </pc:sldMkLst>
+        <pc:spChg chg="mod">
+          <ac:chgData name="202304239" userId="ab1adf7a-b8eb-4038-b404-de23e20d8a3a" providerId="ADAL" clId="{6C0E59ED-D716-49AF-B2FA-B94E7B8E5A8C}" dt="2026-10-02T01:41:32.636" v="29" actId="20577"/>
+          <ac:spMkLst>
+            <pc:docMk/>
+            <pc:sldMk cId="0" sldId="257"/>
+            <ac:spMk id="3" creationId="{00000000-0000-0000-0000-000000000000}"/>
+          </ac:spMkLst>
+        </pc:spChg>
+      </pc:sldChg>
       <pc:sldChg chg="modSp mod">
         <pc:chgData name="202304239" userId="ab1adf7a-b8eb-4038-b404-de23e20d8a3a" providerId="ADAL" clId="{6C0E59ED-D716-49AF-B2FA-B94E7B8E5A8C}" dt="2026-10-02T01:15:41.310" v="14" actId="1076"/>
         <pc:sldMkLst>
@@ -7942,16 +7957,12 @@
           </a:p>
           <a:p>
             <a:r>
-              <a:rPr sz="2400" b="1"/>
-              <a:t>研究</a:t>
-            </a:r>
-            <a:r>
               <a:rPr lang="ja-JP" altLang="en-US" sz="2400" b="1"/>
               <a:t>卒業</a:t>
             </a:r>
             <a:r>
               <a:rPr sz="2400" b="1"/>
-              <a:t>：これを自分で再現し、本物かどうか確かめる</a:t>
+              <a:t>研究：これを自分で再現し、本物かどうか確かめる</a:t>
             </a:r>
             <a:endParaRPr lang="en-US" sz="2400" b="1"/>
           </a:p>

</xml_diff>